<commit_message>
Add kernel installation instructions
</commit_message>
<xml_diff>
--- a/julia_good_back_ugly.pptx
+++ b/julia_good_back_ugly.pptx
@@ -336,7 +336,7 @@
           <a:p>
             <a:fld id="{CC9F3EF1-84A5-42B0-81FF-8805AF740E8D}" type="datetimeFigureOut">
               <a:rPr lang="en-US" smtClean="0"/>
-              <a:t>2025-03-28</a:t>
+              <a:t>2025-10-27</a:t>
             </a:fld>
             <a:endParaRPr lang="en-US"/>
           </a:p>
@@ -750,7 +750,7 @@
           <a:p>
             <a:fld id="{0D45F18C-3E18-466F-8ADF-516304A44708}" type="datetime1">
               <a:rPr lang="en-US" smtClean="0"/>
-              <a:t>2025-03-28</a:t>
+              <a:t>2025-10-27</a:t>
             </a:fld>
             <a:endParaRPr lang="en-US"/>
           </a:p>
@@ -948,7 +948,7 @@
           <a:p>
             <a:fld id="{D5980222-6813-4CA6-84DC-753D8B88D809}" type="datetime1">
               <a:rPr lang="en-US" smtClean="0"/>
-              <a:t>2025-03-28</a:t>
+              <a:t>2025-10-27</a:t>
             </a:fld>
             <a:endParaRPr lang="en-US"/>
           </a:p>
@@ -1156,7 +1156,7 @@
           <a:p>
             <a:fld id="{96F7B8FF-A661-4CB7-BF06-F03D9C89262B}" type="datetime1">
               <a:rPr lang="en-US" smtClean="0"/>
-              <a:t>2025-03-28</a:t>
+              <a:t>2025-10-27</a:t>
             </a:fld>
             <a:endParaRPr lang="en-US"/>
           </a:p>
@@ -1354,7 +1354,7 @@
           <a:p>
             <a:fld id="{CE4E165D-6495-4D37-B27D-5DB6761319B2}" type="datetime1">
               <a:rPr lang="en-US" smtClean="0"/>
-              <a:t>2025-03-28</a:t>
+              <a:t>2025-10-27</a:t>
             </a:fld>
             <a:endParaRPr lang="en-US"/>
           </a:p>
@@ -1629,7 +1629,7 @@
           <a:p>
             <a:fld id="{579D02C7-69E9-4C82-8F80-CB6196DA722C}" type="datetime1">
               <a:rPr lang="en-US" smtClean="0"/>
-              <a:t>2025-03-28</a:t>
+              <a:t>2025-10-27</a:t>
             </a:fld>
             <a:endParaRPr lang="en-US"/>
           </a:p>
@@ -1894,7 +1894,7 @@
           <a:p>
             <a:fld id="{107E8C2C-E058-49BD-9DFF-244106208F3B}" type="datetime1">
               <a:rPr lang="en-US" smtClean="0"/>
-              <a:t>2025-03-28</a:t>
+              <a:t>2025-10-27</a:t>
             </a:fld>
             <a:endParaRPr lang="en-US"/>
           </a:p>
@@ -2306,7 +2306,7 @@
           <a:p>
             <a:fld id="{EBBE2EFD-4DA5-4354-BB09-551207F90777}" type="datetime1">
               <a:rPr lang="en-US" smtClean="0"/>
-              <a:t>2025-03-28</a:t>
+              <a:t>2025-10-27</a:t>
             </a:fld>
             <a:endParaRPr lang="en-US"/>
           </a:p>
@@ -2447,7 +2447,7 @@
           <a:p>
             <a:fld id="{0357F3B6-5D5B-4F6A-8ABC-6500847F3284}" type="datetime1">
               <a:rPr lang="en-US" smtClean="0"/>
-              <a:t>2025-03-28</a:t>
+              <a:t>2025-10-27</a:t>
             </a:fld>
             <a:endParaRPr lang="en-US"/>
           </a:p>
@@ -2560,7 +2560,7 @@
           <a:p>
             <a:fld id="{470EE9C1-5D95-4DE1-8B8E-CE731554AA23}" type="datetime1">
               <a:rPr lang="en-US" smtClean="0"/>
-              <a:t>2025-03-28</a:t>
+              <a:t>2025-10-27</a:t>
             </a:fld>
             <a:endParaRPr lang="en-US"/>
           </a:p>
@@ -2871,7 +2871,7 @@
           <a:p>
             <a:fld id="{ED4A0E8D-A460-4018-89F2-1FF6F9205C86}" type="datetime1">
               <a:rPr lang="en-US" smtClean="0"/>
-              <a:t>2025-03-28</a:t>
+              <a:t>2025-10-27</a:t>
             </a:fld>
             <a:endParaRPr lang="en-US"/>
           </a:p>
@@ -3159,7 +3159,7 @@
           <a:p>
             <a:fld id="{74076E25-3B53-45C6-AE55-8E3CC5E53EDE}" type="datetime1">
               <a:rPr lang="en-US" smtClean="0"/>
-              <a:t>2025-03-28</a:t>
+              <a:t>2025-10-27</a:t>
             </a:fld>
             <a:endParaRPr lang="en-US"/>
           </a:p>
@@ -3400,7 +3400,7 @@
           <a:p>
             <a:fld id="{3B0E2389-F93F-49F3-A6AD-79A456A600D1}" type="datetime1">
               <a:rPr lang="en-US" smtClean="0"/>
-              <a:t>2025-03-28</a:t>
+              <a:t>2025-10-27</a:t>
             </a:fld>
             <a:endParaRPr lang="en-US"/>
           </a:p>
@@ -33083,12 +33083,8 @@
           </a:p>
           <a:p>
             <a:r>
-              <a:rPr lang="en-US" dirty="0" err="1"/>
-              <a:t>Jupyter</a:t>
-            </a:r>
-            <a:r>
               <a:rPr lang="en-US" dirty="0"/>
-              <a:t> Notebook</a:t>
+              <a:t>Run script</a:t>
             </a:r>
           </a:p>
         </p:txBody>
@@ -33124,18 +33120,37 @@
             </a:r>
           </a:p>
           <a:p>
+            <a:pPr lvl="1"/>
+            <a:r>
+              <a:rPr lang="en-US" dirty="0"/>
+              <a:t>First time</a:t>
+            </a:r>
+          </a:p>
+          <a:p>
+            <a:pPr lvl="1"/>
             <a:endParaRPr lang="en-US" dirty="0"/>
           </a:p>
           <a:p>
+            <a:pPr lvl="1"/>
             <a:endParaRPr lang="en-US" dirty="0"/>
           </a:p>
           <a:p>
+            <a:pPr lvl="1"/>
             <a:endParaRPr lang="en-US" dirty="0"/>
           </a:p>
           <a:p>
+            <a:pPr lvl="1"/>
+            <a:endParaRPr lang="en-US" dirty="0"/>
+          </a:p>
+          <a:p>
+            <a:pPr lvl="1"/>
+            <a:endParaRPr lang="en-US" dirty="0"/>
+          </a:p>
+          <a:p>
+            <a:pPr lvl="1"/>
             <a:r>
               <a:rPr lang="en-US" dirty="0"/>
-              <a:t>Run script</a:t>
+              <a:t>Afterwards</a:t>
             </a:r>
           </a:p>
         </p:txBody>
@@ -33183,7 +33198,7 @@
         </p:nvSpPr>
         <p:spPr>
           <a:xfrm>
-            <a:off x="596930" y="2308404"/>
+            <a:off x="1038890" y="2308404"/>
             <a:ext cx="4823888" cy="2462213"/>
           </a:xfrm>
           <a:prstGeom prst="rect">
@@ -33330,10 +33345,10 @@
       </p:sp>
       <p:sp>
         <p:nvSpPr>
-          <p:cNvPr id="6" name="TextBox 5">
+          <p:cNvPr id="9" name="TextBox 8">
             <a:extLst>
               <a:ext uri="{FF2B5EF4-FFF2-40B4-BE49-F238E27FC236}">
-                <a16:creationId xmlns:a16="http://schemas.microsoft.com/office/drawing/2014/main" id="{79588A93-E698-981D-64D9-4DDD1892F4B5}"/>
+                <a16:creationId xmlns:a16="http://schemas.microsoft.com/office/drawing/2014/main" id="{9281971C-AB02-B537-7F9F-C3D789C3072C}"/>
               </a:ext>
             </a:extLst>
           </p:cNvPr>
@@ -33342,7 +33357,256 @@
         </p:nvSpPr>
         <p:spPr>
           <a:xfrm>
-            <a:off x="596931" y="5320903"/>
+            <a:off x="1038890" y="5404072"/>
+            <a:ext cx="4823888" cy="369332"/>
+          </a:xfrm>
+          <a:prstGeom prst="rect">
+            <a:avLst/>
+          </a:prstGeom>
+          <a:solidFill>
+            <a:schemeClr val="tx1"/>
+          </a:solidFill>
+        </p:spPr>
+        <p:txBody>
+          <a:bodyPr wrap="square" rtlCol="0">
+            <a:spAutoFit/>
+          </a:bodyPr>
+          <a:lstStyle/>
+          <a:p>
+            <a:r>
+              <a:rPr lang="en-US" b="1" dirty="0">
+                <a:solidFill>
+                  <a:schemeClr val="bg1"/>
+                </a:solidFill>
+              </a:rPr>
+              <a:t>$ </a:t>
+            </a:r>
+            <a:r>
+              <a:rPr lang="en-US" b="1" dirty="0" err="1">
+                <a:solidFill>
+                  <a:schemeClr val="bg1"/>
+                </a:solidFill>
+              </a:rPr>
+              <a:t>julia</a:t>
+            </a:r>
+            <a:r>
+              <a:rPr lang="en-US" b="1" dirty="0">
+                <a:solidFill>
+                  <a:schemeClr val="bg1"/>
+                </a:solidFill>
+              </a:rPr>
+              <a:t>  </a:t>
+            </a:r>
+            <a:r>
+              <a:rPr lang="en-US" b="1" dirty="0" err="1">
+                <a:solidFill>
+                  <a:schemeClr val="bg1"/>
+                </a:solidFill>
+              </a:rPr>
+              <a:t>my_script.jl</a:t>
+            </a:r>
+            <a:endParaRPr lang="en-US" b="1" dirty="0">
+              <a:solidFill>
+                <a:schemeClr val="bg1"/>
+              </a:solidFill>
+            </a:endParaRPr>
+          </a:p>
+        </p:txBody>
+      </p:sp>
+      <p:sp>
+        <p:nvSpPr>
+          <p:cNvPr id="10" name="TextBox 9">
+            <a:extLst>
+              <a:ext uri="{FF2B5EF4-FFF2-40B4-BE49-F238E27FC236}">
+                <a16:creationId xmlns:a16="http://schemas.microsoft.com/office/drawing/2014/main" id="{AECB3277-94F0-9152-3529-ECD9C73028BC}"/>
+              </a:ext>
+            </a:extLst>
+          </p:cNvPr>
+          <p:cNvSpPr txBox="1"/>
+          <p:nvPr/>
+        </p:nvSpPr>
+        <p:spPr>
+          <a:xfrm>
+            <a:off x="6430852" y="2688122"/>
+            <a:ext cx="4823888" cy="1477328"/>
+          </a:xfrm>
+          <a:prstGeom prst="rect">
+            <a:avLst/>
+          </a:prstGeom>
+          <a:solidFill>
+            <a:schemeClr val="tx1"/>
+          </a:solidFill>
+        </p:spPr>
+        <p:txBody>
+          <a:bodyPr wrap="square" rtlCol="0">
+            <a:spAutoFit/>
+          </a:bodyPr>
+          <a:lstStyle/>
+          <a:p>
+            <a:r>
+              <a:rPr lang="en-US" b="1" dirty="0">
+                <a:solidFill>
+                  <a:schemeClr val="bg1"/>
+                </a:solidFill>
+              </a:rPr>
+              <a:t>$ </a:t>
+            </a:r>
+            <a:r>
+              <a:rPr lang="en-US" b="1" dirty="0" err="1">
+                <a:solidFill>
+                  <a:schemeClr val="bg1"/>
+                </a:solidFill>
+              </a:rPr>
+              <a:t>julia</a:t>
+            </a:r>
+            <a:endParaRPr lang="en-US" b="1" dirty="0">
+              <a:solidFill>
+                <a:schemeClr val="bg1"/>
+              </a:solidFill>
+            </a:endParaRPr>
+          </a:p>
+          <a:p>
+            <a:r>
+              <a:rPr lang="en-US" b="1" dirty="0">
+                <a:solidFill>
+                  <a:schemeClr val="bg1"/>
+                </a:solidFill>
+              </a:rPr>
+              <a:t>…</a:t>
+            </a:r>
+          </a:p>
+          <a:p>
+            <a:r>
+              <a:rPr lang="en-US" b="1" dirty="0" err="1">
+                <a:solidFill>
+                  <a:schemeClr val="bg1"/>
+                </a:solidFill>
+              </a:rPr>
+              <a:t>julia</a:t>
+            </a:r>
+            <a:r>
+              <a:rPr lang="en-US" b="1" dirty="0">
+                <a:solidFill>
+                  <a:schemeClr val="bg1"/>
+                </a:solidFill>
+              </a:rPr>
+              <a:t>&gt; using </a:t>
+            </a:r>
+            <a:r>
+              <a:rPr lang="en-US" b="1" dirty="0" err="1">
+                <a:solidFill>
+                  <a:schemeClr val="bg1"/>
+                </a:solidFill>
+              </a:rPr>
+              <a:t>IJulia</a:t>
+            </a:r>
+            <a:endParaRPr lang="en-US" b="1" dirty="0">
+              <a:solidFill>
+                <a:schemeClr val="bg1"/>
+              </a:solidFill>
+            </a:endParaRPr>
+          </a:p>
+          <a:p>
+            <a:r>
+              <a:rPr lang="en-US" b="1" dirty="0" err="1">
+                <a:solidFill>
+                  <a:schemeClr val="bg1"/>
+                </a:solidFill>
+              </a:rPr>
+              <a:t>julia</a:t>
+            </a:r>
+            <a:r>
+              <a:rPr lang="en-US" b="1" dirty="0">
+                <a:solidFill>
+                  <a:schemeClr val="bg1"/>
+                </a:solidFill>
+              </a:rPr>
+              <a:t>&gt; </a:t>
+            </a:r>
+            <a:r>
+              <a:rPr lang="en-US" b="1" dirty="0" err="1">
+                <a:solidFill>
+                  <a:schemeClr val="bg1"/>
+                </a:solidFill>
+              </a:rPr>
+              <a:t>IJulia.installkernel</a:t>
+            </a:r>
+            <a:r>
+              <a:rPr lang="en-US" b="1" dirty="0">
+                <a:solidFill>
+                  <a:schemeClr val="bg1"/>
+                </a:solidFill>
+              </a:rPr>
+              <a:t>("</a:t>
+            </a:r>
+            <a:r>
+              <a:rPr lang="en-US" b="1" dirty="0" err="1">
+                <a:solidFill>
+                  <a:schemeClr val="bg1"/>
+                </a:solidFill>
+              </a:rPr>
+              <a:t>julia</a:t>
+            </a:r>
+            <a:r>
+              <a:rPr lang="en-US" b="1" dirty="0">
+                <a:solidFill>
+                  <a:schemeClr val="bg1"/>
+                </a:solidFill>
+              </a:rPr>
+              <a:t> 1.12.1")</a:t>
+            </a:r>
+          </a:p>
+          <a:p>
+            <a:r>
+              <a:rPr lang="en-US" b="1" dirty="0" err="1">
+                <a:solidFill>
+                  <a:schemeClr val="bg1"/>
+                </a:solidFill>
+              </a:rPr>
+              <a:t>julia</a:t>
+            </a:r>
+            <a:r>
+              <a:rPr lang="en-US" b="1" dirty="0">
+                <a:solidFill>
+                  <a:schemeClr val="bg1"/>
+                </a:solidFill>
+              </a:rPr>
+              <a:t>&gt; </a:t>
+            </a:r>
+            <a:r>
+              <a:rPr lang="en-US" b="1" dirty="0" err="1">
+                <a:solidFill>
+                  <a:schemeClr val="bg1"/>
+                </a:solidFill>
+              </a:rPr>
+              <a:t>jupyterlab</a:t>
+            </a:r>
+            <a:r>
+              <a:rPr lang="en-US" b="1" dirty="0">
+                <a:solidFill>
+                  <a:schemeClr val="bg1"/>
+                </a:solidFill>
+              </a:rPr>
+              <a:t>()</a:t>
+            </a:r>
+          </a:p>
+        </p:txBody>
+      </p:sp>
+      <p:sp>
+        <p:nvSpPr>
+          <p:cNvPr id="12" name="TextBox 11">
+            <a:extLst>
+              <a:ext uri="{FF2B5EF4-FFF2-40B4-BE49-F238E27FC236}">
+                <a16:creationId xmlns:a16="http://schemas.microsoft.com/office/drawing/2014/main" id="{AABDB0F4-EB22-16D4-FDDF-961A982A1116}"/>
+              </a:ext>
+            </a:extLst>
+          </p:cNvPr>
+          <p:cNvSpPr txBox="1"/>
+          <p:nvPr/>
+        </p:nvSpPr>
+        <p:spPr>
+          <a:xfrm>
+            <a:off x="6430852" y="5058092"/>
             <a:ext cx="4823888" cy="1200329"/>
           </a:xfrm>
           <a:prstGeom prst="rect">
@@ -33364,20 +33628,8 @@
                   <a:schemeClr val="bg1"/>
                 </a:solidFill>
               </a:rPr>
-              <a:t>$ Julia</a:t>
-            </a:r>
-          </a:p>
-          <a:p>
-            <a:r>
-              <a:rPr lang="en-US" b="1" dirty="0">
-                <a:solidFill>
-                  <a:schemeClr val="bg1"/>
-                </a:solidFill>
-              </a:rPr>
-              <a:t>…</a:t>
-            </a:r>
-          </a:p>
-          <a:p>
+              <a:t>$ </a:t>
+            </a:r>
             <a:r>
               <a:rPr lang="en-US" b="1" dirty="0" err="1">
                 <a:solidFill>
@@ -33385,22 +33637,6 @@
                 </a:solidFill>
               </a:rPr>
               <a:t>julia</a:t>
-            </a:r>
-            <a:r>
-              <a:rPr lang="en-US" b="1" dirty="0">
-                <a:solidFill>
-                  <a:schemeClr val="bg1"/>
-                </a:solidFill>
-              </a:rPr>
-              <a:t>&gt; using </a:t>
-            </a:r>
-            <a:r>
-              <a:rPr lang="en-US" b="1" dirty="0" err="1">
-                <a:solidFill>
-                  <a:schemeClr val="bg1"/>
-                </a:solidFill>
-              </a:rPr>
-              <a:t>IJulia</a:t>
             </a:r>
             <a:endParaRPr lang="en-US" b="1" dirty="0">
               <a:solidFill>
@@ -33415,7 +33651,72 @@
                   <a:schemeClr val="bg1"/>
                 </a:solidFill>
               </a:rPr>
-              <a:t>Julia&gt; notebook()</a:t>
+              <a:t>…</a:t>
+            </a:r>
+          </a:p>
+          <a:p>
+            <a:r>
+              <a:rPr lang="en-US" b="1" dirty="0" err="1">
+                <a:solidFill>
+                  <a:schemeClr val="bg1"/>
+                </a:solidFill>
+              </a:rPr>
+              <a:t>julia</a:t>
+            </a:r>
+            <a:r>
+              <a:rPr lang="en-US" b="1" dirty="0">
+                <a:solidFill>
+                  <a:schemeClr val="bg1"/>
+                </a:solidFill>
+              </a:rPr>
+              <a:t>&gt; using </a:t>
+            </a:r>
+            <a:r>
+              <a:rPr lang="en-US" b="1" dirty="0" err="1">
+                <a:solidFill>
+                  <a:schemeClr val="bg1"/>
+                </a:solidFill>
+              </a:rPr>
+              <a:t>IJulia</a:t>
+            </a:r>
+            <a:endParaRPr lang="en-US" b="1" dirty="0">
+              <a:solidFill>
+                <a:schemeClr val="bg1"/>
+              </a:solidFill>
+            </a:endParaRPr>
+          </a:p>
+          <a:p>
+            <a:r>
+              <a:rPr lang="en-US" b="1" dirty="0" err="1">
+                <a:solidFill>
+                  <a:schemeClr val="bg1"/>
+                </a:solidFill>
+              </a:rPr>
+              <a:t>julia</a:t>
+            </a:r>
+            <a:r>
+              <a:rPr lang="en-US" b="1" dirty="0">
+                <a:solidFill>
+                  <a:schemeClr val="bg1"/>
+                </a:solidFill>
+              </a:rPr>
+              <a:t>&gt; </a:t>
+            </a:r>
+            <a:r>
+              <a:rPr lang="en-US" b="1" dirty="0" err="1">
+                <a:solidFill>
+                  <a:schemeClr val="bg1"/>
+                </a:solidFill>
+              </a:rPr>
+              <a:t>jupyterlab</a:t>
+            </a:r>
+            <a:r>
+              <a:rPr lang="en-US" b="1" dirty="0">
+                <a:solidFill>
+                  <a:schemeClr val="bg1"/>
+                </a:solidFill>
+              </a:rPr>
+              <a:t>()</a:t>
             </a:r>
           </a:p>
         </p:txBody>
@@ -33434,13 +33735,15 @@
         </p:nvSpPr>
         <p:spPr>
           <a:xfrm>
-            <a:off x="5747657" y="5715298"/>
-            <a:ext cx="3747308" cy="461665"/>
+            <a:off x="9134790" y="2359810"/>
+            <a:ext cx="2866362" cy="830997"/>
           </a:xfrm>
           <a:prstGeom prst="rect">
             <a:avLst/>
           </a:prstGeom>
-          <a:noFill/>
+          <a:solidFill>
+            <a:schemeClr val="bg1"/>
+          </a:solidFill>
           <a:ln>
             <a:solidFill>
               <a:schemeClr val="tx1"/>
@@ -33455,169 +33758,35 @@
           <a:p>
             <a:r>
               <a:rPr lang="en-US" sz="2400" dirty="0"/>
-              <a:t>First time: will offer to install</a:t>
-            </a:r>
-          </a:p>
-        </p:txBody>
-      </p:sp>
-      <p:sp>
-        <p:nvSpPr>
-          <p:cNvPr id="9" name="TextBox 8">
-            <a:extLst>
-              <a:ext uri="{FF2B5EF4-FFF2-40B4-BE49-F238E27FC236}">
-                <a16:creationId xmlns:a16="http://schemas.microsoft.com/office/drawing/2014/main" id="{9281971C-AB02-B537-7F9F-C3D789C3072C}"/>
-              </a:ext>
-            </a:extLst>
-          </p:cNvPr>
-          <p:cNvSpPr txBox="1"/>
-          <p:nvPr/>
-        </p:nvSpPr>
-        <p:spPr>
-          <a:xfrm>
-            <a:off x="6351056" y="4585951"/>
-            <a:ext cx="4823888" cy="369332"/>
-          </a:xfrm>
-          <a:prstGeom prst="rect">
-            <a:avLst/>
-          </a:prstGeom>
-          <a:solidFill>
-            <a:schemeClr val="tx1"/>
-          </a:solidFill>
-        </p:spPr>
-        <p:txBody>
-          <a:bodyPr wrap="square" rtlCol="0">
-            <a:spAutoFit/>
-          </a:bodyPr>
-          <a:lstStyle/>
-          <a:p>
-            <a:r>
-              <a:rPr lang="en-US" b="1" dirty="0">
-                <a:solidFill>
-                  <a:schemeClr val="bg1"/>
-                </a:solidFill>
-              </a:rPr>
-              <a:t>$ Julia  </a:t>
-            </a:r>
-            <a:r>
-              <a:rPr lang="en-US" b="1" dirty="0" err="1">
-                <a:solidFill>
-                  <a:schemeClr val="bg1"/>
-                </a:solidFill>
-              </a:rPr>
-              <a:t>my_script.jl</a:t>
-            </a:r>
-            <a:endParaRPr lang="en-US" b="1" dirty="0">
-              <a:solidFill>
-                <a:schemeClr val="bg1"/>
-              </a:solidFill>
-            </a:endParaRPr>
-          </a:p>
-        </p:txBody>
-      </p:sp>
-      <p:sp>
-        <p:nvSpPr>
-          <p:cNvPr id="10" name="TextBox 9">
-            <a:extLst>
-              <a:ext uri="{FF2B5EF4-FFF2-40B4-BE49-F238E27FC236}">
-                <a16:creationId xmlns:a16="http://schemas.microsoft.com/office/drawing/2014/main" id="{AECB3277-94F0-9152-3529-ECD9C73028BC}"/>
-              </a:ext>
-            </a:extLst>
-          </p:cNvPr>
-          <p:cNvSpPr txBox="1"/>
-          <p:nvPr/>
-        </p:nvSpPr>
-        <p:spPr>
-          <a:xfrm>
-            <a:off x="6351056" y="2308404"/>
-            <a:ext cx="4823888" cy="1200329"/>
-          </a:xfrm>
-          <a:prstGeom prst="rect">
-            <a:avLst/>
-          </a:prstGeom>
-          <a:solidFill>
-            <a:schemeClr val="tx1"/>
-          </a:solidFill>
-        </p:spPr>
-        <p:txBody>
-          <a:bodyPr wrap="square" rtlCol="0">
-            <a:spAutoFit/>
-          </a:bodyPr>
-          <a:lstStyle/>
-          <a:p>
-            <a:r>
-              <a:rPr lang="en-US" b="1" dirty="0">
-                <a:solidFill>
-                  <a:schemeClr val="bg1"/>
-                </a:solidFill>
-              </a:rPr>
-              <a:t>$ Julia</a:t>
-            </a:r>
-          </a:p>
-          <a:p>
-            <a:r>
-              <a:rPr lang="en-US" b="1" dirty="0">
-                <a:solidFill>
-                  <a:schemeClr val="bg1"/>
-                </a:solidFill>
-              </a:rPr>
-              <a:t>…</a:t>
-            </a:r>
-          </a:p>
-          <a:p>
-            <a:r>
-              <a:rPr lang="en-US" b="1" dirty="0" err="1">
-                <a:solidFill>
-                  <a:schemeClr val="bg1"/>
-                </a:solidFill>
-              </a:rPr>
-              <a:t>julia</a:t>
-            </a:r>
-            <a:r>
-              <a:rPr lang="en-US" b="1" dirty="0">
-                <a:solidFill>
-                  <a:schemeClr val="bg1"/>
-                </a:solidFill>
-              </a:rPr>
-              <a:t>&gt; using </a:t>
-            </a:r>
-            <a:r>
-              <a:rPr lang="en-US" b="1" dirty="0" err="1">
-                <a:solidFill>
-                  <a:schemeClr val="bg1"/>
-                </a:solidFill>
+              <a:t>Offers to install</a:t>
+            </a:r>
+            <a:br>
+              <a:rPr lang="en-US" sz="2400" dirty="0"/>
+            </a:br>
+            <a:r>
+              <a:rPr lang="en-US" sz="2400" dirty="0" err="1">
+                <a:latin typeface="Courier New" panose="02070309020205020404" pitchFamily="49" charset="0"/>
+                <a:cs typeface="Courier New" panose="02070309020205020404" pitchFamily="49" charset="0"/>
               </a:rPr>
               <a:t>IJulia</a:t>
             </a:r>
-            <a:endParaRPr lang="en-US" b="1" dirty="0">
-              <a:solidFill>
-                <a:schemeClr val="bg1"/>
-              </a:solidFill>
-            </a:endParaRPr>
-          </a:p>
-          <a:p>
-            <a:r>
-              <a:rPr lang="en-US" b="1" dirty="0">
-                <a:solidFill>
-                  <a:schemeClr val="bg1"/>
-                </a:solidFill>
-              </a:rPr>
-              <a:t>Julia&gt; </a:t>
-            </a:r>
-            <a:r>
-              <a:rPr lang="en-US" b="1" dirty="0" err="1">
-                <a:solidFill>
-                  <a:schemeClr val="bg1"/>
-                </a:solidFill>
-              </a:rPr>
-              <a:t>jupyterlab</a:t>
-            </a:r>
-            <a:r>
-              <a:rPr lang="en-US" b="1" dirty="0">
-                <a:solidFill>
-                  <a:schemeClr val="bg1"/>
-                </a:solidFill>
-              </a:rPr>
-              <a:t>()</a:t>
+            <a:r>
+              <a:rPr lang="en-US" sz="2400" dirty="0">
+                <a:cs typeface="Courier New" panose="02070309020205020404" pitchFamily="49" charset="0"/>
+              </a:rPr>
+              <a:t>, </a:t>
+            </a:r>
+            <a:r>
+              <a:rPr lang="en-US" sz="2400" dirty="0" err="1">
+                <a:cs typeface="Courier New" panose="02070309020205020404" pitchFamily="49" charset="0"/>
+              </a:rPr>
+              <a:t>Jupyter</a:t>
+            </a:r>
+            <a:r>
+              <a:rPr lang="en-US" sz="2400" dirty="0">
+                <a:cs typeface="Courier New" panose="02070309020205020404" pitchFamily="49" charset="0"/>
+              </a:rPr>
+              <a:t> Lab</a:t>
             </a:r>
           </a:p>
         </p:txBody>
@@ -33749,7 +33918,7 @@
                                           </p:stCondLst>
                                         </p:cTn>
                                         <p:tgtEl>
-                                          <p:spTgt spid="6"/>
+                                          <p:spTgt spid="9"/>
                                         </p:tgtEl>
                                         <p:attrNameLst>
                                           <p:attrName>style.visibility</p:attrName>
@@ -33794,51 +33963,6 @@
                                           </p:stCondLst>
                                         </p:cTn>
                                         <p:tgtEl>
-                                          <p:spTgt spid="7"/>
-                                        </p:tgtEl>
-                                        <p:attrNameLst>
-                                          <p:attrName>style.visibility</p:attrName>
-                                        </p:attrNameLst>
-                                      </p:cBhvr>
-                                      <p:to>
-                                        <p:strVal val="visible"/>
-                                      </p:to>
-                                    </p:set>
-                                  </p:childTnLst>
-                                </p:cTn>
-                              </p:par>
-                            </p:childTnLst>
-                          </p:cTn>
-                        </p:par>
-                      </p:childTnLst>
-                    </p:cTn>
-                  </p:par>
-                  <p:par>
-                    <p:cTn id="17" fill="hold">
-                      <p:stCondLst>
-                        <p:cond delay="indefinite"/>
-                      </p:stCondLst>
-                      <p:childTnLst>
-                        <p:par>
-                          <p:cTn id="18" fill="hold">
-                            <p:stCondLst>
-                              <p:cond delay="0"/>
-                            </p:stCondLst>
-                            <p:childTnLst>
-                              <p:par>
-                                <p:cTn id="19" presetID="1" presetClass="entr" presetSubtype="0" fill="hold" grpId="0" nodeType="clickEffect">
-                                  <p:stCondLst>
-                                    <p:cond delay="0"/>
-                                  </p:stCondLst>
-                                  <p:childTnLst>
-                                    <p:set>
-                                      <p:cBhvr>
-                                        <p:cTn id="20" dur="1" fill="hold">
-                                          <p:stCondLst>
-                                            <p:cond delay="0"/>
-                                          </p:stCondLst>
-                                        </p:cTn>
-                                        <p:tgtEl>
                                           <p:spTgt spid="8">
                                             <p:txEl>
                                               <p:pRg st="0" end="0"/>
@@ -33857,14 +33981,45 @@
                                 </p:cTn>
                               </p:par>
                               <p:par>
-                                <p:cTn id="21" presetID="1" presetClass="entr" presetSubtype="0" fill="hold" grpId="0" nodeType="withEffect">
+                                <p:cTn id="17" presetID="1" presetClass="entr" presetSubtype="0" fill="hold" grpId="0" nodeType="withEffect">
                                   <p:stCondLst>
                                     <p:cond delay="0"/>
                                   </p:stCondLst>
                                   <p:childTnLst>
                                     <p:set>
                                       <p:cBhvr>
-                                        <p:cTn id="22" dur="1" fill="hold">
+                                        <p:cTn id="18" dur="1" fill="hold">
+                                          <p:stCondLst>
+                                            <p:cond delay="0"/>
+                                          </p:stCondLst>
+                                        </p:cTn>
+                                        <p:tgtEl>
+                                          <p:spTgt spid="8">
+                                            <p:txEl>
+                                              <p:pRg st="1" end="1"/>
+                                            </p:txEl>
+                                          </p:spTgt>
+                                        </p:tgtEl>
+                                        <p:attrNameLst>
+                                          <p:attrName>style.visibility</p:attrName>
+                                        </p:attrNameLst>
+                                      </p:cBhvr>
+                                      <p:to>
+                                        <p:strVal val="visible"/>
+                                      </p:to>
+                                    </p:set>
+                                  </p:childTnLst>
+                                </p:cTn>
+                              </p:par>
+                              <p:par>
+                                <p:cTn id="19" presetID="1" presetClass="entr" presetSubtype="0" fill="hold" grpId="0" nodeType="withEffect">
+                                  <p:stCondLst>
+                                    <p:cond delay="0"/>
+                                  </p:stCondLst>
+                                  <p:childTnLst>
+                                    <p:set>
+                                      <p:cBhvr>
+                                        <p:cTn id="20" dur="1" fill="hold">
                                           <p:stCondLst>
                                             <p:cond delay="0"/>
                                           </p:stCondLst>
@@ -33890,26 +34045,71 @@
                     </p:cTn>
                   </p:par>
                   <p:par>
-                    <p:cTn id="23" fill="hold">
+                    <p:cTn id="21" fill="hold">
                       <p:stCondLst>
                         <p:cond delay="indefinite"/>
                       </p:stCondLst>
                       <p:childTnLst>
                         <p:par>
-                          <p:cTn id="24" fill="hold">
+                          <p:cTn id="22" fill="hold">
                             <p:stCondLst>
                               <p:cond delay="0"/>
                             </p:stCondLst>
                             <p:childTnLst>
                               <p:par>
-                                <p:cTn id="25" presetID="1" presetClass="entr" presetSubtype="0" fill="hold" grpId="0" nodeType="clickEffect">
+                                <p:cTn id="23" presetID="1" presetClass="entr" presetSubtype="0" fill="hold" grpId="0" nodeType="clickEffect">
                                   <p:stCondLst>
                                     <p:cond delay="0"/>
                                   </p:stCondLst>
                                   <p:childTnLst>
                                     <p:set>
                                       <p:cBhvr>
-                                        <p:cTn id="26" dur="1" fill="hold">
+                                        <p:cTn id="24" dur="1" fill="hold">
+                                          <p:stCondLst>
+                                            <p:cond delay="0"/>
+                                          </p:stCondLst>
+                                        </p:cTn>
+                                        <p:tgtEl>
+                                          <p:spTgt spid="7"/>
+                                        </p:tgtEl>
+                                        <p:attrNameLst>
+                                          <p:attrName>style.visibility</p:attrName>
+                                        </p:attrNameLst>
+                                      </p:cBhvr>
+                                      <p:to>
+                                        <p:strVal val="visible"/>
+                                      </p:to>
+                                    </p:set>
+                                  </p:childTnLst>
+                                </p:cTn>
+                              </p:par>
+                            </p:childTnLst>
+                          </p:cTn>
+                        </p:par>
+                      </p:childTnLst>
+                    </p:cTn>
+                  </p:par>
+                  <p:par>
+                    <p:cTn id="25" fill="hold">
+                      <p:stCondLst>
+                        <p:cond delay="indefinite"/>
+                      </p:stCondLst>
+                      <p:childTnLst>
+                        <p:par>
+                          <p:cTn id="26" fill="hold">
+                            <p:stCondLst>
+                              <p:cond delay="0"/>
+                            </p:stCondLst>
+                            <p:childTnLst>
+                              <p:par>
+                                <p:cTn id="27" presetID="1" presetClass="entr" presetSubtype="0" fill="hold" grpId="0" nodeType="clickEffect">
+                                  <p:stCondLst>
+                                    <p:cond delay="0"/>
+                                  </p:stCondLst>
+                                  <p:childTnLst>
+                                    <p:set>
+                                      <p:cBhvr>
+                                        <p:cTn id="28" dur="1" fill="hold">
                                           <p:stCondLst>
                                             <p:cond delay="0"/>
                                           </p:stCondLst>
@@ -33917,7 +34117,7 @@
                                         <p:tgtEl>
                                           <p:spTgt spid="8">
                                             <p:txEl>
-                                              <p:pRg st="4" end="4"/>
+                                              <p:pRg st="7" end="7"/>
                                             </p:txEl>
                                           </p:spTgt>
                                         </p:tgtEl>
@@ -33933,20 +34133,20 @@
                                 </p:cTn>
                               </p:par>
                               <p:par>
-                                <p:cTn id="27" presetID="1" presetClass="entr" presetSubtype="0" fill="hold" grpId="0" nodeType="withEffect">
+                                <p:cTn id="29" presetID="1" presetClass="entr" presetSubtype="0" fill="hold" grpId="0" nodeType="withEffect">
                                   <p:stCondLst>
                                     <p:cond delay="0"/>
                                   </p:stCondLst>
                                   <p:childTnLst>
                                     <p:set>
                                       <p:cBhvr>
-                                        <p:cTn id="28" dur="1" fill="hold">
+                                        <p:cTn id="30" dur="1" fill="hold">
                                           <p:stCondLst>
                                             <p:cond delay="0"/>
                                           </p:stCondLst>
                                         </p:cTn>
                                         <p:tgtEl>
-                                          <p:spTgt spid="9"/>
+                                          <p:spTgt spid="12"/>
                                         </p:tgtEl>
                                         <p:attrNameLst>
                                           <p:attrName>style.visibility</p:attrName>
@@ -33988,11 +34188,11 @@
     </p:tnLst>
     <p:bldLst>
       <p:bldP spid="3" grpId="0" uiExpand="1" build="p"/>
-      <p:bldP spid="8" grpId="0" uiExpand="1" build="p"/>
-      <p:bldP spid="6" grpId="0" animBg="1"/>
-      <p:bldP spid="7" grpId="0" animBg="1"/>
+      <p:bldP spid="8" grpId="0" uiExpand="1" build="p" bldLvl="2"/>
       <p:bldP spid="9" grpId="0" animBg="1"/>
       <p:bldP spid="10" grpId="0" animBg="1"/>
+      <p:bldP spid="12" grpId="0" animBg="1"/>
+      <p:bldP spid="7" grpId="0" animBg="1"/>
     </p:bldLst>
   </p:timing>
 </p:sld>

</xml_diff>

<commit_message>
Add remark on Holy traits pattern
</commit_message>
<xml_diff>
--- a/julia_good_back_ugly.pptx
+++ b/julia_good_back_ugly.pptx
@@ -22038,6 +22038,55 @@
             <a:endParaRPr lang="en-US" dirty="0">
               <a:latin typeface="Consolas" panose="020B0609020204030204" pitchFamily="49" charset="0"/>
             </a:endParaRPr>
+          </a:p>
+        </p:txBody>
+      </p:sp>
+      <p:sp>
+        <p:nvSpPr>
+          <p:cNvPr id="6" name="TextBox 5">
+            <a:extLst>
+              <a:ext uri="{FF2B5EF4-FFF2-40B4-BE49-F238E27FC236}">
+                <a16:creationId xmlns:a16="http://schemas.microsoft.com/office/drawing/2014/main" id="{B0DBD163-5A46-095D-9FAB-F44228F66C72}"/>
+              </a:ext>
+            </a:extLst>
+          </p:cNvPr>
+          <p:cNvSpPr txBox="1"/>
+          <p:nvPr/>
+        </p:nvSpPr>
+        <p:spPr>
+          <a:xfrm>
+            <a:off x="4867157" y="533886"/>
+            <a:ext cx="3578031" cy="830997"/>
+          </a:xfrm>
+          <a:prstGeom prst="rect">
+            <a:avLst/>
+          </a:prstGeom>
+          <a:noFill/>
+          <a:ln>
+            <a:solidFill>
+              <a:schemeClr val="tx1"/>
+            </a:solidFill>
+          </a:ln>
+        </p:spPr>
+        <p:txBody>
+          <a:bodyPr wrap="none" rtlCol="0">
+            <a:spAutoFit/>
+          </a:bodyPr>
+          <a:lstStyle/>
+          <a:p>
+            <a:pPr algn="ctr"/>
+            <a:r>
+              <a:rPr lang="en-US" sz="2400" dirty="0"/>
+              <a:t>Holy traits pattern, or</a:t>
+            </a:r>
+          </a:p>
+          <a:p>
+            <a:pPr algn="ctr"/>
+            <a:r>
+              <a:rPr lang="en-US" sz="2400" dirty="0"/>
+              <a:t>The Holy Traits Trick (THTT)</a:t>
+            </a:r>
+            <a:endParaRPr lang="LID4096" sz="2400" dirty="0"/>
           </a:p>
         </p:txBody>
       </p:sp>

</xml_diff>

<commit_message>
Add slides on composition/delegation
</commit_message>
<xml_diff>
--- a/julia_good_back_ugly.pptx
+++ b/julia_good_back_ugly.pptx
@@ -5,7 +5,7 @@
     <p:sldMasterId id="2147483648" r:id="rId1"/>
   </p:sldMasterIdLst>
   <p:notesMasterIdLst>
-    <p:notesMasterId r:id="rId50"/>
+    <p:notesMasterId r:id="rId52"/>
   </p:notesMasterIdLst>
   <p:sldIdLst>
     <p:sldId id="256" r:id="rId2"/>
@@ -38,24 +38,26 @@
     <p:sldId id="268" r:id="rId29"/>
     <p:sldId id="270" r:id="rId30"/>
     <p:sldId id="269" r:id="rId31"/>
-    <p:sldId id="271" r:id="rId32"/>
-    <p:sldId id="272" r:id="rId33"/>
-    <p:sldId id="279" r:id="rId34"/>
-    <p:sldId id="294" r:id="rId35"/>
-    <p:sldId id="295" r:id="rId36"/>
-    <p:sldId id="296" r:id="rId37"/>
-    <p:sldId id="297" r:id="rId38"/>
-    <p:sldId id="280" r:id="rId39"/>
-    <p:sldId id="289" r:id="rId40"/>
-    <p:sldId id="290" r:id="rId41"/>
-    <p:sldId id="291" r:id="rId42"/>
-    <p:sldId id="281" r:id="rId43"/>
-    <p:sldId id="292" r:id="rId44"/>
-    <p:sldId id="298" r:id="rId45"/>
-    <p:sldId id="273" r:id="rId46"/>
-    <p:sldId id="299" r:id="rId47"/>
-    <p:sldId id="274" r:id="rId48"/>
-    <p:sldId id="359" r:id="rId49"/>
+    <p:sldId id="361" r:id="rId32"/>
+    <p:sldId id="362" r:id="rId33"/>
+    <p:sldId id="271" r:id="rId34"/>
+    <p:sldId id="272" r:id="rId35"/>
+    <p:sldId id="279" r:id="rId36"/>
+    <p:sldId id="294" r:id="rId37"/>
+    <p:sldId id="295" r:id="rId38"/>
+    <p:sldId id="296" r:id="rId39"/>
+    <p:sldId id="297" r:id="rId40"/>
+    <p:sldId id="280" r:id="rId41"/>
+    <p:sldId id="289" r:id="rId42"/>
+    <p:sldId id="290" r:id="rId43"/>
+    <p:sldId id="291" r:id="rId44"/>
+    <p:sldId id="281" r:id="rId45"/>
+    <p:sldId id="292" r:id="rId46"/>
+    <p:sldId id="298" r:id="rId47"/>
+    <p:sldId id="273" r:id="rId48"/>
+    <p:sldId id="299" r:id="rId49"/>
+    <p:sldId id="274" r:id="rId50"/>
+    <p:sldId id="359" r:id="rId51"/>
   </p:sldIdLst>
   <p:sldSz cx="12192000" cy="6858000"/>
   <p:notesSz cx="6858000" cy="9144000"/>
@@ -209,6 +211,8 @@
             <p14:sldId id="268"/>
             <p14:sldId id="270"/>
             <p14:sldId id="269"/>
+            <p14:sldId id="361"/>
+            <p14:sldId id="362"/>
             <p14:sldId id="271"/>
             <p14:sldId id="272"/>
             <p14:sldId id="279"/>
@@ -336,7 +340,7 @@
           <a:p>
             <a:fld id="{CC9F3EF1-84A5-42B0-81FF-8805AF740E8D}" type="datetimeFigureOut">
               <a:rPr lang="en-US" smtClean="0"/>
-              <a:t>2025-10-27</a:t>
+              <a:t>2025-11-05</a:t>
             </a:fld>
             <a:endParaRPr lang="en-US"/>
           </a:p>
@@ -750,7 +754,7 @@
           <a:p>
             <a:fld id="{0D45F18C-3E18-466F-8ADF-516304A44708}" type="datetime1">
               <a:rPr lang="en-US" smtClean="0"/>
-              <a:t>2025-10-27</a:t>
+              <a:t>2025-11-05</a:t>
             </a:fld>
             <a:endParaRPr lang="en-US"/>
           </a:p>
@@ -948,7 +952,7 @@
           <a:p>
             <a:fld id="{D5980222-6813-4CA6-84DC-753D8B88D809}" type="datetime1">
               <a:rPr lang="en-US" smtClean="0"/>
-              <a:t>2025-10-27</a:t>
+              <a:t>2025-11-05</a:t>
             </a:fld>
             <a:endParaRPr lang="en-US"/>
           </a:p>
@@ -1156,7 +1160,7 @@
           <a:p>
             <a:fld id="{96F7B8FF-A661-4CB7-BF06-F03D9C89262B}" type="datetime1">
               <a:rPr lang="en-US" smtClean="0"/>
-              <a:t>2025-10-27</a:t>
+              <a:t>2025-11-05</a:t>
             </a:fld>
             <a:endParaRPr lang="en-US"/>
           </a:p>
@@ -1354,7 +1358,7 @@
           <a:p>
             <a:fld id="{CE4E165D-6495-4D37-B27D-5DB6761319B2}" type="datetime1">
               <a:rPr lang="en-US" smtClean="0"/>
-              <a:t>2025-10-27</a:t>
+              <a:t>2025-11-05</a:t>
             </a:fld>
             <a:endParaRPr lang="en-US"/>
           </a:p>
@@ -1629,7 +1633,7 @@
           <a:p>
             <a:fld id="{579D02C7-69E9-4C82-8F80-CB6196DA722C}" type="datetime1">
               <a:rPr lang="en-US" smtClean="0"/>
-              <a:t>2025-10-27</a:t>
+              <a:t>2025-11-05</a:t>
             </a:fld>
             <a:endParaRPr lang="en-US"/>
           </a:p>
@@ -1894,7 +1898,7 @@
           <a:p>
             <a:fld id="{107E8C2C-E058-49BD-9DFF-244106208F3B}" type="datetime1">
               <a:rPr lang="en-US" smtClean="0"/>
-              <a:t>2025-10-27</a:t>
+              <a:t>2025-11-05</a:t>
             </a:fld>
             <a:endParaRPr lang="en-US"/>
           </a:p>
@@ -2306,7 +2310,7 @@
           <a:p>
             <a:fld id="{EBBE2EFD-4DA5-4354-BB09-551207F90777}" type="datetime1">
               <a:rPr lang="en-US" smtClean="0"/>
-              <a:t>2025-10-27</a:t>
+              <a:t>2025-11-05</a:t>
             </a:fld>
             <a:endParaRPr lang="en-US"/>
           </a:p>
@@ -2447,7 +2451,7 @@
           <a:p>
             <a:fld id="{0357F3B6-5D5B-4F6A-8ABC-6500847F3284}" type="datetime1">
               <a:rPr lang="en-US" smtClean="0"/>
-              <a:t>2025-10-27</a:t>
+              <a:t>2025-11-05</a:t>
             </a:fld>
             <a:endParaRPr lang="en-US"/>
           </a:p>
@@ -2560,7 +2564,7 @@
           <a:p>
             <a:fld id="{470EE9C1-5D95-4DE1-8B8E-CE731554AA23}" type="datetime1">
               <a:rPr lang="en-US" smtClean="0"/>
-              <a:t>2025-10-27</a:t>
+              <a:t>2025-11-05</a:t>
             </a:fld>
             <a:endParaRPr lang="en-US"/>
           </a:p>
@@ -2871,7 +2875,7 @@
           <a:p>
             <a:fld id="{ED4A0E8D-A460-4018-89F2-1FF6F9205C86}" type="datetime1">
               <a:rPr lang="en-US" smtClean="0"/>
-              <a:t>2025-10-27</a:t>
+              <a:t>2025-11-05</a:t>
             </a:fld>
             <a:endParaRPr lang="en-US"/>
           </a:p>
@@ -3159,7 +3163,7 @@
           <a:p>
             <a:fld id="{74076E25-3B53-45C6-AE55-8E3CC5E53EDE}" type="datetime1">
               <a:rPr lang="en-US" smtClean="0"/>
-              <a:t>2025-10-27</a:t>
+              <a:t>2025-11-05</a:t>
             </a:fld>
             <a:endParaRPr lang="en-US"/>
           </a:p>
@@ -3400,7 +3404,7 @@
           <a:p>
             <a:fld id="{3B0E2389-F93F-49F3-A6AD-79A456A600D1}" type="datetime1">
               <a:rPr lang="en-US" smtClean="0"/>
-              <a:t>2025-10-27</a:t>
+              <a:t>2025-11-05</a:t>
             </a:fld>
             <a:endParaRPr lang="en-US"/>
           </a:p>
@@ -21612,6 +21616,759 @@
           <p:cNvPr id="2" name="Title 1">
             <a:extLst>
               <a:ext uri="{FF2B5EF4-FFF2-40B4-BE49-F238E27FC236}">
+                <a16:creationId xmlns:a16="http://schemas.microsoft.com/office/drawing/2014/main" id="{7DDA7C9D-ECEC-918E-F432-AED3EF7D6448}"/>
+              </a:ext>
+            </a:extLst>
+          </p:cNvPr>
+          <p:cNvSpPr>
+            <a:spLocks noGrp="1"/>
+          </p:cNvSpPr>
+          <p:nvPr>
+            <p:ph type="title"/>
+          </p:nvPr>
+        </p:nvSpPr>
+        <p:spPr/>
+        <p:txBody>
+          <a:bodyPr/>
+          <a:lstStyle/>
+          <a:p>
+            <a:r>
+              <a:rPr lang="en-US" dirty="0"/>
+              <a:t>Composition</a:t>
+            </a:r>
+            <a:endParaRPr lang="LID4096" dirty="0"/>
+          </a:p>
+        </p:txBody>
+      </p:sp>
+      <p:sp>
+        <p:nvSpPr>
+          <p:cNvPr id="3" name="Content Placeholder 2">
+            <a:extLst>
+              <a:ext uri="{FF2B5EF4-FFF2-40B4-BE49-F238E27FC236}">
+                <a16:creationId xmlns:a16="http://schemas.microsoft.com/office/drawing/2014/main" id="{FD2E4210-BFF6-01E7-58E4-FB2C05C3F9F0}"/>
+              </a:ext>
+            </a:extLst>
+          </p:cNvPr>
+          <p:cNvSpPr>
+            <a:spLocks noGrp="1"/>
+          </p:cNvSpPr>
+          <p:nvPr>
+            <p:ph idx="1"/>
+          </p:nvPr>
+        </p:nvSpPr>
+        <p:spPr/>
+        <p:txBody>
+          <a:bodyPr/>
+          <a:lstStyle/>
+          <a:p>
+            <a:r>
+              <a:rPr lang="en-US" dirty="0"/>
+              <a:t>Inheritance == "is a" relation?</a:t>
+            </a:r>
+          </a:p>
+          <a:p>
+            <a:pPr lvl="1"/>
+            <a:r>
+              <a:rPr lang="en-US" dirty="0"/>
+              <a:t>Concrete type can not be subtyped</a:t>
+            </a:r>
+          </a:p>
+          <a:p>
+            <a:r>
+              <a:rPr lang="en-US" dirty="0"/>
+              <a:t>Use composition instead</a:t>
+            </a:r>
+          </a:p>
+          <a:p>
+            <a:endParaRPr lang="en-US" dirty="0"/>
+          </a:p>
+          <a:p>
+            <a:endParaRPr lang="en-US" dirty="0"/>
+          </a:p>
+          <a:p>
+            <a:endParaRPr lang="en-US" dirty="0"/>
+          </a:p>
+          <a:p>
+            <a:endParaRPr lang="en-US" dirty="0"/>
+          </a:p>
+          <a:p>
+            <a:r>
+              <a:rPr lang="en-US" dirty="0"/>
+              <a:t>Delegate functions</a:t>
+            </a:r>
+          </a:p>
+          <a:p>
+            <a:pPr lvl="1"/>
+            <a:endParaRPr lang="LID4096" dirty="0"/>
+          </a:p>
+        </p:txBody>
+      </p:sp>
+      <p:sp>
+        <p:nvSpPr>
+          <p:cNvPr id="4" name="Slide Number Placeholder 3">
+            <a:extLst>
+              <a:ext uri="{FF2B5EF4-FFF2-40B4-BE49-F238E27FC236}">
+                <a16:creationId xmlns:a16="http://schemas.microsoft.com/office/drawing/2014/main" id="{E30B69FE-174A-9A06-6E4A-325FBAE5E65D}"/>
+              </a:ext>
+            </a:extLst>
+          </p:cNvPr>
+          <p:cNvSpPr>
+            <a:spLocks noGrp="1"/>
+          </p:cNvSpPr>
+          <p:nvPr>
+            <p:ph type="sldNum" sz="quarter" idx="12"/>
+          </p:nvPr>
+        </p:nvSpPr>
+        <p:spPr/>
+        <p:txBody>
+          <a:bodyPr/>
+          <a:lstStyle/>
+          <a:p>
+            <a:fld id="{78F7A1EC-23D1-431D-8C93-9C4ED5D4A04D}" type="slidenum">
+              <a:rPr lang="en-US" smtClean="0"/>
+              <a:t>31</a:t>
+            </a:fld>
+            <a:endParaRPr lang="en-US"/>
+          </a:p>
+        </p:txBody>
+      </p:sp>
+      <p:sp>
+        <p:nvSpPr>
+          <p:cNvPr id="5" name="TextBox 4">
+            <a:extLst>
+              <a:ext uri="{FF2B5EF4-FFF2-40B4-BE49-F238E27FC236}">
+                <a16:creationId xmlns:a16="http://schemas.microsoft.com/office/drawing/2014/main" id="{53FAD45C-0EDA-3ECE-C609-4BA4874173A2}"/>
+              </a:ext>
+            </a:extLst>
+          </p:cNvPr>
+          <p:cNvSpPr txBox="1"/>
+          <p:nvPr/>
+        </p:nvSpPr>
+        <p:spPr>
+          <a:xfrm>
+            <a:off x="1458090" y="3234915"/>
+            <a:ext cx="9816046" cy="1754326"/>
+          </a:xfrm>
+          <a:prstGeom prst="rect">
+            <a:avLst/>
+          </a:prstGeom>
+          <a:solidFill>
+            <a:schemeClr val="bg1">
+              <a:lumMod val="85000"/>
+            </a:schemeClr>
+          </a:solidFill>
+        </p:spPr>
+        <p:txBody>
+          <a:bodyPr wrap="square" rtlCol="0">
+            <a:spAutoFit/>
+          </a:bodyPr>
+          <a:lstStyle/>
+          <a:p>
+            <a:r>
+              <a:rPr lang="en-US" dirty="0">
+                <a:latin typeface="Consolas" panose="020B0609020204030204" pitchFamily="49" charset="0"/>
+              </a:rPr>
+              <a:t>mutable struct </a:t>
+            </a:r>
+            <a:r>
+              <a:rPr lang="en-US" dirty="0" err="1">
+                <a:latin typeface="Consolas" panose="020B0609020204030204" pitchFamily="49" charset="0"/>
+              </a:rPr>
+              <a:t>ColoredPoint</a:t>
+            </a:r>
+            <a:r>
+              <a:rPr lang="en-US" dirty="0">
+                <a:latin typeface="Consolas" panose="020B0609020204030204" pitchFamily="49" charset="0"/>
+              </a:rPr>
+              <a:t> &lt;: </a:t>
+            </a:r>
+            <a:r>
+              <a:rPr lang="en-US" dirty="0" err="1">
+                <a:latin typeface="Consolas" panose="020B0609020204030204" pitchFamily="49" charset="0"/>
+              </a:rPr>
+              <a:t>AbstractPoint</a:t>
+            </a:r>
+            <a:endParaRPr lang="en-US" dirty="0">
+              <a:latin typeface="Consolas" panose="020B0609020204030204" pitchFamily="49" charset="0"/>
+            </a:endParaRPr>
+          </a:p>
+          <a:p>
+            <a:r>
+              <a:rPr lang="en-US" dirty="0">
+                <a:latin typeface="Consolas" panose="020B0609020204030204" pitchFamily="49" charset="0"/>
+              </a:rPr>
+              <a:t>    coords::Point</a:t>
+            </a:r>
+          </a:p>
+          <a:p>
+            <a:r>
+              <a:rPr lang="en-US" dirty="0">
+                <a:latin typeface="Consolas" panose="020B0609020204030204" pitchFamily="49" charset="0"/>
+              </a:rPr>
+              <a:t>    color::String</a:t>
+            </a:r>
+          </a:p>
+          <a:p>
+            <a:endParaRPr lang="en-US" dirty="0">
+              <a:latin typeface="Consolas" panose="020B0609020204030204" pitchFamily="49" charset="0"/>
+            </a:endParaRPr>
+          </a:p>
+          <a:p>
+            <a:r>
+              <a:rPr lang="en-US" dirty="0">
+                <a:latin typeface="Consolas" panose="020B0609020204030204" pitchFamily="49" charset="0"/>
+              </a:rPr>
+              <a:t>    </a:t>
+            </a:r>
+            <a:r>
+              <a:rPr lang="en-US" dirty="0" err="1">
+                <a:latin typeface="Consolas" panose="020B0609020204030204" pitchFamily="49" charset="0"/>
+              </a:rPr>
+              <a:t>ColoredPoint</a:t>
+            </a:r>
+            <a:r>
+              <a:rPr lang="en-US" dirty="0">
+                <a:latin typeface="Consolas" panose="020B0609020204030204" pitchFamily="49" charset="0"/>
+              </a:rPr>
+              <a:t>(x::Real, y::Real, color::String) = new(Point(x, y), color)</a:t>
+            </a:r>
+          </a:p>
+          <a:p>
+            <a:r>
+              <a:rPr lang="en-US" dirty="0">
+                <a:latin typeface="Consolas" panose="020B0609020204030204" pitchFamily="49" charset="0"/>
+              </a:rPr>
+              <a:t>end </a:t>
+            </a:r>
+          </a:p>
+        </p:txBody>
+      </p:sp>
+      <p:grpSp>
+        <p:nvGrpSpPr>
+          <p:cNvPr id="6" name="Group 5">
+            <a:extLst>
+              <a:ext uri="{FF2B5EF4-FFF2-40B4-BE49-F238E27FC236}">
+                <a16:creationId xmlns:a16="http://schemas.microsoft.com/office/drawing/2014/main" id="{4E582B6C-2111-F2C3-F4E9-F061D39BAD0C}"/>
+              </a:ext>
+            </a:extLst>
+          </p:cNvPr>
+          <p:cNvGrpSpPr/>
+          <p:nvPr/>
+        </p:nvGrpSpPr>
+        <p:grpSpPr>
+          <a:xfrm>
+            <a:off x="361865" y="3793474"/>
+            <a:ext cx="1550062" cy="1173922"/>
+            <a:chOff x="7900087" y="855320"/>
+            <a:chExt cx="1550062" cy="1173922"/>
+          </a:xfrm>
+        </p:grpSpPr>
+        <p:sp>
+          <p:nvSpPr>
+            <p:cNvPr id="7" name="TextBox 6">
+              <a:extLst>
+                <a:ext uri="{FF2B5EF4-FFF2-40B4-BE49-F238E27FC236}">
+                  <a16:creationId xmlns:a16="http://schemas.microsoft.com/office/drawing/2014/main" id="{C5CCAB75-2526-D88F-D119-DB0787B036C9}"/>
+                </a:ext>
+              </a:extLst>
+            </p:cNvPr>
+            <p:cNvSpPr txBox="1"/>
+            <p:nvPr/>
+          </p:nvSpPr>
+          <p:spPr>
+            <a:xfrm>
+              <a:off x="7900087" y="1321356"/>
+              <a:ext cx="954107" cy="707886"/>
+            </a:xfrm>
+            <a:prstGeom prst="rect">
+              <a:avLst/>
+            </a:prstGeom>
+            <a:solidFill>
+              <a:schemeClr val="bg1"/>
+            </a:solidFill>
+          </p:spPr>
+          <p:txBody>
+            <a:bodyPr wrap="none" rtlCol="0">
+              <a:spAutoFit/>
+            </a:bodyPr>
+            <a:lstStyle/>
+            <a:p>
+              <a:r>
+                <a:rPr lang="en-US" sz="2000" dirty="0"/>
+                <a:t>Reuse</a:t>
+              </a:r>
+              <a:br>
+                <a:rPr lang="en-US" sz="2000" dirty="0"/>
+              </a:br>
+              <a:r>
+                <a:rPr lang="en-US" sz="2000" dirty="0">
+                  <a:latin typeface="Courier New" panose="02070309020205020404" pitchFamily="49" charset="0"/>
+                  <a:cs typeface="Courier New" panose="02070309020205020404" pitchFamily="49" charset="0"/>
+                </a:rPr>
+                <a:t>Point</a:t>
+              </a:r>
+            </a:p>
+          </p:txBody>
+        </p:sp>
+        <p:cxnSp>
+          <p:nvCxnSpPr>
+            <p:cNvPr id="8" name="Straight Arrow Connector 7">
+              <a:extLst>
+                <a:ext uri="{FF2B5EF4-FFF2-40B4-BE49-F238E27FC236}">
+                  <a16:creationId xmlns:a16="http://schemas.microsoft.com/office/drawing/2014/main" id="{736D1564-86BD-6DBF-1329-80F0DAE2ACD9}"/>
+                </a:ext>
+              </a:extLst>
+            </p:cNvPr>
+            <p:cNvCxnSpPr>
+              <a:cxnSpLocks/>
+              <a:stCxn id="7" idx="0"/>
+            </p:cNvCxnSpPr>
+            <p:nvPr/>
+          </p:nvCxnSpPr>
+          <p:spPr>
+            <a:xfrm flipV="1">
+              <a:off x="8377141" y="855320"/>
+              <a:ext cx="1073008" cy="466036"/>
+            </a:xfrm>
+            <a:prstGeom prst="straightConnector1">
+              <a:avLst/>
+            </a:prstGeom>
+            <a:ln w="12700">
+              <a:solidFill>
+                <a:schemeClr val="tx1"/>
+              </a:solidFill>
+              <a:tailEnd type="stealth" w="lg" len="lg"/>
+            </a:ln>
+          </p:spPr>
+          <p:style>
+            <a:lnRef idx="1">
+              <a:schemeClr val="accent1"/>
+            </a:lnRef>
+            <a:fillRef idx="0">
+              <a:schemeClr val="accent1"/>
+            </a:fillRef>
+            <a:effectRef idx="0">
+              <a:schemeClr val="accent1"/>
+            </a:effectRef>
+            <a:fontRef idx="minor">
+              <a:schemeClr val="tx1"/>
+            </a:fontRef>
+          </p:style>
+        </p:cxnSp>
+      </p:grpSp>
+    </p:spTree>
+    <p:extLst>
+      <p:ext uri="{BB962C8B-B14F-4D97-AF65-F5344CB8AC3E}">
+        <p14:creationId xmlns:p14="http://schemas.microsoft.com/office/powerpoint/2010/main" val="3058559457"/>
+      </p:ext>
+    </p:extLst>
+  </p:cSld>
+  <p:clrMapOvr>
+    <a:masterClrMapping/>
+  </p:clrMapOvr>
+  <p:timing>
+    <p:tnLst>
+      <p:par>
+        <p:cTn id="1" dur="indefinite" restart="never" nodeType="tmRoot">
+          <p:childTnLst>
+            <p:seq concurrent="1" nextAc="seek">
+              <p:cTn id="2" dur="indefinite" nodeType="mainSeq">
+                <p:childTnLst>
+                  <p:par>
+                    <p:cTn id="3" fill="hold">
+                      <p:stCondLst>
+                        <p:cond delay="indefinite"/>
+                      </p:stCondLst>
+                      <p:childTnLst>
+                        <p:par>
+                          <p:cTn id="4" fill="hold">
+                            <p:stCondLst>
+                              <p:cond delay="0"/>
+                            </p:stCondLst>
+                            <p:childTnLst>
+                              <p:par>
+                                <p:cTn id="5" presetID="1" presetClass="entr" presetSubtype="0" fill="hold" nodeType="clickEffect">
+                                  <p:stCondLst>
+                                    <p:cond delay="0"/>
+                                  </p:stCondLst>
+                                  <p:childTnLst>
+                                    <p:set>
+                                      <p:cBhvr>
+                                        <p:cTn id="6" dur="1" fill="hold">
+                                          <p:stCondLst>
+                                            <p:cond delay="0"/>
+                                          </p:stCondLst>
+                                        </p:cTn>
+                                        <p:tgtEl>
+                                          <p:spTgt spid="6"/>
+                                        </p:tgtEl>
+                                        <p:attrNameLst>
+                                          <p:attrName>style.visibility</p:attrName>
+                                        </p:attrNameLst>
+                                      </p:cBhvr>
+                                      <p:to>
+                                        <p:strVal val="visible"/>
+                                      </p:to>
+                                    </p:set>
+                                  </p:childTnLst>
+                                </p:cTn>
+                              </p:par>
+                            </p:childTnLst>
+                          </p:cTn>
+                        </p:par>
+                      </p:childTnLst>
+                    </p:cTn>
+                  </p:par>
+                </p:childTnLst>
+              </p:cTn>
+              <p:prevCondLst>
+                <p:cond evt="onPrev" delay="0">
+                  <p:tgtEl>
+                    <p:sldTgt/>
+                  </p:tgtEl>
+                </p:cond>
+              </p:prevCondLst>
+              <p:nextCondLst>
+                <p:cond evt="onNext" delay="0">
+                  <p:tgtEl>
+                    <p:sldTgt/>
+                  </p:tgtEl>
+                </p:cond>
+              </p:nextCondLst>
+            </p:seq>
+          </p:childTnLst>
+        </p:cTn>
+      </p:par>
+    </p:tnLst>
+  </p:timing>
+</p:sld>
+</file>
+
+<file path=ppt/slides/slide32.xml><?xml version="1.0" encoding="utf-8"?>
+<p:sld xmlns:a="http://schemas.openxmlformats.org/drawingml/2006/main" xmlns:r="http://schemas.openxmlformats.org/officeDocument/2006/relationships" xmlns:p="http://schemas.openxmlformats.org/presentationml/2006/main">
+  <p:cSld>
+    <p:spTree>
+      <p:nvGrpSpPr>
+        <p:cNvPr id="1" name=""/>
+        <p:cNvGrpSpPr/>
+        <p:nvPr/>
+      </p:nvGrpSpPr>
+      <p:grpSpPr>
+        <a:xfrm>
+          <a:off x="0" y="0"/>
+          <a:ext cx="0" cy="0"/>
+          <a:chOff x="0" y="0"/>
+          <a:chExt cx="0" cy="0"/>
+        </a:xfrm>
+      </p:grpSpPr>
+      <p:sp>
+        <p:nvSpPr>
+          <p:cNvPr id="2" name="Title 1">
+            <a:extLst>
+              <a:ext uri="{FF2B5EF4-FFF2-40B4-BE49-F238E27FC236}">
+                <a16:creationId xmlns:a16="http://schemas.microsoft.com/office/drawing/2014/main" id="{36A5A0E1-45EA-856B-F186-80EB71B598B0}"/>
+              </a:ext>
+            </a:extLst>
+          </p:cNvPr>
+          <p:cNvSpPr>
+            <a:spLocks noGrp="1"/>
+          </p:cNvSpPr>
+          <p:nvPr>
+            <p:ph type="title"/>
+          </p:nvPr>
+        </p:nvSpPr>
+        <p:spPr/>
+        <p:txBody>
+          <a:bodyPr/>
+          <a:lstStyle/>
+          <a:p>
+            <a:r>
+              <a:rPr lang="en-US" dirty="0"/>
+              <a:t>Delegation</a:t>
+            </a:r>
+            <a:endParaRPr lang="LID4096" dirty="0"/>
+          </a:p>
+        </p:txBody>
+      </p:sp>
+      <p:sp>
+        <p:nvSpPr>
+          <p:cNvPr id="3" name="Content Placeholder 2">
+            <a:extLst>
+              <a:ext uri="{FF2B5EF4-FFF2-40B4-BE49-F238E27FC236}">
+                <a16:creationId xmlns:a16="http://schemas.microsoft.com/office/drawing/2014/main" id="{F9983C2A-860A-1221-8F31-AF652A24B1D0}"/>
+              </a:ext>
+            </a:extLst>
+          </p:cNvPr>
+          <p:cNvSpPr>
+            <a:spLocks noGrp="1"/>
+          </p:cNvSpPr>
+          <p:nvPr>
+            <p:ph idx="1"/>
+          </p:nvPr>
+        </p:nvSpPr>
+        <p:spPr/>
+        <p:txBody>
+          <a:bodyPr/>
+          <a:lstStyle/>
+          <a:p>
+            <a:r>
+              <a:rPr lang="en-US" dirty="0" err="1">
+                <a:latin typeface="Courier New" panose="02070309020205020404" pitchFamily="49" charset="0"/>
+                <a:cs typeface="Courier New" panose="02070309020205020404" pitchFamily="49" charset="0"/>
+              </a:rPr>
+              <a:t>ColoredPoint</a:t>
+            </a:r>
+            <a:r>
+              <a:rPr lang="en-US" dirty="0"/>
+              <a:t> should act as </a:t>
+            </a:r>
+            <a:r>
+              <a:rPr lang="en-US" dirty="0">
+                <a:latin typeface="Courier New" panose="02070309020205020404" pitchFamily="49" charset="0"/>
+                <a:cs typeface="Courier New" panose="02070309020205020404" pitchFamily="49" charset="0"/>
+              </a:rPr>
+              <a:t>Point</a:t>
+            </a:r>
+          </a:p>
+          <a:p>
+            <a:pPr lvl="1"/>
+            <a:r>
+              <a:rPr lang="en-US" dirty="0" err="1">
+                <a:latin typeface="Courier New" panose="02070309020205020404" pitchFamily="49" charset="0"/>
+                <a:cs typeface="Courier New" panose="02070309020205020404" pitchFamily="49" charset="0"/>
+              </a:rPr>
+              <a:t>get_x_coord</a:t>
+            </a:r>
+            <a:r>
+              <a:rPr lang="en-US" dirty="0"/>
+              <a:t>/</a:t>
+            </a:r>
+            <a:r>
+              <a:rPr lang="en-US" dirty="0" err="1">
+                <a:latin typeface="Courier New" panose="02070309020205020404" pitchFamily="49" charset="0"/>
+                <a:cs typeface="Courier New" panose="02070309020205020404" pitchFamily="49" charset="0"/>
+              </a:rPr>
+              <a:t>set_x_coord</a:t>
+            </a:r>
+            <a:r>
+              <a:rPr lang="en-US" dirty="0">
+                <a:latin typeface="Courier New" panose="02070309020205020404" pitchFamily="49" charset="0"/>
+                <a:cs typeface="Courier New" panose="02070309020205020404" pitchFamily="49" charset="0"/>
+              </a:rPr>
+              <a:t>!</a:t>
+            </a:r>
+          </a:p>
+          <a:p>
+            <a:pPr lvl="1"/>
+            <a:r>
+              <a:rPr lang="en-US" dirty="0">
+                <a:sym typeface="Symbol" panose="05050102010706020507" pitchFamily="18" charset="2"/>
+              </a:rPr>
+              <a:t></a:t>
+            </a:r>
+          </a:p>
+          <a:p>
+            <a:r>
+              <a:rPr lang="en-US" dirty="0">
+                <a:sym typeface="Symbol" panose="05050102010706020507" pitchFamily="18" charset="2"/>
+              </a:rPr>
+              <a:t>Reimplement functions?</a:t>
+            </a:r>
+          </a:p>
+          <a:p>
+            <a:r>
+              <a:rPr lang="en-US" dirty="0">
+                <a:sym typeface="Symbol" panose="05050102010706020507" pitchFamily="18" charset="2"/>
+              </a:rPr>
+              <a:t>Delegate</a:t>
+            </a:r>
+            <a:endParaRPr lang="LID4096" dirty="0"/>
+          </a:p>
+        </p:txBody>
+      </p:sp>
+      <p:sp>
+        <p:nvSpPr>
+          <p:cNvPr id="4" name="Slide Number Placeholder 3">
+            <a:extLst>
+              <a:ext uri="{FF2B5EF4-FFF2-40B4-BE49-F238E27FC236}">
+                <a16:creationId xmlns:a16="http://schemas.microsoft.com/office/drawing/2014/main" id="{1C624E28-70F9-BA11-E3CE-2741358B02D1}"/>
+              </a:ext>
+            </a:extLst>
+          </p:cNvPr>
+          <p:cNvSpPr>
+            <a:spLocks noGrp="1"/>
+          </p:cNvSpPr>
+          <p:nvPr>
+            <p:ph type="sldNum" sz="quarter" idx="12"/>
+          </p:nvPr>
+        </p:nvSpPr>
+        <p:spPr/>
+        <p:txBody>
+          <a:bodyPr/>
+          <a:lstStyle/>
+          <a:p>
+            <a:fld id="{78F7A1EC-23D1-431D-8C93-9C4ED5D4A04D}" type="slidenum">
+              <a:rPr lang="en-US" smtClean="0"/>
+              <a:t>32</a:t>
+            </a:fld>
+            <a:endParaRPr lang="en-US"/>
+          </a:p>
+        </p:txBody>
+      </p:sp>
+      <p:sp>
+        <p:nvSpPr>
+          <p:cNvPr id="5" name="TextBox 4">
+            <a:extLst>
+              <a:ext uri="{FF2B5EF4-FFF2-40B4-BE49-F238E27FC236}">
+                <a16:creationId xmlns:a16="http://schemas.microsoft.com/office/drawing/2014/main" id="{6DFD0576-4772-2861-7BF6-0653E9851682}"/>
+              </a:ext>
+            </a:extLst>
+          </p:cNvPr>
+          <p:cNvSpPr txBox="1"/>
+          <p:nvPr/>
+        </p:nvSpPr>
+        <p:spPr>
+          <a:xfrm>
+            <a:off x="1458090" y="4211661"/>
+            <a:ext cx="9816046" cy="1477328"/>
+          </a:xfrm>
+          <a:prstGeom prst="rect">
+            <a:avLst/>
+          </a:prstGeom>
+          <a:solidFill>
+            <a:schemeClr val="bg1">
+              <a:lumMod val="85000"/>
+            </a:schemeClr>
+          </a:solidFill>
+        </p:spPr>
+        <p:txBody>
+          <a:bodyPr wrap="square" rtlCol="0">
+            <a:spAutoFit/>
+          </a:bodyPr>
+          <a:lstStyle/>
+          <a:p>
+            <a:r>
+              <a:rPr lang="en-US" dirty="0">
+                <a:latin typeface="Consolas" panose="020B0609020204030204" pitchFamily="49" charset="0"/>
+              </a:rPr>
+              <a:t>using Lazy</a:t>
+            </a:r>
+          </a:p>
+          <a:p>
+            <a:endParaRPr lang="en-US" dirty="0">
+              <a:latin typeface="Consolas" panose="020B0609020204030204" pitchFamily="49" charset="0"/>
+            </a:endParaRPr>
+          </a:p>
+          <a:p>
+            <a:r>
+              <a:rPr lang="en-US" dirty="0">
+                <a:latin typeface="Consolas" panose="020B0609020204030204" pitchFamily="49" charset="0"/>
+              </a:rPr>
+              <a:t>@forward </a:t>
+            </a:r>
+            <a:r>
+              <a:rPr lang="en-US" dirty="0" err="1">
+                <a:latin typeface="Consolas" panose="020B0609020204030204" pitchFamily="49" charset="0"/>
+              </a:rPr>
+              <a:t>ColoredPoint.coords</a:t>
+            </a:r>
+            <a:r>
+              <a:rPr lang="en-US" dirty="0">
+                <a:latin typeface="Consolas" panose="020B0609020204030204" pitchFamily="49" charset="0"/>
+              </a:rPr>
+              <a:t> </a:t>
+            </a:r>
+            <a:r>
+              <a:rPr lang="en-US" dirty="0" err="1">
+                <a:latin typeface="Consolas" panose="020B0609020204030204" pitchFamily="49" charset="0"/>
+              </a:rPr>
+              <a:t>get_x_coord</a:t>
+            </a:r>
+            <a:endParaRPr lang="en-US" dirty="0">
+              <a:latin typeface="Consolas" panose="020B0609020204030204" pitchFamily="49" charset="0"/>
+            </a:endParaRPr>
+          </a:p>
+          <a:p>
+            <a:r>
+              <a:rPr lang="en-US" dirty="0">
+                <a:latin typeface="Consolas" panose="020B0609020204030204" pitchFamily="49" charset="0"/>
+              </a:rPr>
+              <a:t>@forward </a:t>
+            </a:r>
+            <a:r>
+              <a:rPr lang="en-US" dirty="0" err="1">
+                <a:latin typeface="Consolas" panose="020B0609020204030204" pitchFamily="49" charset="0"/>
+              </a:rPr>
+              <a:t>ColoredPoint.coords</a:t>
+            </a:r>
+            <a:r>
+              <a:rPr lang="en-US" dirty="0">
+                <a:latin typeface="Consolas" panose="020B0609020204030204" pitchFamily="49" charset="0"/>
+              </a:rPr>
+              <a:t> </a:t>
+            </a:r>
+            <a:r>
+              <a:rPr lang="en-US" dirty="0" err="1">
+                <a:latin typeface="Consolas" panose="020B0609020204030204" pitchFamily="49" charset="0"/>
+              </a:rPr>
+              <a:t>set_x_coord</a:t>
+            </a:r>
+            <a:r>
+              <a:rPr lang="en-US" dirty="0">
+                <a:latin typeface="Consolas" panose="020B0609020204030204" pitchFamily="49" charset="0"/>
+              </a:rPr>
+              <a:t>!</a:t>
+            </a:r>
+          </a:p>
+          <a:p>
+            <a:r>
+              <a:rPr lang="en-US" dirty="0">
+                <a:latin typeface="Consolas" panose="020B0609020204030204" pitchFamily="49" charset="0"/>
+                <a:sym typeface="Symbol" panose="05050102010706020507" pitchFamily="18" charset="2"/>
+              </a:rPr>
+              <a:t></a:t>
+            </a:r>
+            <a:endParaRPr lang="en-US" dirty="0">
+              <a:latin typeface="Consolas" panose="020B0609020204030204" pitchFamily="49" charset="0"/>
+            </a:endParaRPr>
+          </a:p>
+        </p:txBody>
+      </p:sp>
+    </p:spTree>
+    <p:extLst>
+      <p:ext uri="{BB962C8B-B14F-4D97-AF65-F5344CB8AC3E}">
+        <p14:creationId xmlns:p14="http://schemas.microsoft.com/office/powerpoint/2010/main" val="3706691726"/>
+      </p:ext>
+    </p:extLst>
+  </p:cSld>
+  <p:clrMapOvr>
+    <a:masterClrMapping/>
+  </p:clrMapOvr>
+</p:sld>
+</file>
+
+<file path=ppt/slides/slide33.xml><?xml version="1.0" encoding="utf-8"?>
+<p:sld xmlns:a="http://schemas.openxmlformats.org/drawingml/2006/main" xmlns:r="http://schemas.openxmlformats.org/officeDocument/2006/relationships" xmlns:p="http://schemas.openxmlformats.org/presentationml/2006/main">
+  <p:cSld>
+    <p:spTree>
+      <p:nvGrpSpPr>
+        <p:cNvPr id="1" name=""/>
+        <p:cNvGrpSpPr/>
+        <p:nvPr/>
+      </p:nvGrpSpPr>
+      <p:grpSpPr>
+        <a:xfrm>
+          <a:off x="0" y="0"/>
+          <a:ext cx="0" cy="0"/>
+          <a:chOff x="0" y="0"/>
+          <a:chExt cx="0" cy="0"/>
+        </a:xfrm>
+      </p:grpSpPr>
+      <p:sp>
+        <p:nvSpPr>
+          <p:cNvPr id="2" name="Title 1">
+            <a:extLst>
+              <a:ext uri="{FF2B5EF4-FFF2-40B4-BE49-F238E27FC236}">
                 <a16:creationId xmlns:a16="http://schemas.microsoft.com/office/drawing/2014/main" id="{E7A16532-2CE8-4AD7-B819-2EC8F46C855E}"/>
               </a:ext>
             </a:extLst>
@@ -21891,7 +22648,7 @@
           <a:p>
             <a:fld id="{78F7A1EC-23D1-431D-8C93-9C4ED5D4A04D}" type="slidenum">
               <a:rPr lang="en-US" smtClean="0"/>
-              <a:t>31</a:t>
+              <a:t>33</a:t>
             </a:fld>
             <a:endParaRPr lang="en-US"/>
           </a:p>
@@ -22342,7 +23099,7 @@
 </p:sld>
 </file>
 
-<file path=ppt/slides/slide32.xml><?xml version="1.0" encoding="utf-8"?>
+<file path=ppt/slides/slide34.xml><?xml version="1.0" encoding="utf-8"?>
 <p:sld xmlns:a="http://schemas.openxmlformats.org/drawingml/2006/main" xmlns:r="http://schemas.openxmlformats.org/officeDocument/2006/relationships" xmlns:p="http://schemas.openxmlformats.org/presentationml/2006/main">
   <p:cSld>
     <p:spTree>
@@ -22456,7 +23213,7 @@
           <a:p>
             <a:fld id="{78F7A1EC-23D1-431D-8C93-9C4ED5D4A04D}" type="slidenum">
               <a:rPr lang="en-US" smtClean="0"/>
-              <a:t>32</a:t>
+              <a:t>34</a:t>
             </a:fld>
             <a:endParaRPr lang="en-US"/>
           </a:p>
@@ -24009,7 +24766,7 @@
 </p:sld>
 </file>
 
-<file path=ppt/slides/slide33.xml><?xml version="1.0" encoding="utf-8"?>
+<file path=ppt/slides/slide35.xml><?xml version="1.0" encoding="utf-8"?>
 <p:sld xmlns:a="http://schemas.openxmlformats.org/drawingml/2006/main" xmlns:r="http://schemas.openxmlformats.org/officeDocument/2006/relationships" xmlns:p="http://schemas.openxmlformats.org/presentationml/2006/main">
   <p:cSld>
     <p:spTree>
@@ -24132,7 +24889,7 @@
           <a:p>
             <a:fld id="{78F7A1EC-23D1-431D-8C93-9C4ED5D4A04D}" type="slidenum">
               <a:rPr lang="en-US" smtClean="0"/>
-              <a:t>33</a:t>
+              <a:t>35</a:t>
             </a:fld>
             <a:endParaRPr lang="en-US"/>
           </a:p>
@@ -24596,7 +25353,7 @@
 </p:sld>
 </file>
 
-<file path=ppt/slides/slide34.xml><?xml version="1.0" encoding="utf-8"?>
+<file path=ppt/slides/slide36.xml><?xml version="1.0" encoding="utf-8"?>
 <p:sld xmlns:a="http://schemas.openxmlformats.org/drawingml/2006/main" xmlns:r="http://schemas.openxmlformats.org/officeDocument/2006/relationships" xmlns:p="http://schemas.openxmlformats.org/presentationml/2006/main">
   <p:cSld>
     <p:spTree>
@@ -24689,7 +25446,7 @@
           <a:p>
             <a:fld id="{78F7A1EC-23D1-431D-8C93-9C4ED5D4A04D}" type="slidenum">
               <a:rPr lang="en-US" smtClean="0"/>
-              <a:t>34</a:t>
+              <a:t>36</a:t>
             </a:fld>
             <a:endParaRPr lang="en-US"/>
           </a:p>
@@ -24708,7 +25465,7 @@
 </p:sld>
 </file>
 
-<file path=ppt/slides/slide35.xml><?xml version="1.0" encoding="utf-8"?>
+<file path=ppt/slides/slide37.xml><?xml version="1.0" encoding="utf-8"?>
 <p:sld xmlns:a="http://schemas.openxmlformats.org/drawingml/2006/main" xmlns:r="http://schemas.openxmlformats.org/officeDocument/2006/relationships" xmlns:p="http://schemas.openxmlformats.org/presentationml/2006/main">
   <p:cSld>
     <p:spTree>
@@ -24838,7 +25595,7 @@
           <a:p>
             <a:fld id="{78F7A1EC-23D1-431D-8C93-9C4ED5D4A04D}" type="slidenum">
               <a:rPr lang="en-US" smtClean="0"/>
-              <a:t>35</a:t>
+              <a:t>37</a:t>
             </a:fld>
             <a:endParaRPr lang="en-US"/>
           </a:p>
@@ -25574,7 +26331,7 @@
 </p:sld>
 </file>
 
-<file path=ppt/slides/slide36.xml><?xml version="1.0" encoding="utf-8"?>
+<file path=ppt/slides/slide38.xml><?xml version="1.0" encoding="utf-8"?>
 <p:sld xmlns:a="http://schemas.openxmlformats.org/drawingml/2006/main" xmlns:r="http://schemas.openxmlformats.org/officeDocument/2006/relationships" xmlns:p="http://schemas.openxmlformats.org/presentationml/2006/main">
   <p:cSld>
     <p:spTree>
@@ -25642,7 +26399,7 @@
           <a:p>
             <a:fld id="{78F7A1EC-23D1-431D-8C93-9C4ED5D4A04D}" type="slidenum">
               <a:rPr lang="en-US" smtClean="0"/>
-              <a:t>36</a:t>
+              <a:t>38</a:t>
             </a:fld>
             <a:endParaRPr lang="en-US"/>
           </a:p>
@@ -25905,7 +26662,7 @@
 </p:sld>
 </file>
 
-<file path=ppt/slides/slide37.xml><?xml version="1.0" encoding="utf-8"?>
+<file path=ppt/slides/slide39.xml><?xml version="1.0" encoding="utf-8"?>
 <p:sld xmlns:a="http://schemas.openxmlformats.org/drawingml/2006/main" xmlns:r="http://schemas.openxmlformats.org/officeDocument/2006/relationships" xmlns:p="http://schemas.openxmlformats.org/presentationml/2006/main">
   <p:cSld>
     <p:spTree>
@@ -26037,7 +26794,7 @@
           <a:p>
             <a:fld id="{78F7A1EC-23D1-431D-8C93-9C4ED5D4A04D}" type="slidenum">
               <a:rPr lang="en-US" smtClean="0"/>
-              <a:t>37</a:t>
+              <a:t>39</a:t>
             </a:fld>
             <a:endParaRPr lang="en-US"/>
           </a:p>
@@ -26234,1637 +26991,6 @@
     </p:tnLst>
     <p:bldLst>
       <p:bldP spid="4" grpId="0" uiExpand="1" build="p"/>
-    </p:bldLst>
-  </p:timing>
-</p:sld>
-</file>
-
-<file path=ppt/slides/slide38.xml><?xml version="1.0" encoding="utf-8"?>
-<p:sld xmlns:a="http://schemas.openxmlformats.org/drawingml/2006/main" xmlns:r="http://schemas.openxmlformats.org/officeDocument/2006/relationships" xmlns:p="http://schemas.openxmlformats.org/presentationml/2006/main">
-  <p:cSld>
-    <p:spTree>
-      <p:nvGrpSpPr>
-        <p:cNvPr id="1" name=""/>
-        <p:cNvGrpSpPr/>
-        <p:nvPr/>
-      </p:nvGrpSpPr>
-      <p:grpSpPr>
-        <a:xfrm>
-          <a:off x="0" y="0"/>
-          <a:ext cx="0" cy="0"/>
-          <a:chOff x="0" y="0"/>
-          <a:chExt cx="0" cy="0"/>
-        </a:xfrm>
-      </p:grpSpPr>
-      <p:sp>
-        <p:nvSpPr>
-          <p:cNvPr id="2" name="Title 1">
-            <a:extLst>
-              <a:ext uri="{FF2B5EF4-FFF2-40B4-BE49-F238E27FC236}">
-                <a16:creationId xmlns:a16="http://schemas.microsoft.com/office/drawing/2014/main" id="{BD3F676C-8E61-475A-B380-3862D8DBCE89}"/>
-              </a:ext>
-            </a:extLst>
-          </p:cNvPr>
-          <p:cNvSpPr>
-            <a:spLocks noGrp="1"/>
-          </p:cNvSpPr>
-          <p:nvPr>
-            <p:ph type="title"/>
-          </p:nvPr>
-        </p:nvSpPr>
-        <p:spPr/>
-        <p:txBody>
-          <a:bodyPr/>
-          <a:lstStyle/>
-          <a:p>
-            <a:r>
-              <a:rPr lang="en-US" dirty="0"/>
-              <a:t>Code organization</a:t>
-            </a:r>
-          </a:p>
-        </p:txBody>
-      </p:sp>
-      <p:sp>
-        <p:nvSpPr>
-          <p:cNvPr id="3" name="Text Placeholder 2">
-            <a:extLst>
-              <a:ext uri="{FF2B5EF4-FFF2-40B4-BE49-F238E27FC236}">
-                <a16:creationId xmlns:a16="http://schemas.microsoft.com/office/drawing/2014/main" id="{A6A8E519-B664-45C3-9598-AAEDCCBF1B03}"/>
-              </a:ext>
-            </a:extLst>
-          </p:cNvPr>
-          <p:cNvSpPr>
-            <a:spLocks noGrp="1"/>
-          </p:cNvSpPr>
-          <p:nvPr>
-            <p:ph type="body" idx="1"/>
-          </p:nvPr>
-        </p:nvSpPr>
-        <p:spPr/>
-        <p:txBody>
-          <a:bodyPr/>
-          <a:lstStyle/>
-          <a:p>
-            <a:endParaRPr lang="en-US"/>
-          </a:p>
-        </p:txBody>
-      </p:sp>
-      <p:sp>
-        <p:nvSpPr>
-          <p:cNvPr id="4" name="Slide Number Placeholder 3">
-            <a:extLst>
-              <a:ext uri="{FF2B5EF4-FFF2-40B4-BE49-F238E27FC236}">
-                <a16:creationId xmlns:a16="http://schemas.microsoft.com/office/drawing/2014/main" id="{E83AE572-1A4F-44A3-9F9F-2E1F4C95A76D}"/>
-              </a:ext>
-            </a:extLst>
-          </p:cNvPr>
-          <p:cNvSpPr>
-            <a:spLocks noGrp="1"/>
-          </p:cNvSpPr>
-          <p:nvPr>
-            <p:ph type="sldNum" sz="quarter" idx="12"/>
-          </p:nvPr>
-        </p:nvSpPr>
-        <p:spPr/>
-        <p:txBody>
-          <a:bodyPr/>
-          <a:lstStyle/>
-          <a:p>
-            <a:fld id="{78F7A1EC-23D1-431D-8C93-9C4ED5D4A04D}" type="slidenum">
-              <a:rPr lang="en-US" smtClean="0"/>
-              <a:t>38</a:t>
-            </a:fld>
-            <a:endParaRPr lang="en-US"/>
-          </a:p>
-        </p:txBody>
-      </p:sp>
-    </p:spTree>
-    <p:extLst>
-      <p:ext uri="{BB962C8B-B14F-4D97-AF65-F5344CB8AC3E}">
-        <p14:creationId xmlns:p14="http://schemas.microsoft.com/office/powerpoint/2010/main" val="560763537"/>
-      </p:ext>
-    </p:extLst>
-  </p:cSld>
-  <p:clrMapOvr>
-    <a:masterClrMapping/>
-  </p:clrMapOvr>
-</p:sld>
-</file>
-
-<file path=ppt/slides/slide39.xml><?xml version="1.0" encoding="utf-8"?>
-<p:sld xmlns:a="http://schemas.openxmlformats.org/drawingml/2006/main" xmlns:r="http://schemas.openxmlformats.org/officeDocument/2006/relationships" xmlns:p="http://schemas.openxmlformats.org/presentationml/2006/main">
-  <p:cSld>
-    <p:spTree>
-      <p:nvGrpSpPr>
-        <p:cNvPr id="1" name=""/>
-        <p:cNvGrpSpPr/>
-        <p:nvPr/>
-      </p:nvGrpSpPr>
-      <p:grpSpPr>
-        <a:xfrm>
-          <a:off x="0" y="0"/>
-          <a:ext cx="0" cy="0"/>
-          <a:chOff x="0" y="0"/>
-          <a:chExt cx="0" cy="0"/>
-        </a:xfrm>
-      </p:grpSpPr>
-      <p:sp>
-        <p:nvSpPr>
-          <p:cNvPr id="2" name="Title 1">
-            <a:extLst>
-              <a:ext uri="{FF2B5EF4-FFF2-40B4-BE49-F238E27FC236}">
-                <a16:creationId xmlns:a16="http://schemas.microsoft.com/office/drawing/2014/main" id="{291CE4E6-CAD2-46CD-AC0C-36218848C9EF}"/>
-              </a:ext>
-            </a:extLst>
-          </p:cNvPr>
-          <p:cNvSpPr>
-            <a:spLocks noGrp="1"/>
-          </p:cNvSpPr>
-          <p:nvPr>
-            <p:ph type="title"/>
-          </p:nvPr>
-        </p:nvSpPr>
-        <p:spPr/>
-        <p:txBody>
-          <a:bodyPr/>
-          <a:lstStyle/>
-          <a:p>
-            <a:r>
-              <a:rPr lang="en-US" dirty="0"/>
-              <a:t>Modules</a:t>
-            </a:r>
-          </a:p>
-        </p:txBody>
-      </p:sp>
-      <p:sp>
-        <p:nvSpPr>
-          <p:cNvPr id="3" name="Content Placeholder 2">
-            <a:extLst>
-              <a:ext uri="{FF2B5EF4-FFF2-40B4-BE49-F238E27FC236}">
-                <a16:creationId xmlns:a16="http://schemas.microsoft.com/office/drawing/2014/main" id="{5644616E-30B7-47E4-A033-60C1A8006164}"/>
-              </a:ext>
-            </a:extLst>
-          </p:cNvPr>
-          <p:cNvSpPr>
-            <a:spLocks noGrp="1"/>
-          </p:cNvSpPr>
-          <p:nvPr>
-            <p:ph idx="1"/>
-          </p:nvPr>
-        </p:nvSpPr>
-        <p:spPr/>
-        <p:txBody>
-          <a:bodyPr/>
-          <a:lstStyle/>
-          <a:p>
-            <a:r>
-              <a:rPr lang="en-US" dirty="0"/>
-              <a:t>Modules are namespaces</a:t>
-            </a:r>
-          </a:p>
-        </p:txBody>
-      </p:sp>
-      <p:sp>
-        <p:nvSpPr>
-          <p:cNvPr id="4" name="Slide Number Placeholder 3">
-            <a:extLst>
-              <a:ext uri="{FF2B5EF4-FFF2-40B4-BE49-F238E27FC236}">
-                <a16:creationId xmlns:a16="http://schemas.microsoft.com/office/drawing/2014/main" id="{F7373C50-4941-464C-BFFC-BE5DE564BB52}"/>
-              </a:ext>
-            </a:extLst>
-          </p:cNvPr>
-          <p:cNvSpPr>
-            <a:spLocks noGrp="1"/>
-          </p:cNvSpPr>
-          <p:nvPr>
-            <p:ph type="sldNum" sz="quarter" idx="12"/>
-          </p:nvPr>
-        </p:nvSpPr>
-        <p:spPr/>
-        <p:txBody>
-          <a:bodyPr/>
-          <a:lstStyle/>
-          <a:p>
-            <a:fld id="{78F7A1EC-23D1-431D-8C93-9C4ED5D4A04D}" type="slidenum">
-              <a:rPr lang="en-US" smtClean="0"/>
-              <a:t>39</a:t>
-            </a:fld>
-            <a:endParaRPr lang="en-US"/>
-          </a:p>
-        </p:txBody>
-      </p:sp>
-      <p:grpSp>
-        <p:nvGrpSpPr>
-          <p:cNvPr id="8" name="Group 7">
-            <a:extLst>
-              <a:ext uri="{FF2B5EF4-FFF2-40B4-BE49-F238E27FC236}">
-                <a16:creationId xmlns:a16="http://schemas.microsoft.com/office/drawing/2014/main" id="{D663F298-65AC-4AD7-962E-B9C181C42FBB}"/>
-              </a:ext>
-            </a:extLst>
-          </p:cNvPr>
-          <p:cNvGrpSpPr/>
-          <p:nvPr/>
-        </p:nvGrpSpPr>
-        <p:grpSpPr>
-          <a:xfrm>
-            <a:off x="838201" y="2455198"/>
-            <a:ext cx="3025346" cy="3416320"/>
-            <a:chOff x="838201" y="2455198"/>
-            <a:chExt cx="3025346" cy="3416320"/>
-          </a:xfrm>
-        </p:grpSpPr>
-        <p:sp>
-          <p:nvSpPr>
-            <p:cNvPr id="5" name="TextBox 4">
-              <a:extLst>
-                <a:ext uri="{FF2B5EF4-FFF2-40B4-BE49-F238E27FC236}">
-                  <a16:creationId xmlns:a16="http://schemas.microsoft.com/office/drawing/2014/main" id="{49507C89-9635-4240-8B72-2785A6E7DA92}"/>
-                </a:ext>
-              </a:extLst>
-            </p:cNvPr>
-            <p:cNvSpPr txBox="1"/>
-            <p:nvPr/>
-          </p:nvSpPr>
-          <p:spPr>
-            <a:xfrm>
-              <a:off x="838201" y="2455198"/>
-              <a:ext cx="3025346" cy="3416320"/>
-            </a:xfrm>
-            <a:prstGeom prst="rect">
-              <a:avLst/>
-            </a:prstGeom>
-            <a:solidFill>
-              <a:schemeClr val="bg1">
-                <a:lumMod val="85000"/>
-              </a:schemeClr>
-            </a:solidFill>
-          </p:spPr>
-          <p:txBody>
-            <a:bodyPr wrap="square" rtlCol="0">
-              <a:spAutoFit/>
-            </a:bodyPr>
-            <a:lstStyle/>
-            <a:p>
-              <a:r>
-                <a:rPr lang="en-US" dirty="0">
-                  <a:latin typeface="Consolas" panose="020B0609020204030204" pitchFamily="49" charset="0"/>
-                </a:rPr>
-                <a:t>module </a:t>
-              </a:r>
-              <a:r>
-                <a:rPr lang="en-US" dirty="0" err="1">
-                  <a:latin typeface="Consolas" panose="020B0609020204030204" pitchFamily="49" charset="0"/>
-                </a:rPr>
-                <a:t>MyFunctions</a:t>
-              </a:r>
-              <a:endParaRPr lang="en-US" dirty="0">
-                <a:latin typeface="Consolas" panose="020B0609020204030204" pitchFamily="49" charset="0"/>
-              </a:endParaRPr>
-            </a:p>
-            <a:p>
-              <a:r>
-                <a:rPr lang="en-US" dirty="0">
-                  <a:latin typeface="Consolas" panose="020B0609020204030204" pitchFamily="49" charset="0"/>
-                </a:rPr>
-                <a:t>  export </a:t>
-              </a:r>
-              <a:r>
-                <a:rPr lang="en-US" dirty="0">
-                  <a:solidFill>
-                    <a:srgbClr val="00B050"/>
-                  </a:solidFill>
-                  <a:latin typeface="Consolas" panose="020B0609020204030204" pitchFamily="49" charset="0"/>
-                </a:rPr>
-                <a:t>fact</a:t>
-              </a:r>
-            </a:p>
-            <a:p>
-              <a:endParaRPr lang="en-US" dirty="0">
-                <a:latin typeface="Consolas" panose="020B0609020204030204" pitchFamily="49" charset="0"/>
-              </a:endParaRPr>
-            </a:p>
-            <a:p>
-              <a:r>
-                <a:rPr lang="en-US" dirty="0">
-                  <a:latin typeface="Consolas" panose="020B0609020204030204" pitchFamily="49" charset="0"/>
-                </a:rPr>
-                <a:t>  function </a:t>
-              </a:r>
-              <a:r>
-                <a:rPr lang="en-US" dirty="0">
-                  <a:solidFill>
-                    <a:srgbClr val="00B050"/>
-                  </a:solidFill>
-                  <a:latin typeface="Consolas" panose="020B0609020204030204" pitchFamily="49" charset="0"/>
-                </a:rPr>
-                <a:t>fact</a:t>
-              </a:r>
-              <a:r>
-                <a:rPr lang="en-US" dirty="0">
-                  <a:latin typeface="Consolas" panose="020B0609020204030204" pitchFamily="49" charset="0"/>
-                </a:rPr>
-                <a:t>(n)</a:t>
-              </a:r>
-            </a:p>
-            <a:p>
-              <a:r>
-                <a:rPr lang="en-US" dirty="0">
-                  <a:latin typeface="Consolas" panose="020B0609020204030204" pitchFamily="49" charset="0"/>
-                </a:rPr>
-                <a:t>    …</a:t>
-              </a:r>
-            </a:p>
-            <a:p>
-              <a:r>
-                <a:rPr lang="en-US" dirty="0">
-                  <a:latin typeface="Consolas" panose="020B0609020204030204" pitchFamily="49" charset="0"/>
-                </a:rPr>
-                <a:t>  end</a:t>
-              </a:r>
-            </a:p>
-            <a:p>
-              <a:endParaRPr lang="en-US" dirty="0">
-                <a:latin typeface="Consolas" panose="020B0609020204030204" pitchFamily="49" charset="0"/>
-              </a:endParaRPr>
-            </a:p>
-            <a:p>
-              <a:r>
-                <a:rPr lang="en-US" dirty="0">
-                  <a:latin typeface="Consolas" panose="020B0609020204030204" pitchFamily="49" charset="0"/>
-                </a:rPr>
-                <a:t>  function </a:t>
-              </a:r>
-              <a:r>
-                <a:rPr lang="en-US" b="1" dirty="0" err="1">
-                  <a:solidFill>
-                    <a:srgbClr val="0070C0"/>
-                  </a:solidFill>
-                  <a:latin typeface="Consolas" panose="020B0609020204030204" pitchFamily="49" charset="0"/>
-                </a:rPr>
-                <a:t>gcd</a:t>
-              </a:r>
-              <a:r>
-                <a:rPr lang="en-US" dirty="0">
-                  <a:latin typeface="Consolas" panose="020B0609020204030204" pitchFamily="49" charset="0"/>
-                </a:rPr>
-                <a:t>(a, b)</a:t>
-              </a:r>
-            </a:p>
-            <a:p>
-              <a:r>
-                <a:rPr lang="en-US" dirty="0">
-                  <a:latin typeface="Consolas" panose="020B0609020204030204" pitchFamily="49" charset="0"/>
-                </a:rPr>
-                <a:t>    …</a:t>
-              </a:r>
-            </a:p>
-            <a:p>
-              <a:r>
-                <a:rPr lang="en-US" dirty="0">
-                  <a:latin typeface="Consolas" panose="020B0609020204030204" pitchFamily="49" charset="0"/>
-                </a:rPr>
-                <a:t>  end</a:t>
-              </a:r>
-            </a:p>
-            <a:p>
-              <a:endParaRPr lang="en-US" dirty="0">
-                <a:latin typeface="Consolas" panose="020B0609020204030204" pitchFamily="49" charset="0"/>
-              </a:endParaRPr>
-            </a:p>
-            <a:p>
-              <a:r>
-                <a:rPr lang="en-US" dirty="0">
-                  <a:latin typeface="Consolas" panose="020B0609020204030204" pitchFamily="49" charset="0"/>
-                </a:rPr>
-                <a:t>end</a:t>
-              </a:r>
-            </a:p>
-          </p:txBody>
-        </p:sp>
-        <p:sp>
-          <p:nvSpPr>
-            <p:cNvPr id="7" name="TextBox 6">
-              <a:extLst>
-                <a:ext uri="{FF2B5EF4-FFF2-40B4-BE49-F238E27FC236}">
-                  <a16:creationId xmlns:a16="http://schemas.microsoft.com/office/drawing/2014/main" id="{7BFEAC12-832E-4A6C-8684-CAAC907B0A2D}"/>
-                </a:ext>
-              </a:extLst>
-            </p:cNvPr>
-            <p:cNvSpPr txBox="1"/>
-            <p:nvPr/>
-          </p:nvSpPr>
-          <p:spPr>
-            <a:xfrm>
-              <a:off x="2842114" y="5609908"/>
-              <a:ext cx="1021433" cy="261610"/>
-            </a:xfrm>
-            <a:prstGeom prst="rect">
-              <a:avLst/>
-            </a:prstGeom>
-            <a:solidFill>
-              <a:schemeClr val="bg1"/>
-            </a:solidFill>
-            <a:ln>
-              <a:solidFill>
-                <a:schemeClr val="tx1"/>
-              </a:solidFill>
-            </a:ln>
-          </p:spPr>
-          <p:txBody>
-            <a:bodyPr wrap="none" rtlCol="0">
-              <a:spAutoFit/>
-            </a:bodyPr>
-            <a:lstStyle/>
-            <a:p>
-              <a:r>
-                <a:rPr lang="en-US" sz="1100" dirty="0" err="1"/>
-                <a:t>MyFunctions.jl</a:t>
-              </a:r>
-              <a:endParaRPr lang="en-US" sz="1100" dirty="0"/>
-            </a:p>
-          </p:txBody>
-        </p:sp>
-      </p:grpSp>
-      <p:grpSp>
-        <p:nvGrpSpPr>
-          <p:cNvPr id="11" name="Group 10">
-            <a:extLst>
-              <a:ext uri="{FF2B5EF4-FFF2-40B4-BE49-F238E27FC236}">
-                <a16:creationId xmlns:a16="http://schemas.microsoft.com/office/drawing/2014/main" id="{89549B4D-1E15-4A58-9D30-D56C240E9897}"/>
-              </a:ext>
-            </a:extLst>
-          </p:cNvPr>
-          <p:cNvGrpSpPr/>
-          <p:nvPr/>
-        </p:nvGrpSpPr>
-        <p:grpSpPr>
-          <a:xfrm>
-            <a:off x="5142470" y="2455198"/>
-            <a:ext cx="4306329" cy="1754326"/>
-            <a:chOff x="5142470" y="2455198"/>
-            <a:chExt cx="4306329" cy="1754326"/>
-          </a:xfrm>
-        </p:grpSpPr>
-        <p:sp>
-          <p:nvSpPr>
-            <p:cNvPr id="6" name="TextBox 5">
-              <a:extLst>
-                <a:ext uri="{FF2B5EF4-FFF2-40B4-BE49-F238E27FC236}">
-                  <a16:creationId xmlns:a16="http://schemas.microsoft.com/office/drawing/2014/main" id="{1BB28F42-1417-419E-8AD4-CDBDC4E67B9F}"/>
-                </a:ext>
-              </a:extLst>
-            </p:cNvPr>
-            <p:cNvSpPr txBox="1"/>
-            <p:nvPr/>
-          </p:nvSpPr>
-          <p:spPr>
-            <a:xfrm>
-              <a:off x="5142470" y="2455198"/>
-              <a:ext cx="4306329" cy="1754326"/>
-            </a:xfrm>
-            <a:prstGeom prst="rect">
-              <a:avLst/>
-            </a:prstGeom>
-            <a:solidFill>
-              <a:schemeClr val="bg1">
-                <a:lumMod val="85000"/>
-              </a:schemeClr>
-            </a:solidFill>
-          </p:spPr>
-          <p:txBody>
-            <a:bodyPr wrap="square" rtlCol="0">
-              <a:spAutoFit/>
-            </a:bodyPr>
-            <a:lstStyle/>
-            <a:p>
-              <a:r>
-                <a:rPr lang="en-US" dirty="0">
-                  <a:latin typeface="Consolas" panose="020B0609020204030204" pitchFamily="49" charset="0"/>
-                </a:rPr>
-                <a:t>…</a:t>
-              </a:r>
-            </a:p>
-            <a:p>
-              <a:r>
-                <a:rPr lang="en-US" dirty="0">
-                  <a:latin typeface="Consolas" panose="020B0609020204030204" pitchFamily="49" charset="0"/>
-                </a:rPr>
-                <a:t>using </a:t>
-              </a:r>
-              <a:r>
-                <a:rPr lang="en-US" dirty="0" err="1">
-                  <a:latin typeface="Consolas" panose="020B0609020204030204" pitchFamily="49" charset="0"/>
-                </a:rPr>
-                <a:t>MyFunctions</a:t>
-              </a:r>
-              <a:endParaRPr lang="en-US" dirty="0">
-                <a:latin typeface="Consolas" panose="020B0609020204030204" pitchFamily="49" charset="0"/>
-              </a:endParaRPr>
-            </a:p>
-            <a:p>
-              <a:endParaRPr lang="en-US" dirty="0">
-                <a:latin typeface="Consolas" panose="020B0609020204030204" pitchFamily="49" charset="0"/>
-              </a:endParaRPr>
-            </a:p>
-            <a:p>
-              <a:r>
-                <a:rPr lang="en-US" dirty="0" err="1">
-                  <a:latin typeface="Consolas" panose="020B0609020204030204" pitchFamily="49" charset="0"/>
-                </a:rPr>
-                <a:t>println</a:t>
-              </a:r>
-              <a:r>
-                <a:rPr lang="en-US" dirty="0">
-                  <a:latin typeface="Consolas" panose="020B0609020204030204" pitchFamily="49" charset="0"/>
-                </a:rPr>
-                <a:t>(</a:t>
-              </a:r>
-              <a:r>
-                <a:rPr lang="en-US" dirty="0">
-                  <a:solidFill>
-                    <a:srgbClr val="00B050"/>
-                  </a:solidFill>
-                  <a:latin typeface="Consolas" panose="020B0609020204030204" pitchFamily="49" charset="0"/>
-                </a:rPr>
-                <a:t>fact</a:t>
-              </a:r>
-              <a:r>
-                <a:rPr lang="en-US" dirty="0">
-                  <a:latin typeface="Consolas" panose="020B0609020204030204" pitchFamily="49" charset="0"/>
-                </a:rPr>
-                <a:t>(3))</a:t>
-              </a:r>
-            </a:p>
-            <a:p>
-              <a:r>
-                <a:rPr lang="en-US" dirty="0" err="1">
-                  <a:latin typeface="Consolas" panose="020B0609020204030204" pitchFamily="49" charset="0"/>
-                </a:rPr>
-                <a:t>println</a:t>
-              </a:r>
-              <a:r>
-                <a:rPr lang="en-US" dirty="0">
-                  <a:latin typeface="Consolas" panose="020B0609020204030204" pitchFamily="49" charset="0"/>
-                </a:rPr>
-                <a:t>(</a:t>
-              </a:r>
-              <a:r>
-                <a:rPr lang="en-US" dirty="0" err="1">
-                  <a:solidFill>
-                    <a:srgbClr val="0070C0"/>
-                  </a:solidFill>
-                  <a:latin typeface="Consolas" panose="020B0609020204030204" pitchFamily="49" charset="0"/>
-                </a:rPr>
-                <a:t>MyFunctions.gcd</a:t>
-              </a:r>
-              <a:r>
-                <a:rPr lang="en-US" dirty="0">
-                  <a:latin typeface="Consolas" panose="020B0609020204030204" pitchFamily="49" charset="0"/>
-                </a:rPr>
-                <a:t>(14, 35))</a:t>
-              </a:r>
-            </a:p>
-            <a:p>
-              <a:r>
-                <a:rPr lang="en-US" dirty="0">
-                  <a:latin typeface="Consolas" panose="020B0609020204030204" pitchFamily="49" charset="0"/>
-                </a:rPr>
-                <a:t>…</a:t>
-              </a:r>
-            </a:p>
-          </p:txBody>
-        </p:sp>
-        <p:sp>
-          <p:nvSpPr>
-            <p:cNvPr id="10" name="TextBox 9">
-              <a:extLst>
-                <a:ext uri="{FF2B5EF4-FFF2-40B4-BE49-F238E27FC236}">
-                  <a16:creationId xmlns:a16="http://schemas.microsoft.com/office/drawing/2014/main" id="{E84251E4-1CB4-406D-9502-107871E63C05}"/>
-                </a:ext>
-              </a:extLst>
-            </p:cNvPr>
-            <p:cNvSpPr txBox="1"/>
-            <p:nvPr/>
-          </p:nvSpPr>
-          <p:spPr>
-            <a:xfrm>
-              <a:off x="8600490" y="3928907"/>
-              <a:ext cx="848309" cy="261610"/>
-            </a:xfrm>
-            <a:prstGeom prst="rect">
-              <a:avLst/>
-            </a:prstGeom>
-            <a:solidFill>
-              <a:schemeClr val="bg1"/>
-            </a:solidFill>
-            <a:ln>
-              <a:solidFill>
-                <a:schemeClr val="tx1"/>
-              </a:solidFill>
-            </a:ln>
-          </p:spPr>
-          <p:txBody>
-            <a:bodyPr wrap="none" rtlCol="0">
-              <a:spAutoFit/>
-            </a:bodyPr>
-            <a:lstStyle/>
-            <a:p>
-              <a:r>
-                <a:rPr lang="en-US" sz="1100" dirty="0" err="1"/>
-                <a:t>my_script.jl</a:t>
-              </a:r>
-              <a:endParaRPr lang="en-US" sz="1100" dirty="0"/>
-            </a:p>
-          </p:txBody>
-        </p:sp>
-      </p:grpSp>
-      <p:grpSp>
-        <p:nvGrpSpPr>
-          <p:cNvPr id="18" name="Group 17">
-            <a:extLst>
-              <a:ext uri="{FF2B5EF4-FFF2-40B4-BE49-F238E27FC236}">
-                <a16:creationId xmlns:a16="http://schemas.microsoft.com/office/drawing/2014/main" id="{3818AADB-A666-433E-AB21-92FE6E83D4BE}"/>
-              </a:ext>
-            </a:extLst>
-          </p:cNvPr>
-          <p:cNvGrpSpPr/>
-          <p:nvPr/>
-        </p:nvGrpSpPr>
-        <p:grpSpPr>
-          <a:xfrm>
-            <a:off x="2611395" y="3682314"/>
-            <a:ext cx="1657299" cy="534905"/>
-            <a:chOff x="2611395" y="3682314"/>
-            <a:chExt cx="1657299" cy="534905"/>
-          </a:xfrm>
-        </p:grpSpPr>
-        <p:sp>
-          <p:nvSpPr>
-            <p:cNvPr id="12" name="TextBox 11">
-              <a:extLst>
-                <a:ext uri="{FF2B5EF4-FFF2-40B4-BE49-F238E27FC236}">
-                  <a16:creationId xmlns:a16="http://schemas.microsoft.com/office/drawing/2014/main" id="{66D191B9-5557-4D2E-83C4-2F2B94D79032}"/>
-                </a:ext>
-              </a:extLst>
-            </p:cNvPr>
-            <p:cNvSpPr txBox="1"/>
-            <p:nvPr/>
-          </p:nvSpPr>
-          <p:spPr>
-            <a:xfrm>
-              <a:off x="3236937" y="3847887"/>
-              <a:ext cx="1031757" cy="369332"/>
-            </a:xfrm>
-            <a:prstGeom prst="rect">
-              <a:avLst/>
-            </a:prstGeom>
-            <a:solidFill>
-              <a:schemeClr val="bg1"/>
-            </a:solidFill>
-            <a:ln>
-              <a:solidFill>
-                <a:schemeClr val="tx1"/>
-              </a:solidFill>
-            </a:ln>
-          </p:spPr>
-          <p:txBody>
-            <a:bodyPr wrap="none" rtlCol="0">
-              <a:spAutoFit/>
-            </a:bodyPr>
-            <a:lstStyle/>
-            <a:p>
-              <a:r>
-                <a:rPr lang="en-US" dirty="0"/>
-                <a:t>Exported</a:t>
-              </a:r>
-            </a:p>
-          </p:txBody>
-        </p:sp>
-        <p:cxnSp>
-          <p:nvCxnSpPr>
-            <p:cNvPr id="15" name="Straight Arrow Connector 14">
-              <a:extLst>
-                <a:ext uri="{FF2B5EF4-FFF2-40B4-BE49-F238E27FC236}">
-                  <a16:creationId xmlns:a16="http://schemas.microsoft.com/office/drawing/2014/main" id="{C1B9D201-7DA7-492D-B382-2B84A1B4E209}"/>
-                </a:ext>
-              </a:extLst>
-            </p:cNvPr>
-            <p:cNvCxnSpPr/>
-            <p:nvPr/>
-          </p:nvCxnSpPr>
-          <p:spPr>
-            <a:xfrm flipH="1" flipV="1">
-              <a:off x="2611395" y="3682314"/>
-              <a:ext cx="626074" cy="350239"/>
-            </a:xfrm>
-            <a:prstGeom prst="straightConnector1">
-              <a:avLst/>
-            </a:prstGeom>
-            <a:ln w="19050">
-              <a:solidFill>
-                <a:schemeClr val="tx1"/>
-              </a:solidFill>
-              <a:tailEnd type="stealth" w="lg" len="lg"/>
-            </a:ln>
-          </p:spPr>
-          <p:style>
-            <a:lnRef idx="1">
-              <a:schemeClr val="accent1"/>
-            </a:lnRef>
-            <a:fillRef idx="0">
-              <a:schemeClr val="accent1"/>
-            </a:fillRef>
-            <a:effectRef idx="0">
-              <a:schemeClr val="accent1"/>
-            </a:effectRef>
-            <a:fontRef idx="minor">
-              <a:schemeClr val="tx1"/>
-            </a:fontRef>
-          </p:style>
-        </p:cxnSp>
-      </p:grpSp>
-      <p:grpSp>
-        <p:nvGrpSpPr>
-          <p:cNvPr id="19" name="Group 18">
-            <a:extLst>
-              <a:ext uri="{FF2B5EF4-FFF2-40B4-BE49-F238E27FC236}">
-                <a16:creationId xmlns:a16="http://schemas.microsoft.com/office/drawing/2014/main" id="{7FD5D0D4-5B0E-4703-9161-3E672C1B0F77}"/>
-              </a:ext>
-            </a:extLst>
-          </p:cNvPr>
-          <p:cNvGrpSpPr/>
-          <p:nvPr/>
-        </p:nvGrpSpPr>
-        <p:grpSpPr>
-          <a:xfrm>
-            <a:off x="2523405" y="4782220"/>
-            <a:ext cx="2150436" cy="507528"/>
-            <a:chOff x="2523405" y="4782220"/>
-            <a:chExt cx="2150436" cy="507528"/>
-          </a:xfrm>
-        </p:grpSpPr>
-        <p:sp>
-          <p:nvSpPr>
-            <p:cNvPr id="13" name="TextBox 12">
-              <a:extLst>
-                <a:ext uri="{FF2B5EF4-FFF2-40B4-BE49-F238E27FC236}">
-                  <a16:creationId xmlns:a16="http://schemas.microsoft.com/office/drawing/2014/main" id="{C964870B-6C66-482F-BD17-F0609233DFB8}"/>
-                </a:ext>
-              </a:extLst>
-            </p:cNvPr>
-            <p:cNvSpPr txBox="1"/>
-            <p:nvPr/>
-          </p:nvSpPr>
-          <p:spPr>
-            <a:xfrm>
-              <a:off x="3241589" y="4920416"/>
-              <a:ext cx="1432252" cy="369332"/>
-            </a:xfrm>
-            <a:prstGeom prst="rect">
-              <a:avLst/>
-            </a:prstGeom>
-            <a:solidFill>
-              <a:schemeClr val="bg1"/>
-            </a:solidFill>
-            <a:ln>
-              <a:solidFill>
-                <a:schemeClr val="tx1"/>
-              </a:solidFill>
-            </a:ln>
-          </p:spPr>
-          <p:txBody>
-            <a:bodyPr wrap="none" rtlCol="0">
-              <a:spAutoFit/>
-            </a:bodyPr>
-            <a:lstStyle/>
-            <a:p>
-              <a:r>
-                <a:rPr lang="en-US" dirty="0"/>
-                <a:t>Not exported</a:t>
-              </a:r>
-            </a:p>
-          </p:txBody>
-        </p:sp>
-        <p:cxnSp>
-          <p:nvCxnSpPr>
-            <p:cNvPr id="16" name="Straight Arrow Connector 15">
-              <a:extLst>
-                <a:ext uri="{FF2B5EF4-FFF2-40B4-BE49-F238E27FC236}">
-                  <a16:creationId xmlns:a16="http://schemas.microsoft.com/office/drawing/2014/main" id="{E04E67AE-AE2D-4D77-A020-3E24CD5C134A}"/>
-                </a:ext>
-              </a:extLst>
-            </p:cNvPr>
-            <p:cNvCxnSpPr>
-              <a:cxnSpLocks/>
-              <a:stCxn id="13" idx="1"/>
-            </p:cNvCxnSpPr>
-            <p:nvPr/>
-          </p:nvCxnSpPr>
-          <p:spPr>
-            <a:xfrm flipH="1" flipV="1">
-              <a:off x="2523405" y="4782220"/>
-              <a:ext cx="718184" cy="322862"/>
-            </a:xfrm>
-            <a:prstGeom prst="straightConnector1">
-              <a:avLst/>
-            </a:prstGeom>
-            <a:ln w="19050">
-              <a:solidFill>
-                <a:schemeClr val="tx1"/>
-              </a:solidFill>
-              <a:tailEnd type="stealth" w="lg" len="lg"/>
-            </a:ln>
-          </p:spPr>
-          <p:style>
-            <a:lnRef idx="1">
-              <a:schemeClr val="accent1"/>
-            </a:lnRef>
-            <a:fillRef idx="0">
-              <a:schemeClr val="accent1"/>
-            </a:fillRef>
-            <a:effectRef idx="0">
-              <a:schemeClr val="accent1"/>
-            </a:effectRef>
-            <a:fontRef idx="minor">
-              <a:schemeClr val="tx1"/>
-            </a:fontRef>
-          </p:style>
-        </p:cxnSp>
-      </p:grpSp>
-      <p:sp>
-        <p:nvSpPr>
-          <p:cNvPr id="20" name="TextBox 19">
-            <a:extLst>
-              <a:ext uri="{FF2B5EF4-FFF2-40B4-BE49-F238E27FC236}">
-                <a16:creationId xmlns:a16="http://schemas.microsoft.com/office/drawing/2014/main" id="{B8303B27-E879-459C-B25F-9630FEFAEFFD}"/>
-              </a:ext>
-            </a:extLst>
-          </p:cNvPr>
-          <p:cNvSpPr txBox="1"/>
-          <p:nvPr/>
-        </p:nvSpPr>
-        <p:spPr>
-          <a:xfrm>
-            <a:off x="5142470" y="4469765"/>
-            <a:ext cx="4037744" cy="369332"/>
-          </a:xfrm>
-          <a:prstGeom prst="rect">
-            <a:avLst/>
-          </a:prstGeom>
-          <a:solidFill>
-            <a:schemeClr val="bg1">
-              <a:lumMod val="85000"/>
-            </a:schemeClr>
-          </a:solidFill>
-        </p:spPr>
-        <p:txBody>
-          <a:bodyPr wrap="square" rtlCol="0">
-            <a:spAutoFit/>
-          </a:bodyPr>
-          <a:lstStyle/>
-          <a:p>
-            <a:pPr algn="r"/>
-            <a:r>
-              <a:rPr lang="en-US" dirty="0">
-                <a:latin typeface="Consolas" panose="020B0609020204030204" pitchFamily="49" charset="0"/>
-              </a:rPr>
-              <a:t>using </a:t>
-            </a:r>
-            <a:r>
-              <a:rPr lang="en-US" dirty="0" err="1">
-                <a:latin typeface="Consolas" panose="020B0609020204030204" pitchFamily="49" charset="0"/>
-              </a:rPr>
-              <a:t>MyFunctions</a:t>
-            </a:r>
-            <a:r>
-              <a:rPr lang="en-US" dirty="0">
-                <a:latin typeface="Consolas" panose="020B0609020204030204" pitchFamily="49" charset="0"/>
-              </a:rPr>
-              <a:t>: fact</a:t>
-            </a:r>
-          </a:p>
-        </p:txBody>
-      </p:sp>
-      <p:grpSp>
-        <p:nvGrpSpPr>
-          <p:cNvPr id="21" name="Group 20">
-            <a:extLst>
-              <a:ext uri="{FF2B5EF4-FFF2-40B4-BE49-F238E27FC236}">
-                <a16:creationId xmlns:a16="http://schemas.microsoft.com/office/drawing/2014/main" id="{5759EAB1-45AF-4F72-84A7-4A086DB13074}"/>
-              </a:ext>
-            </a:extLst>
-          </p:cNvPr>
-          <p:cNvGrpSpPr/>
-          <p:nvPr/>
-        </p:nvGrpSpPr>
-        <p:grpSpPr>
-          <a:xfrm>
-            <a:off x="9693765" y="4151384"/>
-            <a:ext cx="2371565" cy="1467584"/>
-            <a:chOff x="7234137" y="3063682"/>
-            <a:chExt cx="2371565" cy="1467584"/>
-          </a:xfrm>
-        </p:grpSpPr>
-        <p:sp>
-          <p:nvSpPr>
-            <p:cNvPr id="22" name="TextBox 21">
-              <a:extLst>
-                <a:ext uri="{FF2B5EF4-FFF2-40B4-BE49-F238E27FC236}">
-                  <a16:creationId xmlns:a16="http://schemas.microsoft.com/office/drawing/2014/main" id="{743F5982-650A-4EE0-8242-CE5C2F982D97}"/>
-                </a:ext>
-              </a:extLst>
-            </p:cNvPr>
-            <p:cNvSpPr txBox="1"/>
-            <p:nvPr/>
-          </p:nvSpPr>
-          <p:spPr>
-            <a:xfrm>
-              <a:off x="7850221" y="3700269"/>
-              <a:ext cx="1755481" cy="830997"/>
-            </a:xfrm>
-            <a:prstGeom prst="rect">
-              <a:avLst/>
-            </a:prstGeom>
-            <a:noFill/>
-            <a:ln>
-              <a:solidFill>
-                <a:schemeClr val="tx1"/>
-              </a:solidFill>
-            </a:ln>
-          </p:spPr>
-          <p:txBody>
-            <a:bodyPr wrap="none" rtlCol="0">
-              <a:spAutoFit/>
-            </a:bodyPr>
-            <a:lstStyle/>
-            <a:p>
-              <a:r>
-                <a:rPr lang="en-US" sz="2400" dirty="0"/>
-                <a:t>Don’t </a:t>
-              </a:r>
-              <a:r>
-                <a:rPr lang="en-US" sz="2400" dirty="0" err="1"/>
-                <a:t>polute</a:t>
-              </a:r>
-              <a:endParaRPr lang="en-US" sz="2400" dirty="0"/>
-            </a:p>
-            <a:p>
-              <a:r>
-                <a:rPr lang="en-US" sz="2400" dirty="0"/>
-                <a:t>namespace</a:t>
-              </a:r>
-            </a:p>
-          </p:txBody>
-        </p:sp>
-        <p:pic>
-          <p:nvPicPr>
-            <p:cNvPr id="23" name="Graphic 22" descr="Thumbs up sign with solid fill">
-              <a:extLst>
-                <a:ext uri="{FF2B5EF4-FFF2-40B4-BE49-F238E27FC236}">
-                  <a16:creationId xmlns:a16="http://schemas.microsoft.com/office/drawing/2014/main" id="{83D99621-5A43-48FB-A878-3DA40509541B}"/>
-                </a:ext>
-              </a:extLst>
-            </p:cNvPr>
-            <p:cNvPicPr>
-              <a:picLocks noChangeAspect="1"/>
-            </p:cNvPicPr>
-            <p:nvPr/>
-          </p:nvPicPr>
-          <p:blipFill>
-            <a:blip r:embed="rId2">
-              <a:extLst>
-                <a:ext uri="{28A0092B-C50C-407E-A947-70E740481C1C}">
-                  <a14:useLocalDpi xmlns:a14="http://schemas.microsoft.com/office/drawing/2010/main" val="0"/>
-                </a:ext>
-                <a:ext uri="{96DAC541-7B7A-43D3-8B79-37D633B846F1}">
-                  <asvg:svgBlip xmlns:asvg="http://schemas.microsoft.com/office/drawing/2016/SVG/main" r:embed="rId3"/>
-                </a:ext>
-              </a:extLst>
-            </a:blip>
-            <a:stretch>
-              <a:fillRect/>
-            </a:stretch>
-          </p:blipFill>
-          <p:spPr>
-            <a:xfrm>
-              <a:off x="7234137" y="3063682"/>
-              <a:ext cx="914400" cy="914400"/>
-            </a:xfrm>
-            <a:prstGeom prst="rect">
-              <a:avLst/>
-            </a:prstGeom>
-          </p:spPr>
-        </p:pic>
-      </p:grpSp>
-      <p:sp>
-        <p:nvSpPr>
-          <p:cNvPr id="24" name="TextBox 23">
-            <a:extLst>
-              <a:ext uri="{FF2B5EF4-FFF2-40B4-BE49-F238E27FC236}">
-                <a16:creationId xmlns:a16="http://schemas.microsoft.com/office/drawing/2014/main" id="{9FAA3A86-D19E-477D-A4E8-3B4ABA8169EB}"/>
-              </a:ext>
-            </a:extLst>
-          </p:cNvPr>
-          <p:cNvSpPr txBox="1"/>
-          <p:nvPr/>
-        </p:nvSpPr>
-        <p:spPr>
-          <a:xfrm>
-            <a:off x="5142469" y="5502186"/>
-            <a:ext cx="3215751" cy="369332"/>
-          </a:xfrm>
-          <a:prstGeom prst="rect">
-            <a:avLst/>
-          </a:prstGeom>
-          <a:solidFill>
-            <a:schemeClr val="bg1">
-              <a:lumMod val="85000"/>
-            </a:schemeClr>
-          </a:solidFill>
-        </p:spPr>
-        <p:txBody>
-          <a:bodyPr wrap="square" rtlCol="0">
-            <a:spAutoFit/>
-          </a:bodyPr>
-          <a:lstStyle/>
-          <a:p>
-            <a:r>
-              <a:rPr lang="en-US" dirty="0">
-                <a:latin typeface="Consolas" panose="020B0609020204030204" pitchFamily="49" charset="0"/>
-              </a:rPr>
-              <a:t>import </a:t>
-            </a:r>
-            <a:r>
-              <a:rPr lang="en-US" dirty="0" err="1">
-                <a:latin typeface="Consolas" panose="020B0609020204030204" pitchFamily="49" charset="0"/>
-              </a:rPr>
-              <a:t>MyFunctions</a:t>
-            </a:r>
-            <a:r>
-              <a:rPr lang="en-US" dirty="0">
-                <a:latin typeface="Consolas" panose="020B0609020204030204" pitchFamily="49" charset="0"/>
-              </a:rPr>
-              <a:t>: fact</a:t>
-            </a:r>
-          </a:p>
-        </p:txBody>
-      </p:sp>
-      <p:grpSp>
-        <p:nvGrpSpPr>
-          <p:cNvPr id="25" name="Group 24">
-            <a:extLst>
-              <a:ext uri="{FF2B5EF4-FFF2-40B4-BE49-F238E27FC236}">
-                <a16:creationId xmlns:a16="http://schemas.microsoft.com/office/drawing/2014/main" id="{BD3CF768-65C4-4919-9674-725ADC5EA55D}"/>
-              </a:ext>
-            </a:extLst>
-          </p:cNvPr>
-          <p:cNvGrpSpPr/>
-          <p:nvPr/>
-        </p:nvGrpSpPr>
-        <p:grpSpPr>
-          <a:xfrm>
-            <a:off x="8128147" y="5862354"/>
-            <a:ext cx="3810441" cy="507528"/>
-            <a:chOff x="2523405" y="4782220"/>
-            <a:chExt cx="3810441" cy="507528"/>
-          </a:xfrm>
-        </p:grpSpPr>
-        <p:sp>
-          <p:nvSpPr>
-            <p:cNvPr id="26" name="TextBox 25">
-              <a:extLst>
-                <a:ext uri="{FF2B5EF4-FFF2-40B4-BE49-F238E27FC236}">
-                  <a16:creationId xmlns:a16="http://schemas.microsoft.com/office/drawing/2014/main" id="{100F39DA-A6F3-4400-9F27-CC33A6DA2483}"/>
-                </a:ext>
-              </a:extLst>
-            </p:cNvPr>
-            <p:cNvSpPr txBox="1"/>
-            <p:nvPr/>
-          </p:nvSpPr>
-          <p:spPr>
-            <a:xfrm>
-              <a:off x="3241589" y="4920416"/>
-              <a:ext cx="3092257" cy="369332"/>
-            </a:xfrm>
-            <a:prstGeom prst="rect">
-              <a:avLst/>
-            </a:prstGeom>
-            <a:solidFill>
-              <a:schemeClr val="bg1"/>
-            </a:solidFill>
-            <a:ln>
-              <a:solidFill>
-                <a:schemeClr val="tx1"/>
-              </a:solidFill>
-            </a:ln>
-          </p:spPr>
-          <p:txBody>
-            <a:bodyPr wrap="none" rtlCol="0">
-              <a:spAutoFit/>
-            </a:bodyPr>
-            <a:lstStyle/>
-            <a:p>
-              <a:r>
-                <a:rPr lang="en-US" dirty="0"/>
-                <a:t>Add methods to </a:t>
-              </a:r>
-              <a:r>
-                <a:rPr lang="en-US" dirty="0">
-                  <a:latin typeface="Consolas" panose="020B0609020204030204" pitchFamily="49" charset="0"/>
-                </a:rPr>
-                <a:t>fact</a:t>
-              </a:r>
-              <a:r>
-                <a:rPr lang="en-US" dirty="0"/>
-                <a:t> function</a:t>
-              </a:r>
-            </a:p>
-          </p:txBody>
-        </p:sp>
-        <p:cxnSp>
-          <p:nvCxnSpPr>
-            <p:cNvPr id="27" name="Straight Arrow Connector 26">
-              <a:extLst>
-                <a:ext uri="{FF2B5EF4-FFF2-40B4-BE49-F238E27FC236}">
-                  <a16:creationId xmlns:a16="http://schemas.microsoft.com/office/drawing/2014/main" id="{8FC42654-D385-40F2-8395-D0482F5B1277}"/>
-                </a:ext>
-              </a:extLst>
-            </p:cNvPr>
-            <p:cNvCxnSpPr>
-              <a:cxnSpLocks/>
-              <a:stCxn id="26" idx="1"/>
-            </p:cNvCxnSpPr>
-            <p:nvPr/>
-          </p:nvCxnSpPr>
-          <p:spPr>
-            <a:xfrm flipH="1" flipV="1">
-              <a:off x="2523405" y="4782220"/>
-              <a:ext cx="718184" cy="322862"/>
-            </a:xfrm>
-            <a:prstGeom prst="straightConnector1">
-              <a:avLst/>
-            </a:prstGeom>
-            <a:ln w="19050">
-              <a:solidFill>
-                <a:schemeClr val="tx1"/>
-              </a:solidFill>
-              <a:tailEnd type="stealth" w="lg" len="lg"/>
-            </a:ln>
-          </p:spPr>
-          <p:style>
-            <a:lnRef idx="1">
-              <a:schemeClr val="accent1"/>
-            </a:lnRef>
-            <a:fillRef idx="0">
-              <a:schemeClr val="accent1"/>
-            </a:fillRef>
-            <a:effectRef idx="0">
-              <a:schemeClr val="accent1"/>
-            </a:effectRef>
-            <a:fontRef idx="minor">
-              <a:schemeClr val="tx1"/>
-            </a:fontRef>
-          </p:style>
-        </p:cxnSp>
-      </p:grpSp>
-      <p:sp>
-        <p:nvSpPr>
-          <p:cNvPr id="9" name="TextBox 8">
-            <a:extLst>
-              <a:ext uri="{FF2B5EF4-FFF2-40B4-BE49-F238E27FC236}">
-                <a16:creationId xmlns:a16="http://schemas.microsoft.com/office/drawing/2014/main" id="{09E27FC1-661D-0885-7030-6E5D2655A54B}"/>
-              </a:ext>
-            </a:extLst>
-          </p:cNvPr>
-          <p:cNvSpPr txBox="1"/>
-          <p:nvPr/>
-        </p:nvSpPr>
-        <p:spPr>
-          <a:xfrm>
-            <a:off x="5112704" y="4943651"/>
-            <a:ext cx="4067510" cy="369332"/>
-          </a:xfrm>
-          <a:prstGeom prst="rect">
-            <a:avLst/>
-          </a:prstGeom>
-          <a:solidFill>
-            <a:schemeClr val="bg1">
-              <a:lumMod val="85000"/>
-            </a:schemeClr>
-          </a:solidFill>
-        </p:spPr>
-        <p:txBody>
-          <a:bodyPr wrap="square" rtlCol="0">
-            <a:spAutoFit/>
-          </a:bodyPr>
-          <a:lstStyle/>
-          <a:p>
-            <a:r>
-              <a:rPr lang="en-US" dirty="0">
-                <a:latin typeface="Consolas" panose="020B0609020204030204" pitchFamily="49" charset="0"/>
-              </a:rPr>
-              <a:t>using </a:t>
-            </a:r>
-            <a:r>
-              <a:rPr lang="en-US" dirty="0" err="1">
-                <a:latin typeface="Consolas" panose="020B0609020204030204" pitchFamily="49" charset="0"/>
-              </a:rPr>
-              <a:t>MyFunctions</a:t>
-            </a:r>
-            <a:r>
-              <a:rPr lang="en-US" dirty="0">
-                <a:latin typeface="Consolas" panose="020B0609020204030204" pitchFamily="49" charset="0"/>
-              </a:rPr>
-              <a:t>: fact as fac</a:t>
-            </a:r>
-          </a:p>
-        </p:txBody>
-      </p:sp>
-    </p:spTree>
-    <p:extLst>
-      <p:ext uri="{BB962C8B-B14F-4D97-AF65-F5344CB8AC3E}">
-        <p14:creationId xmlns:p14="http://schemas.microsoft.com/office/powerpoint/2010/main" val="823607669"/>
-      </p:ext>
-    </p:extLst>
-  </p:cSld>
-  <p:clrMapOvr>
-    <a:masterClrMapping/>
-  </p:clrMapOvr>
-  <p:timing>
-    <p:tnLst>
-      <p:par>
-        <p:cTn id="1" dur="indefinite" restart="never" nodeType="tmRoot">
-          <p:childTnLst>
-            <p:seq concurrent="1" nextAc="seek">
-              <p:cTn id="2" dur="indefinite" nodeType="mainSeq">
-                <p:childTnLst>
-                  <p:par>
-                    <p:cTn id="3" fill="hold">
-                      <p:stCondLst>
-                        <p:cond delay="indefinite"/>
-                      </p:stCondLst>
-                      <p:childTnLst>
-                        <p:par>
-                          <p:cTn id="4" fill="hold">
-                            <p:stCondLst>
-                              <p:cond delay="0"/>
-                            </p:stCondLst>
-                            <p:childTnLst>
-                              <p:par>
-                                <p:cTn id="5" presetID="1" presetClass="entr" presetSubtype="0" fill="hold" nodeType="clickEffect">
-                                  <p:stCondLst>
-                                    <p:cond delay="0"/>
-                                  </p:stCondLst>
-                                  <p:childTnLst>
-                                    <p:set>
-                                      <p:cBhvr>
-                                        <p:cTn id="6" dur="1" fill="hold">
-                                          <p:stCondLst>
-                                            <p:cond delay="0"/>
-                                          </p:stCondLst>
-                                        </p:cTn>
-                                        <p:tgtEl>
-                                          <p:spTgt spid="18"/>
-                                        </p:tgtEl>
-                                        <p:attrNameLst>
-                                          <p:attrName>style.visibility</p:attrName>
-                                        </p:attrNameLst>
-                                      </p:cBhvr>
-                                      <p:to>
-                                        <p:strVal val="visible"/>
-                                      </p:to>
-                                    </p:set>
-                                  </p:childTnLst>
-                                </p:cTn>
-                              </p:par>
-                            </p:childTnLst>
-                          </p:cTn>
-                        </p:par>
-                      </p:childTnLst>
-                    </p:cTn>
-                  </p:par>
-                  <p:par>
-                    <p:cTn id="7" fill="hold">
-                      <p:stCondLst>
-                        <p:cond delay="indefinite"/>
-                      </p:stCondLst>
-                      <p:childTnLst>
-                        <p:par>
-                          <p:cTn id="8" fill="hold">
-                            <p:stCondLst>
-                              <p:cond delay="0"/>
-                            </p:stCondLst>
-                            <p:childTnLst>
-                              <p:par>
-                                <p:cTn id="9" presetID="1" presetClass="entr" presetSubtype="0" fill="hold" nodeType="clickEffect">
-                                  <p:stCondLst>
-                                    <p:cond delay="0"/>
-                                  </p:stCondLst>
-                                  <p:childTnLst>
-                                    <p:set>
-                                      <p:cBhvr>
-                                        <p:cTn id="10" dur="1" fill="hold">
-                                          <p:stCondLst>
-                                            <p:cond delay="0"/>
-                                          </p:stCondLst>
-                                        </p:cTn>
-                                        <p:tgtEl>
-                                          <p:spTgt spid="19"/>
-                                        </p:tgtEl>
-                                        <p:attrNameLst>
-                                          <p:attrName>style.visibility</p:attrName>
-                                        </p:attrNameLst>
-                                      </p:cBhvr>
-                                      <p:to>
-                                        <p:strVal val="visible"/>
-                                      </p:to>
-                                    </p:set>
-                                  </p:childTnLst>
-                                </p:cTn>
-                              </p:par>
-                            </p:childTnLst>
-                          </p:cTn>
-                        </p:par>
-                      </p:childTnLst>
-                    </p:cTn>
-                  </p:par>
-                  <p:par>
-                    <p:cTn id="11" fill="hold">
-                      <p:stCondLst>
-                        <p:cond delay="indefinite"/>
-                      </p:stCondLst>
-                      <p:childTnLst>
-                        <p:par>
-                          <p:cTn id="12" fill="hold">
-                            <p:stCondLst>
-                              <p:cond delay="0"/>
-                            </p:stCondLst>
-                            <p:childTnLst>
-                              <p:par>
-                                <p:cTn id="13" presetID="1" presetClass="entr" presetSubtype="0" fill="hold" nodeType="clickEffect">
-                                  <p:stCondLst>
-                                    <p:cond delay="0"/>
-                                  </p:stCondLst>
-                                  <p:childTnLst>
-                                    <p:set>
-                                      <p:cBhvr>
-                                        <p:cTn id="14" dur="1" fill="hold">
-                                          <p:stCondLst>
-                                            <p:cond delay="0"/>
-                                          </p:stCondLst>
-                                        </p:cTn>
-                                        <p:tgtEl>
-                                          <p:spTgt spid="11"/>
-                                        </p:tgtEl>
-                                        <p:attrNameLst>
-                                          <p:attrName>style.visibility</p:attrName>
-                                        </p:attrNameLst>
-                                      </p:cBhvr>
-                                      <p:to>
-                                        <p:strVal val="visible"/>
-                                      </p:to>
-                                    </p:set>
-                                  </p:childTnLst>
-                                </p:cTn>
-                              </p:par>
-                            </p:childTnLst>
-                          </p:cTn>
-                        </p:par>
-                      </p:childTnLst>
-                    </p:cTn>
-                  </p:par>
-                  <p:par>
-                    <p:cTn id="15" fill="hold">
-                      <p:stCondLst>
-                        <p:cond delay="indefinite"/>
-                      </p:stCondLst>
-                      <p:childTnLst>
-                        <p:par>
-                          <p:cTn id="16" fill="hold">
-                            <p:stCondLst>
-                              <p:cond delay="0"/>
-                            </p:stCondLst>
-                            <p:childTnLst>
-                              <p:par>
-                                <p:cTn id="17" presetID="1" presetClass="entr" presetSubtype="0" fill="hold" grpId="0" nodeType="clickEffect">
-                                  <p:stCondLst>
-                                    <p:cond delay="0"/>
-                                  </p:stCondLst>
-                                  <p:childTnLst>
-                                    <p:set>
-                                      <p:cBhvr>
-                                        <p:cTn id="18" dur="1" fill="hold">
-                                          <p:stCondLst>
-                                            <p:cond delay="0"/>
-                                          </p:stCondLst>
-                                        </p:cTn>
-                                        <p:tgtEl>
-                                          <p:spTgt spid="20"/>
-                                        </p:tgtEl>
-                                        <p:attrNameLst>
-                                          <p:attrName>style.visibility</p:attrName>
-                                        </p:attrNameLst>
-                                      </p:cBhvr>
-                                      <p:to>
-                                        <p:strVal val="visible"/>
-                                      </p:to>
-                                    </p:set>
-                                  </p:childTnLst>
-                                </p:cTn>
-                              </p:par>
-                            </p:childTnLst>
-                          </p:cTn>
-                        </p:par>
-                      </p:childTnLst>
-                    </p:cTn>
-                  </p:par>
-                  <p:par>
-                    <p:cTn id="19" fill="hold">
-                      <p:stCondLst>
-                        <p:cond delay="indefinite"/>
-                      </p:stCondLst>
-                      <p:childTnLst>
-                        <p:par>
-                          <p:cTn id="20" fill="hold">
-                            <p:stCondLst>
-                              <p:cond delay="0"/>
-                            </p:stCondLst>
-                            <p:childTnLst>
-                              <p:par>
-                                <p:cTn id="21" presetID="1" presetClass="entr" presetSubtype="0" fill="hold" nodeType="clickEffect">
-                                  <p:stCondLst>
-                                    <p:cond delay="0"/>
-                                  </p:stCondLst>
-                                  <p:childTnLst>
-                                    <p:set>
-                                      <p:cBhvr>
-                                        <p:cTn id="22" dur="1" fill="hold">
-                                          <p:stCondLst>
-                                            <p:cond delay="0"/>
-                                          </p:stCondLst>
-                                        </p:cTn>
-                                        <p:tgtEl>
-                                          <p:spTgt spid="21"/>
-                                        </p:tgtEl>
-                                        <p:attrNameLst>
-                                          <p:attrName>style.visibility</p:attrName>
-                                        </p:attrNameLst>
-                                      </p:cBhvr>
-                                      <p:to>
-                                        <p:strVal val="visible"/>
-                                      </p:to>
-                                    </p:set>
-                                  </p:childTnLst>
-                                </p:cTn>
-                              </p:par>
-                            </p:childTnLst>
-                          </p:cTn>
-                        </p:par>
-                      </p:childTnLst>
-                    </p:cTn>
-                  </p:par>
-                  <p:par>
-                    <p:cTn id="23" fill="hold">
-                      <p:stCondLst>
-                        <p:cond delay="indefinite"/>
-                      </p:stCondLst>
-                      <p:childTnLst>
-                        <p:par>
-                          <p:cTn id="24" fill="hold">
-                            <p:stCondLst>
-                              <p:cond delay="0"/>
-                            </p:stCondLst>
-                            <p:childTnLst>
-                              <p:par>
-                                <p:cTn id="25" presetID="1" presetClass="entr" presetSubtype="0" fill="hold" grpId="0" nodeType="clickEffect">
-                                  <p:stCondLst>
-                                    <p:cond delay="0"/>
-                                  </p:stCondLst>
-                                  <p:childTnLst>
-                                    <p:set>
-                                      <p:cBhvr>
-                                        <p:cTn id="26" dur="1" fill="hold">
-                                          <p:stCondLst>
-                                            <p:cond delay="0"/>
-                                          </p:stCondLst>
-                                        </p:cTn>
-                                        <p:tgtEl>
-                                          <p:spTgt spid="24"/>
-                                        </p:tgtEl>
-                                        <p:attrNameLst>
-                                          <p:attrName>style.visibility</p:attrName>
-                                        </p:attrNameLst>
-                                      </p:cBhvr>
-                                      <p:to>
-                                        <p:strVal val="visible"/>
-                                      </p:to>
-                                    </p:set>
-                                  </p:childTnLst>
-                                </p:cTn>
-                              </p:par>
-                              <p:par>
-                                <p:cTn id="27" presetID="1" presetClass="entr" presetSubtype="0" fill="hold" nodeType="withEffect">
-                                  <p:stCondLst>
-                                    <p:cond delay="0"/>
-                                  </p:stCondLst>
-                                  <p:childTnLst>
-                                    <p:set>
-                                      <p:cBhvr>
-                                        <p:cTn id="28" dur="1" fill="hold">
-                                          <p:stCondLst>
-                                            <p:cond delay="0"/>
-                                          </p:stCondLst>
-                                        </p:cTn>
-                                        <p:tgtEl>
-                                          <p:spTgt spid="25"/>
-                                        </p:tgtEl>
-                                        <p:attrNameLst>
-                                          <p:attrName>style.visibility</p:attrName>
-                                        </p:attrNameLst>
-                                      </p:cBhvr>
-                                      <p:to>
-                                        <p:strVal val="visible"/>
-                                      </p:to>
-                                    </p:set>
-                                  </p:childTnLst>
-                                </p:cTn>
-                              </p:par>
-                            </p:childTnLst>
-                          </p:cTn>
-                        </p:par>
-                      </p:childTnLst>
-                    </p:cTn>
-                  </p:par>
-                  <p:par>
-                    <p:cTn id="29" fill="hold">
-                      <p:stCondLst>
-                        <p:cond delay="indefinite"/>
-                      </p:stCondLst>
-                      <p:childTnLst>
-                        <p:par>
-                          <p:cTn id="30" fill="hold">
-                            <p:stCondLst>
-                              <p:cond delay="0"/>
-                            </p:stCondLst>
-                            <p:childTnLst>
-                              <p:par>
-                                <p:cTn id="31" presetID="1" presetClass="entr" presetSubtype="0" fill="hold" grpId="0" nodeType="clickEffect">
-                                  <p:stCondLst>
-                                    <p:cond delay="0"/>
-                                  </p:stCondLst>
-                                  <p:childTnLst>
-                                    <p:set>
-                                      <p:cBhvr>
-                                        <p:cTn id="32" dur="1" fill="hold">
-                                          <p:stCondLst>
-                                            <p:cond delay="0"/>
-                                          </p:stCondLst>
-                                        </p:cTn>
-                                        <p:tgtEl>
-                                          <p:spTgt spid="9"/>
-                                        </p:tgtEl>
-                                        <p:attrNameLst>
-                                          <p:attrName>style.visibility</p:attrName>
-                                        </p:attrNameLst>
-                                      </p:cBhvr>
-                                      <p:to>
-                                        <p:strVal val="visible"/>
-                                      </p:to>
-                                    </p:set>
-                                  </p:childTnLst>
-                                </p:cTn>
-                              </p:par>
-                            </p:childTnLst>
-                          </p:cTn>
-                        </p:par>
-                      </p:childTnLst>
-                    </p:cTn>
-                  </p:par>
-                </p:childTnLst>
-              </p:cTn>
-              <p:prevCondLst>
-                <p:cond evt="onPrev" delay="0">
-                  <p:tgtEl>
-                    <p:sldTgt/>
-                  </p:tgtEl>
-                </p:cond>
-              </p:prevCondLst>
-              <p:nextCondLst>
-                <p:cond evt="onNext" delay="0">
-                  <p:tgtEl>
-                    <p:sldTgt/>
-                  </p:tgtEl>
-                </p:cond>
-              </p:nextCondLst>
-            </p:seq>
-          </p:childTnLst>
-        </p:cTn>
-      </p:par>
-    </p:tnLst>
-    <p:bldLst>
-      <p:bldP spid="20" grpId="0" animBg="1"/>
-      <p:bldP spid="24" grpId="0" animBg="1"/>
-      <p:bldP spid="9" grpId="0" animBg="1"/>
     </p:bldLst>
   </p:timing>
 </p:sld>
@@ -29491,6 +28617,1637 @@
           <p:cNvPr id="2" name="Title 1">
             <a:extLst>
               <a:ext uri="{FF2B5EF4-FFF2-40B4-BE49-F238E27FC236}">
+                <a16:creationId xmlns:a16="http://schemas.microsoft.com/office/drawing/2014/main" id="{BD3F676C-8E61-475A-B380-3862D8DBCE89}"/>
+              </a:ext>
+            </a:extLst>
+          </p:cNvPr>
+          <p:cNvSpPr>
+            <a:spLocks noGrp="1"/>
+          </p:cNvSpPr>
+          <p:nvPr>
+            <p:ph type="title"/>
+          </p:nvPr>
+        </p:nvSpPr>
+        <p:spPr/>
+        <p:txBody>
+          <a:bodyPr/>
+          <a:lstStyle/>
+          <a:p>
+            <a:r>
+              <a:rPr lang="en-US" dirty="0"/>
+              <a:t>Code organization</a:t>
+            </a:r>
+          </a:p>
+        </p:txBody>
+      </p:sp>
+      <p:sp>
+        <p:nvSpPr>
+          <p:cNvPr id="3" name="Text Placeholder 2">
+            <a:extLst>
+              <a:ext uri="{FF2B5EF4-FFF2-40B4-BE49-F238E27FC236}">
+                <a16:creationId xmlns:a16="http://schemas.microsoft.com/office/drawing/2014/main" id="{A6A8E519-B664-45C3-9598-AAEDCCBF1B03}"/>
+              </a:ext>
+            </a:extLst>
+          </p:cNvPr>
+          <p:cNvSpPr>
+            <a:spLocks noGrp="1"/>
+          </p:cNvSpPr>
+          <p:nvPr>
+            <p:ph type="body" idx="1"/>
+          </p:nvPr>
+        </p:nvSpPr>
+        <p:spPr/>
+        <p:txBody>
+          <a:bodyPr/>
+          <a:lstStyle/>
+          <a:p>
+            <a:endParaRPr lang="en-US"/>
+          </a:p>
+        </p:txBody>
+      </p:sp>
+      <p:sp>
+        <p:nvSpPr>
+          <p:cNvPr id="4" name="Slide Number Placeholder 3">
+            <a:extLst>
+              <a:ext uri="{FF2B5EF4-FFF2-40B4-BE49-F238E27FC236}">
+                <a16:creationId xmlns:a16="http://schemas.microsoft.com/office/drawing/2014/main" id="{E83AE572-1A4F-44A3-9F9F-2E1F4C95A76D}"/>
+              </a:ext>
+            </a:extLst>
+          </p:cNvPr>
+          <p:cNvSpPr>
+            <a:spLocks noGrp="1"/>
+          </p:cNvSpPr>
+          <p:nvPr>
+            <p:ph type="sldNum" sz="quarter" idx="12"/>
+          </p:nvPr>
+        </p:nvSpPr>
+        <p:spPr/>
+        <p:txBody>
+          <a:bodyPr/>
+          <a:lstStyle/>
+          <a:p>
+            <a:fld id="{78F7A1EC-23D1-431D-8C93-9C4ED5D4A04D}" type="slidenum">
+              <a:rPr lang="en-US" smtClean="0"/>
+              <a:t>40</a:t>
+            </a:fld>
+            <a:endParaRPr lang="en-US"/>
+          </a:p>
+        </p:txBody>
+      </p:sp>
+    </p:spTree>
+    <p:extLst>
+      <p:ext uri="{BB962C8B-B14F-4D97-AF65-F5344CB8AC3E}">
+        <p14:creationId xmlns:p14="http://schemas.microsoft.com/office/powerpoint/2010/main" val="560763537"/>
+      </p:ext>
+    </p:extLst>
+  </p:cSld>
+  <p:clrMapOvr>
+    <a:masterClrMapping/>
+  </p:clrMapOvr>
+</p:sld>
+</file>
+
+<file path=ppt/slides/slide41.xml><?xml version="1.0" encoding="utf-8"?>
+<p:sld xmlns:a="http://schemas.openxmlformats.org/drawingml/2006/main" xmlns:r="http://schemas.openxmlformats.org/officeDocument/2006/relationships" xmlns:p="http://schemas.openxmlformats.org/presentationml/2006/main">
+  <p:cSld>
+    <p:spTree>
+      <p:nvGrpSpPr>
+        <p:cNvPr id="1" name=""/>
+        <p:cNvGrpSpPr/>
+        <p:nvPr/>
+      </p:nvGrpSpPr>
+      <p:grpSpPr>
+        <a:xfrm>
+          <a:off x="0" y="0"/>
+          <a:ext cx="0" cy="0"/>
+          <a:chOff x="0" y="0"/>
+          <a:chExt cx="0" cy="0"/>
+        </a:xfrm>
+      </p:grpSpPr>
+      <p:sp>
+        <p:nvSpPr>
+          <p:cNvPr id="2" name="Title 1">
+            <a:extLst>
+              <a:ext uri="{FF2B5EF4-FFF2-40B4-BE49-F238E27FC236}">
+                <a16:creationId xmlns:a16="http://schemas.microsoft.com/office/drawing/2014/main" id="{291CE4E6-CAD2-46CD-AC0C-36218848C9EF}"/>
+              </a:ext>
+            </a:extLst>
+          </p:cNvPr>
+          <p:cNvSpPr>
+            <a:spLocks noGrp="1"/>
+          </p:cNvSpPr>
+          <p:nvPr>
+            <p:ph type="title"/>
+          </p:nvPr>
+        </p:nvSpPr>
+        <p:spPr/>
+        <p:txBody>
+          <a:bodyPr/>
+          <a:lstStyle/>
+          <a:p>
+            <a:r>
+              <a:rPr lang="en-US" dirty="0"/>
+              <a:t>Modules</a:t>
+            </a:r>
+          </a:p>
+        </p:txBody>
+      </p:sp>
+      <p:sp>
+        <p:nvSpPr>
+          <p:cNvPr id="3" name="Content Placeholder 2">
+            <a:extLst>
+              <a:ext uri="{FF2B5EF4-FFF2-40B4-BE49-F238E27FC236}">
+                <a16:creationId xmlns:a16="http://schemas.microsoft.com/office/drawing/2014/main" id="{5644616E-30B7-47E4-A033-60C1A8006164}"/>
+              </a:ext>
+            </a:extLst>
+          </p:cNvPr>
+          <p:cNvSpPr>
+            <a:spLocks noGrp="1"/>
+          </p:cNvSpPr>
+          <p:nvPr>
+            <p:ph idx="1"/>
+          </p:nvPr>
+        </p:nvSpPr>
+        <p:spPr/>
+        <p:txBody>
+          <a:bodyPr/>
+          <a:lstStyle/>
+          <a:p>
+            <a:r>
+              <a:rPr lang="en-US" dirty="0"/>
+              <a:t>Modules are namespaces</a:t>
+            </a:r>
+          </a:p>
+        </p:txBody>
+      </p:sp>
+      <p:sp>
+        <p:nvSpPr>
+          <p:cNvPr id="4" name="Slide Number Placeholder 3">
+            <a:extLst>
+              <a:ext uri="{FF2B5EF4-FFF2-40B4-BE49-F238E27FC236}">
+                <a16:creationId xmlns:a16="http://schemas.microsoft.com/office/drawing/2014/main" id="{F7373C50-4941-464C-BFFC-BE5DE564BB52}"/>
+              </a:ext>
+            </a:extLst>
+          </p:cNvPr>
+          <p:cNvSpPr>
+            <a:spLocks noGrp="1"/>
+          </p:cNvSpPr>
+          <p:nvPr>
+            <p:ph type="sldNum" sz="quarter" idx="12"/>
+          </p:nvPr>
+        </p:nvSpPr>
+        <p:spPr/>
+        <p:txBody>
+          <a:bodyPr/>
+          <a:lstStyle/>
+          <a:p>
+            <a:fld id="{78F7A1EC-23D1-431D-8C93-9C4ED5D4A04D}" type="slidenum">
+              <a:rPr lang="en-US" smtClean="0"/>
+              <a:t>41</a:t>
+            </a:fld>
+            <a:endParaRPr lang="en-US"/>
+          </a:p>
+        </p:txBody>
+      </p:sp>
+      <p:grpSp>
+        <p:nvGrpSpPr>
+          <p:cNvPr id="8" name="Group 7">
+            <a:extLst>
+              <a:ext uri="{FF2B5EF4-FFF2-40B4-BE49-F238E27FC236}">
+                <a16:creationId xmlns:a16="http://schemas.microsoft.com/office/drawing/2014/main" id="{D663F298-65AC-4AD7-962E-B9C181C42FBB}"/>
+              </a:ext>
+            </a:extLst>
+          </p:cNvPr>
+          <p:cNvGrpSpPr/>
+          <p:nvPr/>
+        </p:nvGrpSpPr>
+        <p:grpSpPr>
+          <a:xfrm>
+            <a:off x="838201" y="2455198"/>
+            <a:ext cx="3025346" cy="3416320"/>
+            <a:chOff x="838201" y="2455198"/>
+            <a:chExt cx="3025346" cy="3416320"/>
+          </a:xfrm>
+        </p:grpSpPr>
+        <p:sp>
+          <p:nvSpPr>
+            <p:cNvPr id="5" name="TextBox 4">
+              <a:extLst>
+                <a:ext uri="{FF2B5EF4-FFF2-40B4-BE49-F238E27FC236}">
+                  <a16:creationId xmlns:a16="http://schemas.microsoft.com/office/drawing/2014/main" id="{49507C89-9635-4240-8B72-2785A6E7DA92}"/>
+                </a:ext>
+              </a:extLst>
+            </p:cNvPr>
+            <p:cNvSpPr txBox="1"/>
+            <p:nvPr/>
+          </p:nvSpPr>
+          <p:spPr>
+            <a:xfrm>
+              <a:off x="838201" y="2455198"/>
+              <a:ext cx="3025346" cy="3416320"/>
+            </a:xfrm>
+            <a:prstGeom prst="rect">
+              <a:avLst/>
+            </a:prstGeom>
+            <a:solidFill>
+              <a:schemeClr val="bg1">
+                <a:lumMod val="85000"/>
+              </a:schemeClr>
+            </a:solidFill>
+          </p:spPr>
+          <p:txBody>
+            <a:bodyPr wrap="square" rtlCol="0">
+              <a:spAutoFit/>
+            </a:bodyPr>
+            <a:lstStyle/>
+            <a:p>
+              <a:r>
+                <a:rPr lang="en-US" dirty="0">
+                  <a:latin typeface="Consolas" panose="020B0609020204030204" pitchFamily="49" charset="0"/>
+                </a:rPr>
+                <a:t>module </a:t>
+              </a:r>
+              <a:r>
+                <a:rPr lang="en-US" dirty="0" err="1">
+                  <a:latin typeface="Consolas" panose="020B0609020204030204" pitchFamily="49" charset="0"/>
+                </a:rPr>
+                <a:t>MyFunctions</a:t>
+              </a:r>
+              <a:endParaRPr lang="en-US" dirty="0">
+                <a:latin typeface="Consolas" panose="020B0609020204030204" pitchFamily="49" charset="0"/>
+              </a:endParaRPr>
+            </a:p>
+            <a:p>
+              <a:r>
+                <a:rPr lang="en-US" dirty="0">
+                  <a:latin typeface="Consolas" panose="020B0609020204030204" pitchFamily="49" charset="0"/>
+                </a:rPr>
+                <a:t>  export </a:t>
+              </a:r>
+              <a:r>
+                <a:rPr lang="en-US" dirty="0">
+                  <a:solidFill>
+                    <a:srgbClr val="00B050"/>
+                  </a:solidFill>
+                  <a:latin typeface="Consolas" panose="020B0609020204030204" pitchFamily="49" charset="0"/>
+                </a:rPr>
+                <a:t>fact</a:t>
+              </a:r>
+            </a:p>
+            <a:p>
+              <a:endParaRPr lang="en-US" dirty="0">
+                <a:latin typeface="Consolas" panose="020B0609020204030204" pitchFamily="49" charset="0"/>
+              </a:endParaRPr>
+            </a:p>
+            <a:p>
+              <a:r>
+                <a:rPr lang="en-US" dirty="0">
+                  <a:latin typeface="Consolas" panose="020B0609020204030204" pitchFamily="49" charset="0"/>
+                </a:rPr>
+                <a:t>  function </a:t>
+              </a:r>
+              <a:r>
+                <a:rPr lang="en-US" dirty="0">
+                  <a:solidFill>
+                    <a:srgbClr val="00B050"/>
+                  </a:solidFill>
+                  <a:latin typeface="Consolas" panose="020B0609020204030204" pitchFamily="49" charset="0"/>
+                </a:rPr>
+                <a:t>fact</a:t>
+              </a:r>
+              <a:r>
+                <a:rPr lang="en-US" dirty="0">
+                  <a:latin typeface="Consolas" panose="020B0609020204030204" pitchFamily="49" charset="0"/>
+                </a:rPr>
+                <a:t>(n)</a:t>
+              </a:r>
+            </a:p>
+            <a:p>
+              <a:r>
+                <a:rPr lang="en-US" dirty="0">
+                  <a:latin typeface="Consolas" panose="020B0609020204030204" pitchFamily="49" charset="0"/>
+                </a:rPr>
+                <a:t>    …</a:t>
+              </a:r>
+            </a:p>
+            <a:p>
+              <a:r>
+                <a:rPr lang="en-US" dirty="0">
+                  <a:latin typeface="Consolas" panose="020B0609020204030204" pitchFamily="49" charset="0"/>
+                </a:rPr>
+                <a:t>  end</a:t>
+              </a:r>
+            </a:p>
+            <a:p>
+              <a:endParaRPr lang="en-US" dirty="0">
+                <a:latin typeface="Consolas" panose="020B0609020204030204" pitchFamily="49" charset="0"/>
+              </a:endParaRPr>
+            </a:p>
+            <a:p>
+              <a:r>
+                <a:rPr lang="en-US" dirty="0">
+                  <a:latin typeface="Consolas" panose="020B0609020204030204" pitchFamily="49" charset="0"/>
+                </a:rPr>
+                <a:t>  function </a:t>
+              </a:r>
+              <a:r>
+                <a:rPr lang="en-US" b="1" dirty="0" err="1">
+                  <a:solidFill>
+                    <a:srgbClr val="0070C0"/>
+                  </a:solidFill>
+                  <a:latin typeface="Consolas" panose="020B0609020204030204" pitchFamily="49" charset="0"/>
+                </a:rPr>
+                <a:t>gcd</a:t>
+              </a:r>
+              <a:r>
+                <a:rPr lang="en-US" dirty="0">
+                  <a:latin typeface="Consolas" panose="020B0609020204030204" pitchFamily="49" charset="0"/>
+                </a:rPr>
+                <a:t>(a, b)</a:t>
+              </a:r>
+            </a:p>
+            <a:p>
+              <a:r>
+                <a:rPr lang="en-US" dirty="0">
+                  <a:latin typeface="Consolas" panose="020B0609020204030204" pitchFamily="49" charset="0"/>
+                </a:rPr>
+                <a:t>    …</a:t>
+              </a:r>
+            </a:p>
+            <a:p>
+              <a:r>
+                <a:rPr lang="en-US" dirty="0">
+                  <a:latin typeface="Consolas" panose="020B0609020204030204" pitchFamily="49" charset="0"/>
+                </a:rPr>
+                <a:t>  end</a:t>
+              </a:r>
+            </a:p>
+            <a:p>
+              <a:endParaRPr lang="en-US" dirty="0">
+                <a:latin typeface="Consolas" panose="020B0609020204030204" pitchFamily="49" charset="0"/>
+              </a:endParaRPr>
+            </a:p>
+            <a:p>
+              <a:r>
+                <a:rPr lang="en-US" dirty="0">
+                  <a:latin typeface="Consolas" panose="020B0609020204030204" pitchFamily="49" charset="0"/>
+                </a:rPr>
+                <a:t>end</a:t>
+              </a:r>
+            </a:p>
+          </p:txBody>
+        </p:sp>
+        <p:sp>
+          <p:nvSpPr>
+            <p:cNvPr id="7" name="TextBox 6">
+              <a:extLst>
+                <a:ext uri="{FF2B5EF4-FFF2-40B4-BE49-F238E27FC236}">
+                  <a16:creationId xmlns:a16="http://schemas.microsoft.com/office/drawing/2014/main" id="{7BFEAC12-832E-4A6C-8684-CAAC907B0A2D}"/>
+                </a:ext>
+              </a:extLst>
+            </p:cNvPr>
+            <p:cNvSpPr txBox="1"/>
+            <p:nvPr/>
+          </p:nvSpPr>
+          <p:spPr>
+            <a:xfrm>
+              <a:off x="2842114" y="5609908"/>
+              <a:ext cx="1021433" cy="261610"/>
+            </a:xfrm>
+            <a:prstGeom prst="rect">
+              <a:avLst/>
+            </a:prstGeom>
+            <a:solidFill>
+              <a:schemeClr val="bg1"/>
+            </a:solidFill>
+            <a:ln>
+              <a:solidFill>
+                <a:schemeClr val="tx1"/>
+              </a:solidFill>
+            </a:ln>
+          </p:spPr>
+          <p:txBody>
+            <a:bodyPr wrap="none" rtlCol="0">
+              <a:spAutoFit/>
+            </a:bodyPr>
+            <a:lstStyle/>
+            <a:p>
+              <a:r>
+                <a:rPr lang="en-US" sz="1100" dirty="0" err="1"/>
+                <a:t>MyFunctions.jl</a:t>
+              </a:r>
+              <a:endParaRPr lang="en-US" sz="1100" dirty="0"/>
+            </a:p>
+          </p:txBody>
+        </p:sp>
+      </p:grpSp>
+      <p:grpSp>
+        <p:nvGrpSpPr>
+          <p:cNvPr id="11" name="Group 10">
+            <a:extLst>
+              <a:ext uri="{FF2B5EF4-FFF2-40B4-BE49-F238E27FC236}">
+                <a16:creationId xmlns:a16="http://schemas.microsoft.com/office/drawing/2014/main" id="{89549B4D-1E15-4A58-9D30-D56C240E9897}"/>
+              </a:ext>
+            </a:extLst>
+          </p:cNvPr>
+          <p:cNvGrpSpPr/>
+          <p:nvPr/>
+        </p:nvGrpSpPr>
+        <p:grpSpPr>
+          <a:xfrm>
+            <a:off x="5142470" y="2455198"/>
+            <a:ext cx="4306329" cy="1754326"/>
+            <a:chOff x="5142470" y="2455198"/>
+            <a:chExt cx="4306329" cy="1754326"/>
+          </a:xfrm>
+        </p:grpSpPr>
+        <p:sp>
+          <p:nvSpPr>
+            <p:cNvPr id="6" name="TextBox 5">
+              <a:extLst>
+                <a:ext uri="{FF2B5EF4-FFF2-40B4-BE49-F238E27FC236}">
+                  <a16:creationId xmlns:a16="http://schemas.microsoft.com/office/drawing/2014/main" id="{1BB28F42-1417-419E-8AD4-CDBDC4E67B9F}"/>
+                </a:ext>
+              </a:extLst>
+            </p:cNvPr>
+            <p:cNvSpPr txBox="1"/>
+            <p:nvPr/>
+          </p:nvSpPr>
+          <p:spPr>
+            <a:xfrm>
+              <a:off x="5142470" y="2455198"/>
+              <a:ext cx="4306329" cy="1754326"/>
+            </a:xfrm>
+            <a:prstGeom prst="rect">
+              <a:avLst/>
+            </a:prstGeom>
+            <a:solidFill>
+              <a:schemeClr val="bg1">
+                <a:lumMod val="85000"/>
+              </a:schemeClr>
+            </a:solidFill>
+          </p:spPr>
+          <p:txBody>
+            <a:bodyPr wrap="square" rtlCol="0">
+              <a:spAutoFit/>
+            </a:bodyPr>
+            <a:lstStyle/>
+            <a:p>
+              <a:r>
+                <a:rPr lang="en-US" dirty="0">
+                  <a:latin typeface="Consolas" panose="020B0609020204030204" pitchFamily="49" charset="0"/>
+                </a:rPr>
+                <a:t>…</a:t>
+              </a:r>
+            </a:p>
+            <a:p>
+              <a:r>
+                <a:rPr lang="en-US" dirty="0">
+                  <a:latin typeface="Consolas" panose="020B0609020204030204" pitchFamily="49" charset="0"/>
+                </a:rPr>
+                <a:t>using </a:t>
+              </a:r>
+              <a:r>
+                <a:rPr lang="en-US" dirty="0" err="1">
+                  <a:latin typeface="Consolas" panose="020B0609020204030204" pitchFamily="49" charset="0"/>
+                </a:rPr>
+                <a:t>MyFunctions</a:t>
+              </a:r>
+              <a:endParaRPr lang="en-US" dirty="0">
+                <a:latin typeface="Consolas" panose="020B0609020204030204" pitchFamily="49" charset="0"/>
+              </a:endParaRPr>
+            </a:p>
+            <a:p>
+              <a:endParaRPr lang="en-US" dirty="0">
+                <a:latin typeface="Consolas" panose="020B0609020204030204" pitchFamily="49" charset="0"/>
+              </a:endParaRPr>
+            </a:p>
+            <a:p>
+              <a:r>
+                <a:rPr lang="en-US" dirty="0" err="1">
+                  <a:latin typeface="Consolas" panose="020B0609020204030204" pitchFamily="49" charset="0"/>
+                </a:rPr>
+                <a:t>println</a:t>
+              </a:r>
+              <a:r>
+                <a:rPr lang="en-US" dirty="0">
+                  <a:latin typeface="Consolas" panose="020B0609020204030204" pitchFamily="49" charset="0"/>
+                </a:rPr>
+                <a:t>(</a:t>
+              </a:r>
+              <a:r>
+                <a:rPr lang="en-US" dirty="0">
+                  <a:solidFill>
+                    <a:srgbClr val="00B050"/>
+                  </a:solidFill>
+                  <a:latin typeface="Consolas" panose="020B0609020204030204" pitchFamily="49" charset="0"/>
+                </a:rPr>
+                <a:t>fact</a:t>
+              </a:r>
+              <a:r>
+                <a:rPr lang="en-US" dirty="0">
+                  <a:latin typeface="Consolas" panose="020B0609020204030204" pitchFamily="49" charset="0"/>
+                </a:rPr>
+                <a:t>(3))</a:t>
+              </a:r>
+            </a:p>
+            <a:p>
+              <a:r>
+                <a:rPr lang="en-US" dirty="0" err="1">
+                  <a:latin typeface="Consolas" panose="020B0609020204030204" pitchFamily="49" charset="0"/>
+                </a:rPr>
+                <a:t>println</a:t>
+              </a:r>
+              <a:r>
+                <a:rPr lang="en-US" dirty="0">
+                  <a:latin typeface="Consolas" panose="020B0609020204030204" pitchFamily="49" charset="0"/>
+                </a:rPr>
+                <a:t>(</a:t>
+              </a:r>
+              <a:r>
+                <a:rPr lang="en-US" dirty="0" err="1">
+                  <a:solidFill>
+                    <a:srgbClr val="0070C0"/>
+                  </a:solidFill>
+                  <a:latin typeface="Consolas" panose="020B0609020204030204" pitchFamily="49" charset="0"/>
+                </a:rPr>
+                <a:t>MyFunctions.gcd</a:t>
+              </a:r>
+              <a:r>
+                <a:rPr lang="en-US" dirty="0">
+                  <a:latin typeface="Consolas" panose="020B0609020204030204" pitchFamily="49" charset="0"/>
+                </a:rPr>
+                <a:t>(14, 35))</a:t>
+              </a:r>
+            </a:p>
+            <a:p>
+              <a:r>
+                <a:rPr lang="en-US" dirty="0">
+                  <a:latin typeface="Consolas" panose="020B0609020204030204" pitchFamily="49" charset="0"/>
+                </a:rPr>
+                <a:t>…</a:t>
+              </a:r>
+            </a:p>
+          </p:txBody>
+        </p:sp>
+        <p:sp>
+          <p:nvSpPr>
+            <p:cNvPr id="10" name="TextBox 9">
+              <a:extLst>
+                <a:ext uri="{FF2B5EF4-FFF2-40B4-BE49-F238E27FC236}">
+                  <a16:creationId xmlns:a16="http://schemas.microsoft.com/office/drawing/2014/main" id="{E84251E4-1CB4-406D-9502-107871E63C05}"/>
+                </a:ext>
+              </a:extLst>
+            </p:cNvPr>
+            <p:cNvSpPr txBox="1"/>
+            <p:nvPr/>
+          </p:nvSpPr>
+          <p:spPr>
+            <a:xfrm>
+              <a:off x="8600490" y="3928907"/>
+              <a:ext cx="848309" cy="261610"/>
+            </a:xfrm>
+            <a:prstGeom prst="rect">
+              <a:avLst/>
+            </a:prstGeom>
+            <a:solidFill>
+              <a:schemeClr val="bg1"/>
+            </a:solidFill>
+            <a:ln>
+              <a:solidFill>
+                <a:schemeClr val="tx1"/>
+              </a:solidFill>
+            </a:ln>
+          </p:spPr>
+          <p:txBody>
+            <a:bodyPr wrap="none" rtlCol="0">
+              <a:spAutoFit/>
+            </a:bodyPr>
+            <a:lstStyle/>
+            <a:p>
+              <a:r>
+                <a:rPr lang="en-US" sz="1100" dirty="0" err="1"/>
+                <a:t>my_script.jl</a:t>
+              </a:r>
+              <a:endParaRPr lang="en-US" sz="1100" dirty="0"/>
+            </a:p>
+          </p:txBody>
+        </p:sp>
+      </p:grpSp>
+      <p:grpSp>
+        <p:nvGrpSpPr>
+          <p:cNvPr id="18" name="Group 17">
+            <a:extLst>
+              <a:ext uri="{FF2B5EF4-FFF2-40B4-BE49-F238E27FC236}">
+                <a16:creationId xmlns:a16="http://schemas.microsoft.com/office/drawing/2014/main" id="{3818AADB-A666-433E-AB21-92FE6E83D4BE}"/>
+              </a:ext>
+            </a:extLst>
+          </p:cNvPr>
+          <p:cNvGrpSpPr/>
+          <p:nvPr/>
+        </p:nvGrpSpPr>
+        <p:grpSpPr>
+          <a:xfrm>
+            <a:off x="2611395" y="3682314"/>
+            <a:ext cx="1657299" cy="534905"/>
+            <a:chOff x="2611395" y="3682314"/>
+            <a:chExt cx="1657299" cy="534905"/>
+          </a:xfrm>
+        </p:grpSpPr>
+        <p:sp>
+          <p:nvSpPr>
+            <p:cNvPr id="12" name="TextBox 11">
+              <a:extLst>
+                <a:ext uri="{FF2B5EF4-FFF2-40B4-BE49-F238E27FC236}">
+                  <a16:creationId xmlns:a16="http://schemas.microsoft.com/office/drawing/2014/main" id="{66D191B9-5557-4D2E-83C4-2F2B94D79032}"/>
+                </a:ext>
+              </a:extLst>
+            </p:cNvPr>
+            <p:cNvSpPr txBox="1"/>
+            <p:nvPr/>
+          </p:nvSpPr>
+          <p:spPr>
+            <a:xfrm>
+              <a:off x="3236937" y="3847887"/>
+              <a:ext cx="1031757" cy="369332"/>
+            </a:xfrm>
+            <a:prstGeom prst="rect">
+              <a:avLst/>
+            </a:prstGeom>
+            <a:solidFill>
+              <a:schemeClr val="bg1"/>
+            </a:solidFill>
+            <a:ln>
+              <a:solidFill>
+                <a:schemeClr val="tx1"/>
+              </a:solidFill>
+            </a:ln>
+          </p:spPr>
+          <p:txBody>
+            <a:bodyPr wrap="none" rtlCol="0">
+              <a:spAutoFit/>
+            </a:bodyPr>
+            <a:lstStyle/>
+            <a:p>
+              <a:r>
+                <a:rPr lang="en-US" dirty="0"/>
+                <a:t>Exported</a:t>
+              </a:r>
+            </a:p>
+          </p:txBody>
+        </p:sp>
+        <p:cxnSp>
+          <p:nvCxnSpPr>
+            <p:cNvPr id="15" name="Straight Arrow Connector 14">
+              <a:extLst>
+                <a:ext uri="{FF2B5EF4-FFF2-40B4-BE49-F238E27FC236}">
+                  <a16:creationId xmlns:a16="http://schemas.microsoft.com/office/drawing/2014/main" id="{C1B9D201-7DA7-492D-B382-2B84A1B4E209}"/>
+                </a:ext>
+              </a:extLst>
+            </p:cNvPr>
+            <p:cNvCxnSpPr/>
+            <p:nvPr/>
+          </p:nvCxnSpPr>
+          <p:spPr>
+            <a:xfrm flipH="1" flipV="1">
+              <a:off x="2611395" y="3682314"/>
+              <a:ext cx="626074" cy="350239"/>
+            </a:xfrm>
+            <a:prstGeom prst="straightConnector1">
+              <a:avLst/>
+            </a:prstGeom>
+            <a:ln w="19050">
+              <a:solidFill>
+                <a:schemeClr val="tx1"/>
+              </a:solidFill>
+              <a:tailEnd type="stealth" w="lg" len="lg"/>
+            </a:ln>
+          </p:spPr>
+          <p:style>
+            <a:lnRef idx="1">
+              <a:schemeClr val="accent1"/>
+            </a:lnRef>
+            <a:fillRef idx="0">
+              <a:schemeClr val="accent1"/>
+            </a:fillRef>
+            <a:effectRef idx="0">
+              <a:schemeClr val="accent1"/>
+            </a:effectRef>
+            <a:fontRef idx="minor">
+              <a:schemeClr val="tx1"/>
+            </a:fontRef>
+          </p:style>
+        </p:cxnSp>
+      </p:grpSp>
+      <p:grpSp>
+        <p:nvGrpSpPr>
+          <p:cNvPr id="19" name="Group 18">
+            <a:extLst>
+              <a:ext uri="{FF2B5EF4-FFF2-40B4-BE49-F238E27FC236}">
+                <a16:creationId xmlns:a16="http://schemas.microsoft.com/office/drawing/2014/main" id="{7FD5D0D4-5B0E-4703-9161-3E672C1B0F77}"/>
+              </a:ext>
+            </a:extLst>
+          </p:cNvPr>
+          <p:cNvGrpSpPr/>
+          <p:nvPr/>
+        </p:nvGrpSpPr>
+        <p:grpSpPr>
+          <a:xfrm>
+            <a:off x="2523405" y="4782220"/>
+            <a:ext cx="2150436" cy="507528"/>
+            <a:chOff x="2523405" y="4782220"/>
+            <a:chExt cx="2150436" cy="507528"/>
+          </a:xfrm>
+        </p:grpSpPr>
+        <p:sp>
+          <p:nvSpPr>
+            <p:cNvPr id="13" name="TextBox 12">
+              <a:extLst>
+                <a:ext uri="{FF2B5EF4-FFF2-40B4-BE49-F238E27FC236}">
+                  <a16:creationId xmlns:a16="http://schemas.microsoft.com/office/drawing/2014/main" id="{C964870B-6C66-482F-BD17-F0609233DFB8}"/>
+                </a:ext>
+              </a:extLst>
+            </p:cNvPr>
+            <p:cNvSpPr txBox="1"/>
+            <p:nvPr/>
+          </p:nvSpPr>
+          <p:spPr>
+            <a:xfrm>
+              <a:off x="3241589" y="4920416"/>
+              <a:ext cx="1432252" cy="369332"/>
+            </a:xfrm>
+            <a:prstGeom prst="rect">
+              <a:avLst/>
+            </a:prstGeom>
+            <a:solidFill>
+              <a:schemeClr val="bg1"/>
+            </a:solidFill>
+            <a:ln>
+              <a:solidFill>
+                <a:schemeClr val="tx1"/>
+              </a:solidFill>
+            </a:ln>
+          </p:spPr>
+          <p:txBody>
+            <a:bodyPr wrap="none" rtlCol="0">
+              <a:spAutoFit/>
+            </a:bodyPr>
+            <a:lstStyle/>
+            <a:p>
+              <a:r>
+                <a:rPr lang="en-US" dirty="0"/>
+                <a:t>Not exported</a:t>
+              </a:r>
+            </a:p>
+          </p:txBody>
+        </p:sp>
+        <p:cxnSp>
+          <p:nvCxnSpPr>
+            <p:cNvPr id="16" name="Straight Arrow Connector 15">
+              <a:extLst>
+                <a:ext uri="{FF2B5EF4-FFF2-40B4-BE49-F238E27FC236}">
+                  <a16:creationId xmlns:a16="http://schemas.microsoft.com/office/drawing/2014/main" id="{E04E67AE-AE2D-4D77-A020-3E24CD5C134A}"/>
+                </a:ext>
+              </a:extLst>
+            </p:cNvPr>
+            <p:cNvCxnSpPr>
+              <a:cxnSpLocks/>
+              <a:stCxn id="13" idx="1"/>
+            </p:cNvCxnSpPr>
+            <p:nvPr/>
+          </p:nvCxnSpPr>
+          <p:spPr>
+            <a:xfrm flipH="1" flipV="1">
+              <a:off x="2523405" y="4782220"/>
+              <a:ext cx="718184" cy="322862"/>
+            </a:xfrm>
+            <a:prstGeom prst="straightConnector1">
+              <a:avLst/>
+            </a:prstGeom>
+            <a:ln w="19050">
+              <a:solidFill>
+                <a:schemeClr val="tx1"/>
+              </a:solidFill>
+              <a:tailEnd type="stealth" w="lg" len="lg"/>
+            </a:ln>
+          </p:spPr>
+          <p:style>
+            <a:lnRef idx="1">
+              <a:schemeClr val="accent1"/>
+            </a:lnRef>
+            <a:fillRef idx="0">
+              <a:schemeClr val="accent1"/>
+            </a:fillRef>
+            <a:effectRef idx="0">
+              <a:schemeClr val="accent1"/>
+            </a:effectRef>
+            <a:fontRef idx="minor">
+              <a:schemeClr val="tx1"/>
+            </a:fontRef>
+          </p:style>
+        </p:cxnSp>
+      </p:grpSp>
+      <p:sp>
+        <p:nvSpPr>
+          <p:cNvPr id="20" name="TextBox 19">
+            <a:extLst>
+              <a:ext uri="{FF2B5EF4-FFF2-40B4-BE49-F238E27FC236}">
+                <a16:creationId xmlns:a16="http://schemas.microsoft.com/office/drawing/2014/main" id="{B8303B27-E879-459C-B25F-9630FEFAEFFD}"/>
+              </a:ext>
+            </a:extLst>
+          </p:cNvPr>
+          <p:cNvSpPr txBox="1"/>
+          <p:nvPr/>
+        </p:nvSpPr>
+        <p:spPr>
+          <a:xfrm>
+            <a:off x="5142470" y="4469765"/>
+            <a:ext cx="4037744" cy="369332"/>
+          </a:xfrm>
+          <a:prstGeom prst="rect">
+            <a:avLst/>
+          </a:prstGeom>
+          <a:solidFill>
+            <a:schemeClr val="bg1">
+              <a:lumMod val="85000"/>
+            </a:schemeClr>
+          </a:solidFill>
+        </p:spPr>
+        <p:txBody>
+          <a:bodyPr wrap="square" rtlCol="0">
+            <a:spAutoFit/>
+          </a:bodyPr>
+          <a:lstStyle/>
+          <a:p>
+            <a:pPr algn="r"/>
+            <a:r>
+              <a:rPr lang="en-US" dirty="0">
+                <a:latin typeface="Consolas" panose="020B0609020204030204" pitchFamily="49" charset="0"/>
+              </a:rPr>
+              <a:t>using </a:t>
+            </a:r>
+            <a:r>
+              <a:rPr lang="en-US" dirty="0" err="1">
+                <a:latin typeface="Consolas" panose="020B0609020204030204" pitchFamily="49" charset="0"/>
+              </a:rPr>
+              <a:t>MyFunctions</a:t>
+            </a:r>
+            <a:r>
+              <a:rPr lang="en-US" dirty="0">
+                <a:latin typeface="Consolas" panose="020B0609020204030204" pitchFamily="49" charset="0"/>
+              </a:rPr>
+              <a:t>: fact</a:t>
+            </a:r>
+          </a:p>
+        </p:txBody>
+      </p:sp>
+      <p:grpSp>
+        <p:nvGrpSpPr>
+          <p:cNvPr id="21" name="Group 20">
+            <a:extLst>
+              <a:ext uri="{FF2B5EF4-FFF2-40B4-BE49-F238E27FC236}">
+                <a16:creationId xmlns:a16="http://schemas.microsoft.com/office/drawing/2014/main" id="{5759EAB1-45AF-4F72-84A7-4A086DB13074}"/>
+              </a:ext>
+            </a:extLst>
+          </p:cNvPr>
+          <p:cNvGrpSpPr/>
+          <p:nvPr/>
+        </p:nvGrpSpPr>
+        <p:grpSpPr>
+          <a:xfrm>
+            <a:off x="9693765" y="4151384"/>
+            <a:ext cx="2371565" cy="1467584"/>
+            <a:chOff x="7234137" y="3063682"/>
+            <a:chExt cx="2371565" cy="1467584"/>
+          </a:xfrm>
+        </p:grpSpPr>
+        <p:sp>
+          <p:nvSpPr>
+            <p:cNvPr id="22" name="TextBox 21">
+              <a:extLst>
+                <a:ext uri="{FF2B5EF4-FFF2-40B4-BE49-F238E27FC236}">
+                  <a16:creationId xmlns:a16="http://schemas.microsoft.com/office/drawing/2014/main" id="{743F5982-650A-4EE0-8242-CE5C2F982D97}"/>
+                </a:ext>
+              </a:extLst>
+            </p:cNvPr>
+            <p:cNvSpPr txBox="1"/>
+            <p:nvPr/>
+          </p:nvSpPr>
+          <p:spPr>
+            <a:xfrm>
+              <a:off x="7850221" y="3700269"/>
+              <a:ext cx="1755481" cy="830997"/>
+            </a:xfrm>
+            <a:prstGeom prst="rect">
+              <a:avLst/>
+            </a:prstGeom>
+            <a:noFill/>
+            <a:ln>
+              <a:solidFill>
+                <a:schemeClr val="tx1"/>
+              </a:solidFill>
+            </a:ln>
+          </p:spPr>
+          <p:txBody>
+            <a:bodyPr wrap="none" rtlCol="0">
+              <a:spAutoFit/>
+            </a:bodyPr>
+            <a:lstStyle/>
+            <a:p>
+              <a:r>
+                <a:rPr lang="en-US" sz="2400" dirty="0"/>
+                <a:t>Don’t </a:t>
+              </a:r>
+              <a:r>
+                <a:rPr lang="en-US" sz="2400" dirty="0" err="1"/>
+                <a:t>polute</a:t>
+              </a:r>
+              <a:endParaRPr lang="en-US" sz="2400" dirty="0"/>
+            </a:p>
+            <a:p>
+              <a:r>
+                <a:rPr lang="en-US" sz="2400" dirty="0"/>
+                <a:t>namespace</a:t>
+              </a:r>
+            </a:p>
+          </p:txBody>
+        </p:sp>
+        <p:pic>
+          <p:nvPicPr>
+            <p:cNvPr id="23" name="Graphic 22" descr="Thumbs up sign with solid fill">
+              <a:extLst>
+                <a:ext uri="{FF2B5EF4-FFF2-40B4-BE49-F238E27FC236}">
+                  <a16:creationId xmlns:a16="http://schemas.microsoft.com/office/drawing/2014/main" id="{83D99621-5A43-48FB-A878-3DA40509541B}"/>
+                </a:ext>
+              </a:extLst>
+            </p:cNvPr>
+            <p:cNvPicPr>
+              <a:picLocks noChangeAspect="1"/>
+            </p:cNvPicPr>
+            <p:nvPr/>
+          </p:nvPicPr>
+          <p:blipFill>
+            <a:blip r:embed="rId2">
+              <a:extLst>
+                <a:ext uri="{28A0092B-C50C-407E-A947-70E740481C1C}">
+                  <a14:useLocalDpi xmlns:a14="http://schemas.microsoft.com/office/drawing/2010/main" val="0"/>
+                </a:ext>
+                <a:ext uri="{96DAC541-7B7A-43D3-8B79-37D633B846F1}">
+                  <asvg:svgBlip xmlns:asvg="http://schemas.microsoft.com/office/drawing/2016/SVG/main" r:embed="rId3"/>
+                </a:ext>
+              </a:extLst>
+            </a:blip>
+            <a:stretch>
+              <a:fillRect/>
+            </a:stretch>
+          </p:blipFill>
+          <p:spPr>
+            <a:xfrm>
+              <a:off x="7234137" y="3063682"/>
+              <a:ext cx="914400" cy="914400"/>
+            </a:xfrm>
+            <a:prstGeom prst="rect">
+              <a:avLst/>
+            </a:prstGeom>
+          </p:spPr>
+        </p:pic>
+      </p:grpSp>
+      <p:sp>
+        <p:nvSpPr>
+          <p:cNvPr id="24" name="TextBox 23">
+            <a:extLst>
+              <a:ext uri="{FF2B5EF4-FFF2-40B4-BE49-F238E27FC236}">
+                <a16:creationId xmlns:a16="http://schemas.microsoft.com/office/drawing/2014/main" id="{9FAA3A86-D19E-477D-A4E8-3B4ABA8169EB}"/>
+              </a:ext>
+            </a:extLst>
+          </p:cNvPr>
+          <p:cNvSpPr txBox="1"/>
+          <p:nvPr/>
+        </p:nvSpPr>
+        <p:spPr>
+          <a:xfrm>
+            <a:off x="5142469" y="5502186"/>
+            <a:ext cx="3215751" cy="369332"/>
+          </a:xfrm>
+          <a:prstGeom prst="rect">
+            <a:avLst/>
+          </a:prstGeom>
+          <a:solidFill>
+            <a:schemeClr val="bg1">
+              <a:lumMod val="85000"/>
+            </a:schemeClr>
+          </a:solidFill>
+        </p:spPr>
+        <p:txBody>
+          <a:bodyPr wrap="square" rtlCol="0">
+            <a:spAutoFit/>
+          </a:bodyPr>
+          <a:lstStyle/>
+          <a:p>
+            <a:r>
+              <a:rPr lang="en-US" dirty="0">
+                <a:latin typeface="Consolas" panose="020B0609020204030204" pitchFamily="49" charset="0"/>
+              </a:rPr>
+              <a:t>import </a:t>
+            </a:r>
+            <a:r>
+              <a:rPr lang="en-US" dirty="0" err="1">
+                <a:latin typeface="Consolas" panose="020B0609020204030204" pitchFamily="49" charset="0"/>
+              </a:rPr>
+              <a:t>MyFunctions</a:t>
+            </a:r>
+            <a:r>
+              <a:rPr lang="en-US" dirty="0">
+                <a:latin typeface="Consolas" panose="020B0609020204030204" pitchFamily="49" charset="0"/>
+              </a:rPr>
+              <a:t>: fact</a:t>
+            </a:r>
+          </a:p>
+        </p:txBody>
+      </p:sp>
+      <p:grpSp>
+        <p:nvGrpSpPr>
+          <p:cNvPr id="25" name="Group 24">
+            <a:extLst>
+              <a:ext uri="{FF2B5EF4-FFF2-40B4-BE49-F238E27FC236}">
+                <a16:creationId xmlns:a16="http://schemas.microsoft.com/office/drawing/2014/main" id="{BD3CF768-65C4-4919-9674-725ADC5EA55D}"/>
+              </a:ext>
+            </a:extLst>
+          </p:cNvPr>
+          <p:cNvGrpSpPr/>
+          <p:nvPr/>
+        </p:nvGrpSpPr>
+        <p:grpSpPr>
+          <a:xfrm>
+            <a:off x="8128147" y="5862354"/>
+            <a:ext cx="3810441" cy="507528"/>
+            <a:chOff x="2523405" y="4782220"/>
+            <a:chExt cx="3810441" cy="507528"/>
+          </a:xfrm>
+        </p:grpSpPr>
+        <p:sp>
+          <p:nvSpPr>
+            <p:cNvPr id="26" name="TextBox 25">
+              <a:extLst>
+                <a:ext uri="{FF2B5EF4-FFF2-40B4-BE49-F238E27FC236}">
+                  <a16:creationId xmlns:a16="http://schemas.microsoft.com/office/drawing/2014/main" id="{100F39DA-A6F3-4400-9F27-CC33A6DA2483}"/>
+                </a:ext>
+              </a:extLst>
+            </p:cNvPr>
+            <p:cNvSpPr txBox="1"/>
+            <p:nvPr/>
+          </p:nvSpPr>
+          <p:spPr>
+            <a:xfrm>
+              <a:off x="3241589" y="4920416"/>
+              <a:ext cx="3092257" cy="369332"/>
+            </a:xfrm>
+            <a:prstGeom prst="rect">
+              <a:avLst/>
+            </a:prstGeom>
+            <a:solidFill>
+              <a:schemeClr val="bg1"/>
+            </a:solidFill>
+            <a:ln>
+              <a:solidFill>
+                <a:schemeClr val="tx1"/>
+              </a:solidFill>
+            </a:ln>
+          </p:spPr>
+          <p:txBody>
+            <a:bodyPr wrap="none" rtlCol="0">
+              <a:spAutoFit/>
+            </a:bodyPr>
+            <a:lstStyle/>
+            <a:p>
+              <a:r>
+                <a:rPr lang="en-US" dirty="0"/>
+                <a:t>Add methods to </a:t>
+              </a:r>
+              <a:r>
+                <a:rPr lang="en-US" dirty="0">
+                  <a:latin typeface="Consolas" panose="020B0609020204030204" pitchFamily="49" charset="0"/>
+                </a:rPr>
+                <a:t>fact</a:t>
+              </a:r>
+              <a:r>
+                <a:rPr lang="en-US" dirty="0"/>
+                <a:t> function</a:t>
+              </a:r>
+            </a:p>
+          </p:txBody>
+        </p:sp>
+        <p:cxnSp>
+          <p:nvCxnSpPr>
+            <p:cNvPr id="27" name="Straight Arrow Connector 26">
+              <a:extLst>
+                <a:ext uri="{FF2B5EF4-FFF2-40B4-BE49-F238E27FC236}">
+                  <a16:creationId xmlns:a16="http://schemas.microsoft.com/office/drawing/2014/main" id="{8FC42654-D385-40F2-8395-D0482F5B1277}"/>
+                </a:ext>
+              </a:extLst>
+            </p:cNvPr>
+            <p:cNvCxnSpPr>
+              <a:cxnSpLocks/>
+              <a:stCxn id="26" idx="1"/>
+            </p:cNvCxnSpPr>
+            <p:nvPr/>
+          </p:nvCxnSpPr>
+          <p:spPr>
+            <a:xfrm flipH="1" flipV="1">
+              <a:off x="2523405" y="4782220"/>
+              <a:ext cx="718184" cy="322862"/>
+            </a:xfrm>
+            <a:prstGeom prst="straightConnector1">
+              <a:avLst/>
+            </a:prstGeom>
+            <a:ln w="19050">
+              <a:solidFill>
+                <a:schemeClr val="tx1"/>
+              </a:solidFill>
+              <a:tailEnd type="stealth" w="lg" len="lg"/>
+            </a:ln>
+          </p:spPr>
+          <p:style>
+            <a:lnRef idx="1">
+              <a:schemeClr val="accent1"/>
+            </a:lnRef>
+            <a:fillRef idx="0">
+              <a:schemeClr val="accent1"/>
+            </a:fillRef>
+            <a:effectRef idx="0">
+              <a:schemeClr val="accent1"/>
+            </a:effectRef>
+            <a:fontRef idx="minor">
+              <a:schemeClr val="tx1"/>
+            </a:fontRef>
+          </p:style>
+        </p:cxnSp>
+      </p:grpSp>
+      <p:sp>
+        <p:nvSpPr>
+          <p:cNvPr id="9" name="TextBox 8">
+            <a:extLst>
+              <a:ext uri="{FF2B5EF4-FFF2-40B4-BE49-F238E27FC236}">
+                <a16:creationId xmlns:a16="http://schemas.microsoft.com/office/drawing/2014/main" id="{09E27FC1-661D-0885-7030-6E5D2655A54B}"/>
+              </a:ext>
+            </a:extLst>
+          </p:cNvPr>
+          <p:cNvSpPr txBox="1"/>
+          <p:nvPr/>
+        </p:nvSpPr>
+        <p:spPr>
+          <a:xfrm>
+            <a:off x="5112704" y="4943651"/>
+            <a:ext cx="4067510" cy="369332"/>
+          </a:xfrm>
+          <a:prstGeom prst="rect">
+            <a:avLst/>
+          </a:prstGeom>
+          <a:solidFill>
+            <a:schemeClr val="bg1">
+              <a:lumMod val="85000"/>
+            </a:schemeClr>
+          </a:solidFill>
+        </p:spPr>
+        <p:txBody>
+          <a:bodyPr wrap="square" rtlCol="0">
+            <a:spAutoFit/>
+          </a:bodyPr>
+          <a:lstStyle/>
+          <a:p>
+            <a:r>
+              <a:rPr lang="en-US" dirty="0">
+                <a:latin typeface="Consolas" panose="020B0609020204030204" pitchFamily="49" charset="0"/>
+              </a:rPr>
+              <a:t>using </a:t>
+            </a:r>
+            <a:r>
+              <a:rPr lang="en-US" dirty="0" err="1">
+                <a:latin typeface="Consolas" panose="020B0609020204030204" pitchFamily="49" charset="0"/>
+              </a:rPr>
+              <a:t>MyFunctions</a:t>
+            </a:r>
+            <a:r>
+              <a:rPr lang="en-US" dirty="0">
+                <a:latin typeface="Consolas" panose="020B0609020204030204" pitchFamily="49" charset="0"/>
+              </a:rPr>
+              <a:t>: fact as fac</a:t>
+            </a:r>
+          </a:p>
+        </p:txBody>
+      </p:sp>
+    </p:spTree>
+    <p:extLst>
+      <p:ext uri="{BB962C8B-B14F-4D97-AF65-F5344CB8AC3E}">
+        <p14:creationId xmlns:p14="http://schemas.microsoft.com/office/powerpoint/2010/main" val="823607669"/>
+      </p:ext>
+    </p:extLst>
+  </p:cSld>
+  <p:clrMapOvr>
+    <a:masterClrMapping/>
+  </p:clrMapOvr>
+  <p:timing>
+    <p:tnLst>
+      <p:par>
+        <p:cTn id="1" dur="indefinite" restart="never" nodeType="tmRoot">
+          <p:childTnLst>
+            <p:seq concurrent="1" nextAc="seek">
+              <p:cTn id="2" dur="indefinite" nodeType="mainSeq">
+                <p:childTnLst>
+                  <p:par>
+                    <p:cTn id="3" fill="hold">
+                      <p:stCondLst>
+                        <p:cond delay="indefinite"/>
+                      </p:stCondLst>
+                      <p:childTnLst>
+                        <p:par>
+                          <p:cTn id="4" fill="hold">
+                            <p:stCondLst>
+                              <p:cond delay="0"/>
+                            </p:stCondLst>
+                            <p:childTnLst>
+                              <p:par>
+                                <p:cTn id="5" presetID="1" presetClass="entr" presetSubtype="0" fill="hold" nodeType="clickEffect">
+                                  <p:stCondLst>
+                                    <p:cond delay="0"/>
+                                  </p:stCondLst>
+                                  <p:childTnLst>
+                                    <p:set>
+                                      <p:cBhvr>
+                                        <p:cTn id="6" dur="1" fill="hold">
+                                          <p:stCondLst>
+                                            <p:cond delay="0"/>
+                                          </p:stCondLst>
+                                        </p:cTn>
+                                        <p:tgtEl>
+                                          <p:spTgt spid="18"/>
+                                        </p:tgtEl>
+                                        <p:attrNameLst>
+                                          <p:attrName>style.visibility</p:attrName>
+                                        </p:attrNameLst>
+                                      </p:cBhvr>
+                                      <p:to>
+                                        <p:strVal val="visible"/>
+                                      </p:to>
+                                    </p:set>
+                                  </p:childTnLst>
+                                </p:cTn>
+                              </p:par>
+                            </p:childTnLst>
+                          </p:cTn>
+                        </p:par>
+                      </p:childTnLst>
+                    </p:cTn>
+                  </p:par>
+                  <p:par>
+                    <p:cTn id="7" fill="hold">
+                      <p:stCondLst>
+                        <p:cond delay="indefinite"/>
+                      </p:stCondLst>
+                      <p:childTnLst>
+                        <p:par>
+                          <p:cTn id="8" fill="hold">
+                            <p:stCondLst>
+                              <p:cond delay="0"/>
+                            </p:stCondLst>
+                            <p:childTnLst>
+                              <p:par>
+                                <p:cTn id="9" presetID="1" presetClass="entr" presetSubtype="0" fill="hold" nodeType="clickEffect">
+                                  <p:stCondLst>
+                                    <p:cond delay="0"/>
+                                  </p:stCondLst>
+                                  <p:childTnLst>
+                                    <p:set>
+                                      <p:cBhvr>
+                                        <p:cTn id="10" dur="1" fill="hold">
+                                          <p:stCondLst>
+                                            <p:cond delay="0"/>
+                                          </p:stCondLst>
+                                        </p:cTn>
+                                        <p:tgtEl>
+                                          <p:spTgt spid="19"/>
+                                        </p:tgtEl>
+                                        <p:attrNameLst>
+                                          <p:attrName>style.visibility</p:attrName>
+                                        </p:attrNameLst>
+                                      </p:cBhvr>
+                                      <p:to>
+                                        <p:strVal val="visible"/>
+                                      </p:to>
+                                    </p:set>
+                                  </p:childTnLst>
+                                </p:cTn>
+                              </p:par>
+                            </p:childTnLst>
+                          </p:cTn>
+                        </p:par>
+                      </p:childTnLst>
+                    </p:cTn>
+                  </p:par>
+                  <p:par>
+                    <p:cTn id="11" fill="hold">
+                      <p:stCondLst>
+                        <p:cond delay="indefinite"/>
+                      </p:stCondLst>
+                      <p:childTnLst>
+                        <p:par>
+                          <p:cTn id="12" fill="hold">
+                            <p:stCondLst>
+                              <p:cond delay="0"/>
+                            </p:stCondLst>
+                            <p:childTnLst>
+                              <p:par>
+                                <p:cTn id="13" presetID="1" presetClass="entr" presetSubtype="0" fill="hold" nodeType="clickEffect">
+                                  <p:stCondLst>
+                                    <p:cond delay="0"/>
+                                  </p:stCondLst>
+                                  <p:childTnLst>
+                                    <p:set>
+                                      <p:cBhvr>
+                                        <p:cTn id="14" dur="1" fill="hold">
+                                          <p:stCondLst>
+                                            <p:cond delay="0"/>
+                                          </p:stCondLst>
+                                        </p:cTn>
+                                        <p:tgtEl>
+                                          <p:spTgt spid="11"/>
+                                        </p:tgtEl>
+                                        <p:attrNameLst>
+                                          <p:attrName>style.visibility</p:attrName>
+                                        </p:attrNameLst>
+                                      </p:cBhvr>
+                                      <p:to>
+                                        <p:strVal val="visible"/>
+                                      </p:to>
+                                    </p:set>
+                                  </p:childTnLst>
+                                </p:cTn>
+                              </p:par>
+                            </p:childTnLst>
+                          </p:cTn>
+                        </p:par>
+                      </p:childTnLst>
+                    </p:cTn>
+                  </p:par>
+                  <p:par>
+                    <p:cTn id="15" fill="hold">
+                      <p:stCondLst>
+                        <p:cond delay="indefinite"/>
+                      </p:stCondLst>
+                      <p:childTnLst>
+                        <p:par>
+                          <p:cTn id="16" fill="hold">
+                            <p:stCondLst>
+                              <p:cond delay="0"/>
+                            </p:stCondLst>
+                            <p:childTnLst>
+                              <p:par>
+                                <p:cTn id="17" presetID="1" presetClass="entr" presetSubtype="0" fill="hold" grpId="0" nodeType="clickEffect">
+                                  <p:stCondLst>
+                                    <p:cond delay="0"/>
+                                  </p:stCondLst>
+                                  <p:childTnLst>
+                                    <p:set>
+                                      <p:cBhvr>
+                                        <p:cTn id="18" dur="1" fill="hold">
+                                          <p:stCondLst>
+                                            <p:cond delay="0"/>
+                                          </p:stCondLst>
+                                        </p:cTn>
+                                        <p:tgtEl>
+                                          <p:spTgt spid="20"/>
+                                        </p:tgtEl>
+                                        <p:attrNameLst>
+                                          <p:attrName>style.visibility</p:attrName>
+                                        </p:attrNameLst>
+                                      </p:cBhvr>
+                                      <p:to>
+                                        <p:strVal val="visible"/>
+                                      </p:to>
+                                    </p:set>
+                                  </p:childTnLst>
+                                </p:cTn>
+                              </p:par>
+                            </p:childTnLst>
+                          </p:cTn>
+                        </p:par>
+                      </p:childTnLst>
+                    </p:cTn>
+                  </p:par>
+                  <p:par>
+                    <p:cTn id="19" fill="hold">
+                      <p:stCondLst>
+                        <p:cond delay="indefinite"/>
+                      </p:stCondLst>
+                      <p:childTnLst>
+                        <p:par>
+                          <p:cTn id="20" fill="hold">
+                            <p:stCondLst>
+                              <p:cond delay="0"/>
+                            </p:stCondLst>
+                            <p:childTnLst>
+                              <p:par>
+                                <p:cTn id="21" presetID="1" presetClass="entr" presetSubtype="0" fill="hold" nodeType="clickEffect">
+                                  <p:stCondLst>
+                                    <p:cond delay="0"/>
+                                  </p:stCondLst>
+                                  <p:childTnLst>
+                                    <p:set>
+                                      <p:cBhvr>
+                                        <p:cTn id="22" dur="1" fill="hold">
+                                          <p:stCondLst>
+                                            <p:cond delay="0"/>
+                                          </p:stCondLst>
+                                        </p:cTn>
+                                        <p:tgtEl>
+                                          <p:spTgt spid="21"/>
+                                        </p:tgtEl>
+                                        <p:attrNameLst>
+                                          <p:attrName>style.visibility</p:attrName>
+                                        </p:attrNameLst>
+                                      </p:cBhvr>
+                                      <p:to>
+                                        <p:strVal val="visible"/>
+                                      </p:to>
+                                    </p:set>
+                                  </p:childTnLst>
+                                </p:cTn>
+                              </p:par>
+                            </p:childTnLst>
+                          </p:cTn>
+                        </p:par>
+                      </p:childTnLst>
+                    </p:cTn>
+                  </p:par>
+                  <p:par>
+                    <p:cTn id="23" fill="hold">
+                      <p:stCondLst>
+                        <p:cond delay="indefinite"/>
+                      </p:stCondLst>
+                      <p:childTnLst>
+                        <p:par>
+                          <p:cTn id="24" fill="hold">
+                            <p:stCondLst>
+                              <p:cond delay="0"/>
+                            </p:stCondLst>
+                            <p:childTnLst>
+                              <p:par>
+                                <p:cTn id="25" presetID="1" presetClass="entr" presetSubtype="0" fill="hold" grpId="0" nodeType="clickEffect">
+                                  <p:stCondLst>
+                                    <p:cond delay="0"/>
+                                  </p:stCondLst>
+                                  <p:childTnLst>
+                                    <p:set>
+                                      <p:cBhvr>
+                                        <p:cTn id="26" dur="1" fill="hold">
+                                          <p:stCondLst>
+                                            <p:cond delay="0"/>
+                                          </p:stCondLst>
+                                        </p:cTn>
+                                        <p:tgtEl>
+                                          <p:spTgt spid="24"/>
+                                        </p:tgtEl>
+                                        <p:attrNameLst>
+                                          <p:attrName>style.visibility</p:attrName>
+                                        </p:attrNameLst>
+                                      </p:cBhvr>
+                                      <p:to>
+                                        <p:strVal val="visible"/>
+                                      </p:to>
+                                    </p:set>
+                                  </p:childTnLst>
+                                </p:cTn>
+                              </p:par>
+                              <p:par>
+                                <p:cTn id="27" presetID="1" presetClass="entr" presetSubtype="0" fill="hold" nodeType="withEffect">
+                                  <p:stCondLst>
+                                    <p:cond delay="0"/>
+                                  </p:stCondLst>
+                                  <p:childTnLst>
+                                    <p:set>
+                                      <p:cBhvr>
+                                        <p:cTn id="28" dur="1" fill="hold">
+                                          <p:stCondLst>
+                                            <p:cond delay="0"/>
+                                          </p:stCondLst>
+                                        </p:cTn>
+                                        <p:tgtEl>
+                                          <p:spTgt spid="25"/>
+                                        </p:tgtEl>
+                                        <p:attrNameLst>
+                                          <p:attrName>style.visibility</p:attrName>
+                                        </p:attrNameLst>
+                                      </p:cBhvr>
+                                      <p:to>
+                                        <p:strVal val="visible"/>
+                                      </p:to>
+                                    </p:set>
+                                  </p:childTnLst>
+                                </p:cTn>
+                              </p:par>
+                            </p:childTnLst>
+                          </p:cTn>
+                        </p:par>
+                      </p:childTnLst>
+                    </p:cTn>
+                  </p:par>
+                  <p:par>
+                    <p:cTn id="29" fill="hold">
+                      <p:stCondLst>
+                        <p:cond delay="indefinite"/>
+                      </p:stCondLst>
+                      <p:childTnLst>
+                        <p:par>
+                          <p:cTn id="30" fill="hold">
+                            <p:stCondLst>
+                              <p:cond delay="0"/>
+                            </p:stCondLst>
+                            <p:childTnLst>
+                              <p:par>
+                                <p:cTn id="31" presetID="1" presetClass="entr" presetSubtype="0" fill="hold" grpId="0" nodeType="clickEffect">
+                                  <p:stCondLst>
+                                    <p:cond delay="0"/>
+                                  </p:stCondLst>
+                                  <p:childTnLst>
+                                    <p:set>
+                                      <p:cBhvr>
+                                        <p:cTn id="32" dur="1" fill="hold">
+                                          <p:stCondLst>
+                                            <p:cond delay="0"/>
+                                          </p:stCondLst>
+                                        </p:cTn>
+                                        <p:tgtEl>
+                                          <p:spTgt spid="9"/>
+                                        </p:tgtEl>
+                                        <p:attrNameLst>
+                                          <p:attrName>style.visibility</p:attrName>
+                                        </p:attrNameLst>
+                                      </p:cBhvr>
+                                      <p:to>
+                                        <p:strVal val="visible"/>
+                                      </p:to>
+                                    </p:set>
+                                  </p:childTnLst>
+                                </p:cTn>
+                              </p:par>
+                            </p:childTnLst>
+                          </p:cTn>
+                        </p:par>
+                      </p:childTnLst>
+                    </p:cTn>
+                  </p:par>
+                </p:childTnLst>
+              </p:cTn>
+              <p:prevCondLst>
+                <p:cond evt="onPrev" delay="0">
+                  <p:tgtEl>
+                    <p:sldTgt/>
+                  </p:tgtEl>
+                </p:cond>
+              </p:prevCondLst>
+              <p:nextCondLst>
+                <p:cond evt="onNext" delay="0">
+                  <p:tgtEl>
+                    <p:sldTgt/>
+                  </p:tgtEl>
+                </p:cond>
+              </p:nextCondLst>
+            </p:seq>
+          </p:childTnLst>
+        </p:cTn>
+      </p:par>
+    </p:tnLst>
+    <p:bldLst>
+      <p:bldP spid="20" grpId="0" animBg="1"/>
+      <p:bldP spid="24" grpId="0" animBg="1"/>
+      <p:bldP spid="9" grpId="0" animBg="1"/>
+    </p:bldLst>
+  </p:timing>
+</p:sld>
+</file>
+
+<file path=ppt/slides/slide42.xml><?xml version="1.0" encoding="utf-8"?>
+<p:sld xmlns:a="http://schemas.openxmlformats.org/drawingml/2006/main" xmlns:r="http://schemas.openxmlformats.org/officeDocument/2006/relationships" xmlns:p="http://schemas.openxmlformats.org/presentationml/2006/main">
+  <p:cSld>
+    <p:spTree>
+      <p:nvGrpSpPr>
+        <p:cNvPr id="1" name=""/>
+        <p:cNvGrpSpPr/>
+        <p:nvPr/>
+      </p:nvGrpSpPr>
+      <p:grpSpPr>
+        <a:xfrm>
+          <a:off x="0" y="0"/>
+          <a:ext cx="0" cy="0"/>
+          <a:chOff x="0" y="0"/>
+          <a:chExt cx="0" cy="0"/>
+        </a:xfrm>
+      </p:grpSpPr>
+      <p:sp>
+        <p:nvSpPr>
+          <p:cNvPr id="2" name="Title 1">
+            <a:extLst>
+              <a:ext uri="{FF2B5EF4-FFF2-40B4-BE49-F238E27FC236}">
                 <a16:creationId xmlns:a16="http://schemas.microsoft.com/office/drawing/2014/main" id="{55AC2C90-DDC5-486E-9507-4F3418F774CF}"/>
               </a:ext>
             </a:extLst>
@@ -29578,7 +30335,7 @@
           <a:p>
             <a:fld id="{78F7A1EC-23D1-431D-8C93-9C4ED5D4A04D}" type="slidenum">
               <a:rPr lang="en-US" smtClean="0"/>
-              <a:t>40</a:t>
+              <a:t>42</a:t>
             </a:fld>
             <a:endParaRPr lang="en-US"/>
           </a:p>
@@ -30157,7 +30914,7 @@
 </p:sld>
 </file>
 
-<file path=ppt/slides/slide41.xml><?xml version="1.0" encoding="utf-8"?>
+<file path=ppt/slides/slide43.xml><?xml version="1.0" encoding="utf-8"?>
 <p:sld xmlns:a="http://schemas.openxmlformats.org/drawingml/2006/main" xmlns:r="http://schemas.openxmlformats.org/officeDocument/2006/relationships" xmlns:p="http://schemas.openxmlformats.org/presentationml/2006/main">
   <p:cSld>
     <p:spTree>
@@ -30253,7 +31010,7 @@
           <a:p>
             <a:fld id="{78F7A1EC-23D1-431D-8C93-9C4ED5D4A04D}" type="slidenum">
               <a:rPr lang="en-US" smtClean="0"/>
-              <a:t>41</a:t>
+              <a:t>43</a:t>
             </a:fld>
             <a:endParaRPr lang="en-US"/>
           </a:p>
@@ -30666,7 +31423,7 @@
 </p:sld>
 </file>
 
-<file path=ppt/slides/slide42.xml><?xml version="1.0" encoding="utf-8"?>
+<file path=ppt/slides/slide44.xml><?xml version="1.0" encoding="utf-8"?>
 <p:sld xmlns:a="http://schemas.openxmlformats.org/drawingml/2006/main" xmlns:r="http://schemas.openxmlformats.org/officeDocument/2006/relationships" xmlns:p="http://schemas.openxmlformats.org/presentationml/2006/main">
   <p:cSld>
     <p:spTree>
@@ -30759,7 +31516,7 @@
           <a:p>
             <a:fld id="{78F7A1EC-23D1-431D-8C93-9C4ED5D4A04D}" type="slidenum">
               <a:rPr lang="en-US" smtClean="0"/>
-              <a:t>42</a:t>
+              <a:t>44</a:t>
             </a:fld>
             <a:endParaRPr lang="en-US"/>
           </a:p>
@@ -30778,7 +31535,7 @@
 </p:sld>
 </file>
 
-<file path=ppt/slides/slide43.xml><?xml version="1.0" encoding="utf-8"?>
+<file path=ppt/slides/slide45.xml><?xml version="1.0" encoding="utf-8"?>
 <p:sld xmlns:a="http://schemas.openxmlformats.org/drawingml/2006/main" xmlns:r="http://schemas.openxmlformats.org/officeDocument/2006/relationships" xmlns:p="http://schemas.openxmlformats.org/presentationml/2006/main">
   <p:cSld>
     <p:spTree>
@@ -30902,7 +31659,7 @@
           <a:p>
             <a:fld id="{78F7A1EC-23D1-431D-8C93-9C4ED5D4A04D}" type="slidenum">
               <a:rPr lang="en-US" smtClean="0"/>
-              <a:t>43</a:t>
+              <a:t>45</a:t>
             </a:fld>
             <a:endParaRPr lang="en-US"/>
           </a:p>
@@ -31153,7 +31910,7 @@
 </p:sld>
 </file>
 
-<file path=ppt/slides/slide44.xml><?xml version="1.0" encoding="utf-8"?>
+<file path=ppt/slides/slide46.xml><?xml version="1.0" encoding="utf-8"?>
 <p:sld xmlns:a="http://schemas.openxmlformats.org/drawingml/2006/main" xmlns:r="http://schemas.openxmlformats.org/officeDocument/2006/relationships" xmlns:p="http://schemas.openxmlformats.org/presentationml/2006/main">
   <p:cSld>
     <p:spTree>
@@ -31309,7 +32066,7 @@
           <a:p>
             <a:fld id="{78F7A1EC-23D1-431D-8C93-9C4ED5D4A04D}" type="slidenum">
               <a:rPr lang="en-US" smtClean="0"/>
-              <a:t>44</a:t>
+              <a:t>46</a:t>
             </a:fld>
             <a:endParaRPr lang="en-US"/>
           </a:p>
@@ -31609,7 +32366,7 @@
 </p:sld>
 </file>
 
-<file path=ppt/slides/slide45.xml><?xml version="1.0" encoding="utf-8"?>
+<file path=ppt/slides/slide47.xml><?xml version="1.0" encoding="utf-8"?>
 <p:sld xmlns:a="http://schemas.openxmlformats.org/drawingml/2006/main" xmlns:r="http://schemas.openxmlformats.org/officeDocument/2006/relationships" xmlns:p="http://schemas.openxmlformats.org/presentationml/2006/main">
   <p:cSld>
     <p:spTree>
@@ -31702,7 +32459,7 @@
           <a:p>
             <a:fld id="{78F7A1EC-23D1-431D-8C93-9C4ED5D4A04D}" type="slidenum">
               <a:rPr lang="en-US" smtClean="0"/>
-              <a:t>45</a:t>
+              <a:t>47</a:t>
             </a:fld>
             <a:endParaRPr lang="en-US"/>
           </a:p>
@@ -31721,7 +32478,7 @@
 </p:sld>
 </file>
 
-<file path=ppt/slides/slide46.xml><?xml version="1.0" encoding="utf-8"?>
+<file path=ppt/slides/slide48.xml><?xml version="1.0" encoding="utf-8"?>
 <p:sld xmlns:a="http://schemas.openxmlformats.org/drawingml/2006/main" xmlns:r="http://schemas.openxmlformats.org/officeDocument/2006/relationships" xmlns:p="http://schemas.openxmlformats.org/presentationml/2006/main">
   <p:cSld>
     <p:spTree>
@@ -31829,7 +32586,7 @@
           <a:p>
             <a:fld id="{78F7A1EC-23D1-431D-8C93-9C4ED5D4A04D}" type="slidenum">
               <a:rPr lang="en-US" smtClean="0"/>
-              <a:t>46</a:t>
+              <a:t>48</a:t>
             </a:fld>
             <a:endParaRPr lang="en-US"/>
           </a:p>
@@ -32114,7 +32871,7 @@
 </p:sld>
 </file>
 
-<file path=ppt/slides/slide47.xml><?xml version="1.0" encoding="utf-8"?>
+<file path=ppt/slides/slide49.xml><?xml version="1.0" encoding="utf-8"?>
 <p:sld xmlns:a="http://schemas.openxmlformats.org/drawingml/2006/main" xmlns:r="http://schemas.openxmlformats.org/officeDocument/2006/relationships" xmlns:p="http://schemas.openxmlformats.org/presentationml/2006/main">
   <p:cSld>
     <p:spTree>
@@ -32249,7 +33006,7 @@
           <a:p>
             <a:fld id="{78F7A1EC-23D1-431D-8C93-9C4ED5D4A04D}" type="slidenum">
               <a:rPr lang="en-US" smtClean="0"/>
-              <a:t>47</a:t>
+              <a:t>49</a:t>
             </a:fld>
             <a:endParaRPr lang="en-US"/>
           </a:p>
@@ -32259,144 +33016,6 @@
     <p:extLst>
       <p:ext uri="{BB962C8B-B14F-4D97-AF65-F5344CB8AC3E}">
         <p14:creationId xmlns:p14="http://schemas.microsoft.com/office/powerpoint/2010/main" val="3896452192"/>
-      </p:ext>
-    </p:extLst>
-  </p:cSld>
-  <p:clrMapOvr>
-    <a:masterClrMapping/>
-  </p:clrMapOvr>
-</p:sld>
-</file>
-
-<file path=ppt/slides/slide48.xml><?xml version="1.0" encoding="utf-8"?>
-<p:sld xmlns:a="http://schemas.openxmlformats.org/drawingml/2006/main" xmlns:r="http://schemas.openxmlformats.org/officeDocument/2006/relationships" xmlns:p="http://schemas.openxmlformats.org/presentationml/2006/main">
-  <p:cSld>
-    <p:spTree>
-      <p:nvGrpSpPr>
-        <p:cNvPr id="1" name=""/>
-        <p:cNvGrpSpPr/>
-        <p:nvPr/>
-      </p:nvGrpSpPr>
-      <p:grpSpPr>
-        <a:xfrm>
-          <a:off x="0" y="0"/>
-          <a:ext cx="0" cy="0"/>
-          <a:chOff x="0" y="0"/>
-          <a:chExt cx="0" cy="0"/>
-        </a:xfrm>
-      </p:grpSpPr>
-      <p:sp>
-        <p:nvSpPr>
-          <p:cNvPr id="2" name="Title 1">
-            <a:extLst>
-              <a:ext uri="{FF2B5EF4-FFF2-40B4-BE49-F238E27FC236}">
-                <a16:creationId xmlns:a16="http://schemas.microsoft.com/office/drawing/2014/main" id="{2C5A0FB5-DDBF-AC0A-228B-48A40DDC7058}"/>
-              </a:ext>
-            </a:extLst>
-          </p:cNvPr>
-          <p:cNvSpPr>
-            <a:spLocks noGrp="1"/>
-          </p:cNvSpPr>
-          <p:nvPr>
-            <p:ph type="title"/>
-          </p:nvPr>
-        </p:nvSpPr>
-        <p:spPr/>
-        <p:txBody>
-          <a:bodyPr/>
-          <a:lstStyle/>
-          <a:p>
-            <a:r>
-              <a:rPr lang="en-US" dirty="0"/>
-              <a:t>Software</a:t>
-            </a:r>
-            <a:endParaRPr lang="LID4096" dirty="0"/>
-          </a:p>
-        </p:txBody>
-      </p:sp>
-      <p:sp>
-        <p:nvSpPr>
-          <p:cNvPr id="3" name="Content Placeholder 2">
-            <a:extLst>
-              <a:ext uri="{FF2B5EF4-FFF2-40B4-BE49-F238E27FC236}">
-                <a16:creationId xmlns:a16="http://schemas.microsoft.com/office/drawing/2014/main" id="{28C604BA-9585-A7ED-0B84-D3477F529262}"/>
-              </a:ext>
-            </a:extLst>
-          </p:cNvPr>
-          <p:cNvSpPr>
-            <a:spLocks noGrp="1"/>
-          </p:cNvSpPr>
-          <p:nvPr>
-            <p:ph idx="1"/>
-          </p:nvPr>
-        </p:nvSpPr>
-        <p:spPr/>
-        <p:txBody>
-          <a:bodyPr/>
-          <a:lstStyle/>
-          <a:p>
-            <a:r>
-              <a:rPr lang="en-US" dirty="0"/>
-              <a:t>Google </a:t>
-            </a:r>
-            <a:r>
-              <a:rPr lang="en-US" dirty="0" err="1"/>
-              <a:t>Colab</a:t>
-            </a:r>
-            <a:r>
-              <a:rPr lang="en-US" dirty="0"/>
-              <a:t> template</a:t>
-            </a:r>
-            <a:br>
-              <a:rPr lang="en-US" dirty="0"/>
-            </a:br>
-            <a:r>
-              <a:rPr lang="en-US" sz="1600" dirty="0">
-                <a:hlinkClick r:id="rId2"/>
-              </a:rPr>
-              <a:t>https://colab.research.google.com/github/ageron/julia_notebooks/blob/master/Julia_Colab_Notebook_Template.ipynb</a:t>
-            </a:r>
-            <a:r>
-              <a:rPr lang="en-US" sz="1600" dirty="0"/>
-              <a:t> </a:t>
-            </a:r>
-            <a:endParaRPr lang="LID4096" dirty="0"/>
-          </a:p>
-        </p:txBody>
-      </p:sp>
-      <p:sp>
-        <p:nvSpPr>
-          <p:cNvPr id="4" name="Slide Number Placeholder 3">
-            <a:extLst>
-              <a:ext uri="{FF2B5EF4-FFF2-40B4-BE49-F238E27FC236}">
-                <a16:creationId xmlns:a16="http://schemas.microsoft.com/office/drawing/2014/main" id="{EFC9C216-3FDD-3468-8E30-D89BBEAB0C69}"/>
-              </a:ext>
-            </a:extLst>
-          </p:cNvPr>
-          <p:cNvSpPr>
-            <a:spLocks noGrp="1"/>
-          </p:cNvSpPr>
-          <p:nvPr>
-            <p:ph type="sldNum" sz="quarter" idx="12"/>
-          </p:nvPr>
-        </p:nvSpPr>
-        <p:spPr/>
-        <p:txBody>
-          <a:bodyPr/>
-          <a:lstStyle/>
-          <a:p>
-            <a:fld id="{78F7A1EC-23D1-431D-8C93-9C4ED5D4A04D}" type="slidenum">
-              <a:rPr lang="en-US" smtClean="0"/>
-              <a:t>48</a:t>
-            </a:fld>
-            <a:endParaRPr lang="en-US"/>
-          </a:p>
-        </p:txBody>
-      </p:sp>
-    </p:spTree>
-    <p:extLst>
-      <p:ext uri="{BB962C8B-B14F-4D97-AF65-F5344CB8AC3E}">
-        <p14:creationId xmlns:p14="http://schemas.microsoft.com/office/powerpoint/2010/main" val="1076162063"/>
       </p:ext>
     </p:extLst>
   </p:cSld>
@@ -33039,6 +33658,144 @@
       <p:bldP spid="3" grpId="0" uiExpand="1" build="p"/>
     </p:bldLst>
   </p:timing>
+</p:sld>
+</file>
+
+<file path=ppt/slides/slide50.xml><?xml version="1.0" encoding="utf-8"?>
+<p:sld xmlns:a="http://schemas.openxmlformats.org/drawingml/2006/main" xmlns:r="http://schemas.openxmlformats.org/officeDocument/2006/relationships" xmlns:p="http://schemas.openxmlformats.org/presentationml/2006/main">
+  <p:cSld>
+    <p:spTree>
+      <p:nvGrpSpPr>
+        <p:cNvPr id="1" name=""/>
+        <p:cNvGrpSpPr/>
+        <p:nvPr/>
+      </p:nvGrpSpPr>
+      <p:grpSpPr>
+        <a:xfrm>
+          <a:off x="0" y="0"/>
+          <a:ext cx="0" cy="0"/>
+          <a:chOff x="0" y="0"/>
+          <a:chExt cx="0" cy="0"/>
+        </a:xfrm>
+      </p:grpSpPr>
+      <p:sp>
+        <p:nvSpPr>
+          <p:cNvPr id="2" name="Title 1">
+            <a:extLst>
+              <a:ext uri="{FF2B5EF4-FFF2-40B4-BE49-F238E27FC236}">
+                <a16:creationId xmlns:a16="http://schemas.microsoft.com/office/drawing/2014/main" id="{2C5A0FB5-DDBF-AC0A-228B-48A40DDC7058}"/>
+              </a:ext>
+            </a:extLst>
+          </p:cNvPr>
+          <p:cNvSpPr>
+            <a:spLocks noGrp="1"/>
+          </p:cNvSpPr>
+          <p:nvPr>
+            <p:ph type="title"/>
+          </p:nvPr>
+        </p:nvSpPr>
+        <p:spPr/>
+        <p:txBody>
+          <a:bodyPr/>
+          <a:lstStyle/>
+          <a:p>
+            <a:r>
+              <a:rPr lang="en-US" dirty="0"/>
+              <a:t>Software</a:t>
+            </a:r>
+            <a:endParaRPr lang="LID4096" dirty="0"/>
+          </a:p>
+        </p:txBody>
+      </p:sp>
+      <p:sp>
+        <p:nvSpPr>
+          <p:cNvPr id="3" name="Content Placeholder 2">
+            <a:extLst>
+              <a:ext uri="{FF2B5EF4-FFF2-40B4-BE49-F238E27FC236}">
+                <a16:creationId xmlns:a16="http://schemas.microsoft.com/office/drawing/2014/main" id="{28C604BA-9585-A7ED-0B84-D3477F529262}"/>
+              </a:ext>
+            </a:extLst>
+          </p:cNvPr>
+          <p:cNvSpPr>
+            <a:spLocks noGrp="1"/>
+          </p:cNvSpPr>
+          <p:nvPr>
+            <p:ph idx="1"/>
+          </p:nvPr>
+        </p:nvSpPr>
+        <p:spPr/>
+        <p:txBody>
+          <a:bodyPr/>
+          <a:lstStyle/>
+          <a:p>
+            <a:r>
+              <a:rPr lang="en-US" dirty="0"/>
+              <a:t>Google </a:t>
+            </a:r>
+            <a:r>
+              <a:rPr lang="en-US" dirty="0" err="1"/>
+              <a:t>Colab</a:t>
+            </a:r>
+            <a:r>
+              <a:rPr lang="en-US" dirty="0"/>
+              <a:t> template</a:t>
+            </a:r>
+            <a:br>
+              <a:rPr lang="en-US" dirty="0"/>
+            </a:br>
+            <a:r>
+              <a:rPr lang="en-US" sz="1600" dirty="0">
+                <a:hlinkClick r:id="rId2"/>
+              </a:rPr>
+              <a:t>https://colab.research.google.com/github/ageron/julia_notebooks/blob/master/Julia_Colab_Notebook_Template.ipynb</a:t>
+            </a:r>
+            <a:r>
+              <a:rPr lang="en-US" sz="1600" dirty="0"/>
+              <a:t> </a:t>
+            </a:r>
+            <a:endParaRPr lang="LID4096" dirty="0"/>
+          </a:p>
+        </p:txBody>
+      </p:sp>
+      <p:sp>
+        <p:nvSpPr>
+          <p:cNvPr id="4" name="Slide Number Placeholder 3">
+            <a:extLst>
+              <a:ext uri="{FF2B5EF4-FFF2-40B4-BE49-F238E27FC236}">
+                <a16:creationId xmlns:a16="http://schemas.microsoft.com/office/drawing/2014/main" id="{EFC9C216-3FDD-3468-8E30-D89BBEAB0C69}"/>
+              </a:ext>
+            </a:extLst>
+          </p:cNvPr>
+          <p:cNvSpPr>
+            <a:spLocks noGrp="1"/>
+          </p:cNvSpPr>
+          <p:nvPr>
+            <p:ph type="sldNum" sz="quarter" idx="12"/>
+          </p:nvPr>
+        </p:nvSpPr>
+        <p:spPr/>
+        <p:txBody>
+          <a:bodyPr/>
+          <a:lstStyle/>
+          <a:p>
+            <a:fld id="{78F7A1EC-23D1-431D-8C93-9C4ED5D4A04D}" type="slidenum">
+              <a:rPr lang="en-US" smtClean="0"/>
+              <a:t>50</a:t>
+            </a:fld>
+            <a:endParaRPr lang="en-US"/>
+          </a:p>
+        </p:txBody>
+      </p:sp>
+    </p:spTree>
+    <p:extLst>
+      <p:ext uri="{BB962C8B-B14F-4D97-AF65-F5344CB8AC3E}">
+        <p14:creationId xmlns:p14="http://schemas.microsoft.com/office/powerpoint/2010/main" val="1076162063"/>
+      </p:ext>
+    </p:extLst>
+  </p:cSld>
+  <p:clrMapOvr>
+    <a:masterClrMapping/>
+  </p:clrMapOvr>
 </p:sld>
 </file>
 

</xml_diff>